<commit_message>
Build connector-ready executive briefing pipeline
</commit_message>
<xml_diff>
--- a/outputs/executive-briefing-machine-demo/executive-briefing-demo.pptx
+++ b/outputs/executive-briefing-machine-demo/executive-briefing-demo.pptx
@@ -2,17 +2,17 @@
 <file path=ppt/presentation.xml><?xml version="1.0" encoding="utf-8"?>
 <p:presentation xmlns:p="http://schemas.openxmlformats.org/presentationml/2006/main">
   <p:sldMasterIdLst>
-    <p:sldMasterId xmlns:r="http://schemas.openxmlformats.org/officeDocument/2006/relationships" id="2147483648" r:id="Rcca1e50f3b9c450a"/>
+    <p:sldMasterId xmlns:r="http://schemas.openxmlformats.org/officeDocument/2006/relationships" id="2147483648" r:id="R22aad39d52c4476a"/>
   </p:sldMasterIdLst>
   <p:notesMasterIdLst>
-    <p:notesMasterId xmlns:r="http://schemas.openxmlformats.org/officeDocument/2006/relationships" r:id="Rda70233070ed4911"/>
+    <p:notesMasterId xmlns:r="http://schemas.openxmlformats.org/officeDocument/2006/relationships" r:id="R09127fae92ed4be3"/>
   </p:notesMasterIdLst>
   <p:sldIdLst>
-    <p:sldId xmlns:r="http://schemas.openxmlformats.org/officeDocument/2006/relationships" id="256" r:id="R3fd0bb8570514357"/>
-    <p:sldId xmlns:r="http://schemas.openxmlformats.org/officeDocument/2006/relationships" id="257" r:id="Reb1b5a4b0c184247"/>
-    <p:sldId xmlns:r="http://schemas.openxmlformats.org/officeDocument/2006/relationships" id="258" r:id="R5b750097f718491a"/>
-    <p:sldId xmlns:r="http://schemas.openxmlformats.org/officeDocument/2006/relationships" id="259" r:id="R327b621d7de147dd"/>
-    <p:sldId xmlns:r="http://schemas.openxmlformats.org/officeDocument/2006/relationships" id="260" r:id="Rbbbbff259778462b"/>
+    <p:sldId xmlns:r="http://schemas.openxmlformats.org/officeDocument/2006/relationships" id="256" r:id="R7dc1f00ffc304d9d"/>
+    <p:sldId xmlns:r="http://schemas.openxmlformats.org/officeDocument/2006/relationships" id="257" r:id="R1319853b892642ca"/>
+    <p:sldId xmlns:r="http://schemas.openxmlformats.org/officeDocument/2006/relationships" id="258" r:id="Reac96d31f6414c76"/>
+    <p:sldId xmlns:r="http://schemas.openxmlformats.org/officeDocument/2006/relationships" id="259" r:id="R3139205e3d3b4013"/>
+    <p:sldId xmlns:r="http://schemas.openxmlformats.org/officeDocument/2006/relationships" id="260" r:id="Re885fb9238784981"/>
   </p:sldIdLst>
   <p:sldSz cx="12192000" cy="6858000"/>
   <p:notesSz cx="6858000" cy="9144000"/>
@@ -721,7 +721,7 @@
           <p:cNvPr id="1" name="Title 1">
             <a:extLst xmlns:a="http://schemas.openxmlformats.org/drawingml/2006/main">
               <a:ext uri="{FF2B5EF4-FFF2-40B4-BE49-F238E27FC236}">
-                <a16:creationId xmlns:a16="http://schemas.microsoft.com/office/drawing/2014/main" id="{60E4A545-9052-477D-B94C-83F3B294F169}"/>
+                <a16:creationId xmlns:a16="http://schemas.microsoft.com/office/drawing/2014/main" id="{5D6607B5-A12B-40F7-AFBA-3051487DFF19}"/>
               </a:ext>
             </a:extLst>
           </p:cNvPr>
@@ -752,7 +752,7 @@
           <p:cNvPr id="2" name="Subtitle 2">
             <a:extLst xmlns:a="http://schemas.openxmlformats.org/drawingml/2006/main">
               <a:ext uri="{FF2B5EF4-FFF2-40B4-BE49-F238E27FC236}">
-                <a16:creationId xmlns:a16="http://schemas.microsoft.com/office/drawing/2014/main" id="{8F115DB5-0B9D-43AC-AA07-E0F211BCB9B3}"/>
+                <a16:creationId xmlns:a16="http://schemas.microsoft.com/office/drawing/2014/main" id="{0B0C3C5C-D3FC-4B17-ADF3-1452B1071AFC}"/>
               </a:ext>
             </a:extLst>
           </p:cNvPr>
@@ -815,7 +815,7 @@
           <p:cNvPr id="3" name="Date Placeholder 3">
             <a:extLst xmlns:a="http://schemas.openxmlformats.org/drawingml/2006/main">
               <a:ext uri="{FF2B5EF4-FFF2-40B4-BE49-F238E27FC236}">
-                <a16:creationId xmlns:a16="http://schemas.microsoft.com/office/drawing/2014/main" id="{E93CDE38-8651-48E3-8350-5156A88AA953}"/>
+                <a16:creationId xmlns:a16="http://schemas.microsoft.com/office/drawing/2014/main" id="{5EFF3265-1718-4D45-B612-0191F6B55479}"/>
               </a:ext>
             </a:extLst>
           </p:cNvPr>
@@ -836,7 +836,7 @@
           <p:cNvPr id="4" name="Footer Placeholder 4">
             <a:extLst xmlns:a="http://schemas.openxmlformats.org/drawingml/2006/main">
               <a:ext uri="{FF2B5EF4-FFF2-40B4-BE49-F238E27FC236}">
-                <a16:creationId xmlns:a16="http://schemas.microsoft.com/office/drawing/2014/main" id="{0D728AFD-3D1C-45F2-9839-84A899DC48F4}"/>
+                <a16:creationId xmlns:a16="http://schemas.microsoft.com/office/drawing/2014/main" id="{2E01B156-63A3-491B-9FF6-B50EEBEBD63A}"/>
               </a:ext>
             </a:extLst>
           </p:cNvPr>
@@ -857,7 +857,7 @@
           <p:cNvPr id="5" name="Slide Number Placeholder 5">
             <a:extLst xmlns:a="http://schemas.openxmlformats.org/drawingml/2006/main">
               <a:ext uri="{FF2B5EF4-FFF2-40B4-BE49-F238E27FC236}">
-                <a16:creationId xmlns:a16="http://schemas.microsoft.com/office/drawing/2014/main" id="{EBA25663-28C7-4899-833E-A1FF244700B5}"/>
+                <a16:creationId xmlns:a16="http://schemas.microsoft.com/office/drawing/2014/main" id="{A4FB032A-3EC5-473E-95EF-14E6ABFA23A7}"/>
               </a:ext>
             </a:extLst>
           </p:cNvPr>
@@ -900,7 +900,7 @@
           <p:cNvPr id="1" name="Slide Number Placeholder 5">
             <a:extLst xmlns:a="http://schemas.openxmlformats.org/drawingml/2006/main">
               <a:ext uri="{FF2B5EF4-FFF2-40B4-BE49-F238E27FC236}">
-                <a16:creationId xmlns:a16="http://schemas.microsoft.com/office/drawing/2014/main" id="{4B32D2B9-C7D2-4DF5-B315-985EC445FA21}"/>
+                <a16:creationId xmlns:a16="http://schemas.microsoft.com/office/drawing/2014/main" id="{C39FFE53-6569-4E06-B264-8E9E38B50BF9}"/>
               </a:ext>
             </a:extLst>
           </p:cNvPr>
@@ -939,7 +939,7 @@
   </p:cSld>
   <p:clrMap bg1="lt1" tx1="dk1" bg2="lt2" tx2="dk2" accent1="accent1" accent2="accent2" accent3="accent3" accent4="accent4" accent5="accent5" accent6="accent6" hlink="hlink" folHlink="folHlink"/>
   <p:sldLayoutIdLst>
-    <p:sldLayoutId xmlns:r="http://schemas.openxmlformats.org/officeDocument/2006/relationships" id="2147483649" r:id="R3251e724ac8742c1"/>
+    <p:sldLayoutId xmlns:r="http://schemas.openxmlformats.org/officeDocument/2006/relationships" id="2147483649" r:id="R4a5f7961dc0a4e0e"/>
   </p:sldLayoutIdLst>
   <p:txStyles>
     <p:titleStyle>
@@ -1540,7 +1540,7 @@
           <p:cNvPr id="1" name="Slide Number Placeholder 5">
             <a:extLst xmlns:a="http://schemas.openxmlformats.org/drawingml/2006/main">
               <a:ext uri="{FF2B5EF4-FFF2-40B4-BE49-F238E27FC236}">
-                <a16:creationId xmlns:a16="http://schemas.microsoft.com/office/drawing/2014/main" id="{EBA25663-28C7-4899-833E-A1FF244700B5}"/>
+                <a16:creationId xmlns:a16="http://schemas.microsoft.com/office/drawing/2014/main" id="{A4FB032A-3EC5-473E-95EF-14E6ABFA23A7}"/>
               </a:ext>
             </a:extLst>
           </p:cNvPr>
@@ -1572,7 +1572,7 @@
           <p:cNvPr id="2" name="">
             <a:extLst xmlns:a="http://schemas.openxmlformats.org/drawingml/2006/main">
               <a:ext uri="{FF2B5EF4-FFF2-40B4-BE49-F238E27FC236}">
-                <a16:creationId xmlns:a16="http://schemas.microsoft.com/office/drawing/2014/main" id="{94D772FE-EA7C-43BD-8FDC-9061F515F6BC}"/>
+                <a16:creationId xmlns:a16="http://schemas.microsoft.com/office/drawing/2014/main" id="{52849F57-0305-414B-9C17-503BCF30A4FA}"/>
               </a:ext>
             </a:extLst>
           </p:cNvPr>
@@ -1605,7 +1605,7 @@
           <p:cNvPr id="3" name="">
             <a:extLst xmlns:a="http://schemas.openxmlformats.org/drawingml/2006/main">
               <a:ext uri="{FF2B5EF4-FFF2-40B4-BE49-F238E27FC236}">
-                <a16:creationId xmlns:a16="http://schemas.microsoft.com/office/drawing/2014/main" id="{89CC7D4E-FBF1-4D7E-96D7-4F65074A89FB}"/>
+                <a16:creationId xmlns:a16="http://schemas.microsoft.com/office/drawing/2014/main" id="{FE04CF9C-6B15-46E0-B3E1-B7D171D75728}"/>
               </a:ext>
             </a:extLst>
           </p:cNvPr>
@@ -1638,7 +1638,7 @@
           <p:cNvPr id="4" name="">
             <a:extLst xmlns:a="http://schemas.openxmlformats.org/drawingml/2006/main">
               <a:ext uri="{FF2B5EF4-FFF2-40B4-BE49-F238E27FC236}">
-                <a16:creationId xmlns:a16="http://schemas.microsoft.com/office/drawing/2014/main" id="{A67A50DD-AD20-4733-99BB-0B09FA2E1A34}"/>
+                <a16:creationId xmlns:a16="http://schemas.microsoft.com/office/drawing/2014/main" id="{32453FD8-A33A-4A14-B266-6EC81683A7DB}"/>
               </a:ext>
             </a:extLst>
           </p:cNvPr>
@@ -1689,7 +1689,7 @@
           <p:cNvPr id="5" name="">
             <a:extLst xmlns:a="http://schemas.openxmlformats.org/drawingml/2006/main">
               <a:ext uri="{FF2B5EF4-FFF2-40B4-BE49-F238E27FC236}">
-                <a16:creationId xmlns:a16="http://schemas.microsoft.com/office/drawing/2014/main" id="{C972665C-4F7C-4DB5-A877-898DE6DE3508}"/>
+                <a16:creationId xmlns:a16="http://schemas.microsoft.com/office/drawing/2014/main" id="{113BE01D-BD90-48BC-A364-2E08048D8959}"/>
               </a:ext>
             </a:extLst>
           </p:cNvPr>
@@ -1740,7 +1740,7 @@
           <p:cNvPr id="6" name="">
             <a:extLst xmlns:a="http://schemas.openxmlformats.org/drawingml/2006/main">
               <a:ext uri="{FF2B5EF4-FFF2-40B4-BE49-F238E27FC236}">
-                <a16:creationId xmlns:a16="http://schemas.microsoft.com/office/drawing/2014/main" id="{9384C589-976D-4C02-9F65-E088C6C3D38D}"/>
+                <a16:creationId xmlns:a16="http://schemas.microsoft.com/office/drawing/2014/main" id="{1754F990-5343-4453-907F-1C9DE6F8AC55}"/>
               </a:ext>
             </a:extLst>
           </p:cNvPr>
@@ -1775,7 +1775,7 @@
           <p:cNvPr id="7" name="">
             <a:extLst xmlns:a="http://schemas.openxmlformats.org/drawingml/2006/main">
               <a:ext uri="{FF2B5EF4-FFF2-40B4-BE49-F238E27FC236}">
-                <a16:creationId xmlns:a16="http://schemas.microsoft.com/office/drawing/2014/main" id="{0F8E1AC2-6A96-4400-98EC-398BFD417FA1}"/>
+                <a16:creationId xmlns:a16="http://schemas.microsoft.com/office/drawing/2014/main" id="{3EFD4FE3-EE78-49C0-B66C-33D7302B5C84}"/>
               </a:ext>
             </a:extLst>
           </p:cNvPr>
@@ -1810,7 +1810,7 @@
           <p:cNvPr id="8" name="">
             <a:extLst xmlns:a="http://schemas.openxmlformats.org/drawingml/2006/main">
               <a:ext uri="{FF2B5EF4-FFF2-40B4-BE49-F238E27FC236}">
-                <a16:creationId xmlns:a16="http://schemas.microsoft.com/office/drawing/2014/main" id="{13B5D5F2-C884-47E6-A1E6-AA5E6357780E}"/>
+                <a16:creationId xmlns:a16="http://schemas.microsoft.com/office/drawing/2014/main" id="{47719D48-6D03-49BD-A1FE-5884DA4D53E1}"/>
               </a:ext>
             </a:extLst>
           </p:cNvPr>
@@ -1861,7 +1861,7 @@
           <p:cNvPr id="9" name="">
             <a:extLst xmlns:a="http://schemas.openxmlformats.org/drawingml/2006/main">
               <a:ext uri="{FF2B5EF4-FFF2-40B4-BE49-F238E27FC236}">
-                <a16:creationId xmlns:a16="http://schemas.microsoft.com/office/drawing/2014/main" id="{AB989052-D092-415C-A73B-E3FF9978306D}"/>
+                <a16:creationId xmlns:a16="http://schemas.microsoft.com/office/drawing/2014/main" id="{E72C1D47-353D-4062-8FB7-2B99F8A4E0DD}"/>
               </a:ext>
             </a:extLst>
           </p:cNvPr>
@@ -1917,7 +1917,7 @@
                   <a:srgbClr val="334155"/>
                 </a:solidFill>
               </a:rPr>
-              <a:t>Generated from sample Slack, GitHub, KPI, and leadership-note inputs.</a:t>
+              <a:t>Generated from sample collaboration-style inputs with connector-ready adapters.</a:t>
             </a:r>
           </a:p>
         </p:txBody>
@@ -1927,7 +1927,7 @@
           <p:cNvPr id="10" name="">
             <a:extLst xmlns:a="http://schemas.openxmlformats.org/drawingml/2006/main">
               <a:ext uri="{FF2B5EF4-FFF2-40B4-BE49-F238E27FC236}">
-                <a16:creationId xmlns:a16="http://schemas.microsoft.com/office/drawing/2014/main" id="{F4EB8C03-6F5E-425B-8B0A-76016F712498}"/>
+                <a16:creationId xmlns:a16="http://schemas.microsoft.com/office/drawing/2014/main" id="{BF1C89E7-A2C4-41D2-837D-50719BDE8B1D}"/>
               </a:ext>
             </a:extLst>
           </p:cNvPr>
@@ -1962,7 +1962,7 @@
           <p:cNvPr id="11" name="">
             <a:extLst xmlns:a="http://schemas.openxmlformats.org/drawingml/2006/main">
               <a:ext uri="{FF2B5EF4-FFF2-40B4-BE49-F238E27FC236}">
-                <a16:creationId xmlns:a16="http://schemas.microsoft.com/office/drawing/2014/main" id="{2952815B-DE39-4084-A27A-E63287A9E442}"/>
+                <a16:creationId xmlns:a16="http://schemas.microsoft.com/office/drawing/2014/main" id="{77CBAB87-9715-49E7-A1E2-59C44829004D}"/>
               </a:ext>
             </a:extLst>
           </p:cNvPr>
@@ -1997,7 +1997,7 @@
           <p:cNvPr id="12" name="">
             <a:extLst xmlns:a="http://schemas.openxmlformats.org/drawingml/2006/main">
               <a:ext uri="{FF2B5EF4-FFF2-40B4-BE49-F238E27FC236}">
-                <a16:creationId xmlns:a16="http://schemas.microsoft.com/office/drawing/2014/main" id="{D3D25EA2-0739-4396-A5D8-E04CE52546E9}"/>
+                <a16:creationId xmlns:a16="http://schemas.microsoft.com/office/drawing/2014/main" id="{3D015C8A-C3B9-4E81-A219-7F25869D3A36}"/>
               </a:ext>
             </a:extLst>
           </p:cNvPr>
@@ -2048,7 +2048,7 @@
           <p:cNvPr id="13" name="">
             <a:extLst xmlns:a="http://schemas.openxmlformats.org/drawingml/2006/main">
               <a:ext uri="{FF2B5EF4-FFF2-40B4-BE49-F238E27FC236}">
-                <a16:creationId xmlns:a16="http://schemas.microsoft.com/office/drawing/2014/main" id="{09BF8A7F-AD57-4FEE-8DEB-3F13D2286587}"/>
+                <a16:creationId xmlns:a16="http://schemas.microsoft.com/office/drawing/2014/main" id="{4BE5DD4D-596C-43CD-9E9F-2477F779108D}"/>
               </a:ext>
             </a:extLst>
           </p:cNvPr>
@@ -2114,7 +2114,7 @@
           <p:cNvPr id="14" name="">
             <a:extLst xmlns:a="http://schemas.openxmlformats.org/drawingml/2006/main">
               <a:ext uri="{FF2B5EF4-FFF2-40B4-BE49-F238E27FC236}">
-                <a16:creationId xmlns:a16="http://schemas.microsoft.com/office/drawing/2014/main" id="{B0C080B6-4297-4C0E-86F5-158E7E138205}"/>
+                <a16:creationId xmlns:a16="http://schemas.microsoft.com/office/drawing/2014/main" id="{CD647E5C-83DB-49C1-8C33-FCE7FCF52B0B}"/>
               </a:ext>
             </a:extLst>
           </p:cNvPr>
@@ -2149,7 +2149,7 @@
           <p:cNvPr id="15" name="">
             <a:extLst xmlns:a="http://schemas.openxmlformats.org/drawingml/2006/main">
               <a:ext uri="{FF2B5EF4-FFF2-40B4-BE49-F238E27FC236}">
-                <a16:creationId xmlns:a16="http://schemas.microsoft.com/office/drawing/2014/main" id="{FEB8549C-6E4C-4D75-BA15-89C39ED17545}"/>
+                <a16:creationId xmlns:a16="http://schemas.microsoft.com/office/drawing/2014/main" id="{A6419A76-F700-4C2E-B0D9-A7A017D550DA}"/>
               </a:ext>
             </a:extLst>
           </p:cNvPr>
@@ -2184,7 +2184,7 @@
           <p:cNvPr id="16" name="">
             <a:extLst xmlns:a="http://schemas.openxmlformats.org/drawingml/2006/main">
               <a:ext uri="{FF2B5EF4-FFF2-40B4-BE49-F238E27FC236}">
-                <a16:creationId xmlns:a16="http://schemas.microsoft.com/office/drawing/2014/main" id="{BA20B77C-0938-4E24-9DB7-9B3DA9FD88F4}"/>
+                <a16:creationId xmlns:a16="http://schemas.microsoft.com/office/drawing/2014/main" id="{070443B3-EEB9-4802-BD54-308801A0B49E}"/>
               </a:ext>
             </a:extLst>
           </p:cNvPr>
@@ -2235,7 +2235,7 @@
           <p:cNvPr id="17" name="">
             <a:extLst xmlns:a="http://schemas.openxmlformats.org/drawingml/2006/main">
               <a:ext uri="{FF2B5EF4-FFF2-40B4-BE49-F238E27FC236}">
-                <a16:creationId xmlns:a16="http://schemas.microsoft.com/office/drawing/2014/main" id="{F6D725D0-3E4D-44D1-81F1-1FA54927708C}"/>
+                <a16:creationId xmlns:a16="http://schemas.microsoft.com/office/drawing/2014/main" id="{FC7A8385-6469-42BA-88B0-EA5C82911ADA}"/>
               </a:ext>
             </a:extLst>
           </p:cNvPr>
@@ -2284,7 +2284,7 @@
     </p:spTree>
     <p:extLst>
       <p:ext uri="{BB962C8B-B14F-4D97-AF65-F5344CB8AC3E}">
-        <p14:creationId xmlns:p14="http://schemas.microsoft.com/office/powerpoint/2010/main" val="1676640241"/>
+        <p14:creationId xmlns:p14="http://schemas.microsoft.com/office/powerpoint/2010/main" val="1445099010"/>
       </p:ext>
     </p:extLst>
   </p:cSld>
@@ -2308,7 +2308,7 @@
           <p:cNvPr id="1" name="Slide Number Placeholder 5">
             <a:extLst xmlns:a="http://schemas.openxmlformats.org/drawingml/2006/main">
               <a:ext uri="{FF2B5EF4-FFF2-40B4-BE49-F238E27FC236}">
-                <a16:creationId xmlns:a16="http://schemas.microsoft.com/office/drawing/2014/main" id="{EBA25663-28C7-4899-833E-A1FF244700B5}"/>
+                <a16:creationId xmlns:a16="http://schemas.microsoft.com/office/drawing/2014/main" id="{A4FB032A-3EC5-473E-95EF-14E6ABFA23A7}"/>
               </a:ext>
             </a:extLst>
           </p:cNvPr>
@@ -2340,7 +2340,7 @@
           <p:cNvPr id="2" name="">
             <a:extLst xmlns:a="http://schemas.openxmlformats.org/drawingml/2006/main">
               <a:ext uri="{FF2B5EF4-FFF2-40B4-BE49-F238E27FC236}">
-                <a16:creationId xmlns:a16="http://schemas.microsoft.com/office/drawing/2014/main" id="{574629E2-DF60-441F-8BD3-F35F3D13149A}"/>
+                <a16:creationId xmlns:a16="http://schemas.microsoft.com/office/drawing/2014/main" id="{DF73B052-E88D-4DF9-A6D8-E810DBFF2983}"/>
               </a:ext>
             </a:extLst>
           </p:cNvPr>
@@ -2373,7 +2373,7 @@
           <p:cNvPr id="3" name="">
             <a:extLst xmlns:a="http://schemas.openxmlformats.org/drawingml/2006/main">
               <a:ext uri="{FF2B5EF4-FFF2-40B4-BE49-F238E27FC236}">
-                <a16:creationId xmlns:a16="http://schemas.microsoft.com/office/drawing/2014/main" id="{CB3EDF0A-2690-48CE-A573-62E9259A175E}"/>
+                <a16:creationId xmlns:a16="http://schemas.microsoft.com/office/drawing/2014/main" id="{7B105DE8-DF01-4EFF-A9BD-1ED9C9A8C972}"/>
               </a:ext>
             </a:extLst>
           </p:cNvPr>
@@ -2406,7 +2406,7 @@
           <p:cNvPr id="4" name="">
             <a:extLst xmlns:a="http://schemas.openxmlformats.org/drawingml/2006/main">
               <a:ext uri="{FF2B5EF4-FFF2-40B4-BE49-F238E27FC236}">
-                <a16:creationId xmlns:a16="http://schemas.microsoft.com/office/drawing/2014/main" id="{F69B616B-4B54-409C-96B1-EC709CA892A4}"/>
+                <a16:creationId xmlns:a16="http://schemas.microsoft.com/office/drawing/2014/main" id="{413A60B1-17F5-4AED-A125-D44F73B66F3B}"/>
               </a:ext>
             </a:extLst>
           </p:cNvPr>
@@ -2457,7 +2457,7 @@
           <p:cNvPr id="5" name="">
             <a:extLst xmlns:a="http://schemas.openxmlformats.org/drawingml/2006/main">
               <a:ext uri="{FF2B5EF4-FFF2-40B4-BE49-F238E27FC236}">
-                <a16:creationId xmlns:a16="http://schemas.microsoft.com/office/drawing/2014/main" id="{5687AFBC-642B-462B-A753-2D36E76B815A}"/>
+                <a16:creationId xmlns:a16="http://schemas.microsoft.com/office/drawing/2014/main" id="{3F87070D-F4FA-4012-8821-F87F601FD418}"/>
               </a:ext>
             </a:extLst>
           </p:cNvPr>
@@ -2492,7 +2492,7 @@
           <p:cNvPr id="6" name="">
             <a:extLst xmlns:a="http://schemas.openxmlformats.org/drawingml/2006/main">
               <a:ext uri="{FF2B5EF4-FFF2-40B4-BE49-F238E27FC236}">
-                <a16:creationId xmlns:a16="http://schemas.microsoft.com/office/drawing/2014/main" id="{86A3B261-FE8A-474A-9D8A-7DFD2B179E41}"/>
+                <a16:creationId xmlns:a16="http://schemas.microsoft.com/office/drawing/2014/main" id="{6D65AA1A-64BC-45A9-8B8E-BD71E11C436A}"/>
               </a:ext>
             </a:extLst>
           </p:cNvPr>
@@ -2527,7 +2527,7 @@
           <p:cNvPr id="7" name="">
             <a:extLst xmlns:a="http://schemas.openxmlformats.org/drawingml/2006/main">
               <a:ext uri="{FF2B5EF4-FFF2-40B4-BE49-F238E27FC236}">
-                <a16:creationId xmlns:a16="http://schemas.microsoft.com/office/drawing/2014/main" id="{1EA9DC8B-D192-4753-BE7F-0FB6430D7C2B}"/>
+                <a16:creationId xmlns:a16="http://schemas.microsoft.com/office/drawing/2014/main" id="{126A7142-3A3D-4DE8-B29D-FD170BBBD5A1}"/>
               </a:ext>
             </a:extLst>
           </p:cNvPr>
@@ -2578,7 +2578,7 @@
           <p:cNvPr id="8" name="">
             <a:extLst xmlns:a="http://schemas.openxmlformats.org/drawingml/2006/main">
               <a:ext uri="{FF2B5EF4-FFF2-40B4-BE49-F238E27FC236}">
-                <a16:creationId xmlns:a16="http://schemas.microsoft.com/office/drawing/2014/main" id="{EF949073-4F8F-4552-AE10-EB4F39BFB8AB}"/>
+                <a16:creationId xmlns:a16="http://schemas.microsoft.com/office/drawing/2014/main" id="{F811AF18-204A-425B-99D3-402B4AC3160F}"/>
               </a:ext>
             </a:extLst>
           </p:cNvPr>
@@ -2629,7 +2629,7 @@
           <p:cNvPr id="9" name="">
             <a:extLst xmlns:a="http://schemas.openxmlformats.org/drawingml/2006/main">
               <a:ext uri="{FF2B5EF4-FFF2-40B4-BE49-F238E27FC236}">
-                <a16:creationId xmlns:a16="http://schemas.microsoft.com/office/drawing/2014/main" id="{77B118AB-F206-463E-9B10-8AC32E680649}"/>
+                <a16:creationId xmlns:a16="http://schemas.microsoft.com/office/drawing/2014/main" id="{CFF4BF3E-58EC-4FB8-9B52-179480001A00}"/>
               </a:ext>
             </a:extLst>
           </p:cNvPr>
@@ -2664,7 +2664,7 @@
           <p:cNvPr id="10" name="">
             <a:extLst xmlns:a="http://schemas.openxmlformats.org/drawingml/2006/main">
               <a:ext uri="{FF2B5EF4-FFF2-40B4-BE49-F238E27FC236}">
-                <a16:creationId xmlns:a16="http://schemas.microsoft.com/office/drawing/2014/main" id="{B7AE935C-0E31-42FF-A185-CE5592314A14}"/>
+                <a16:creationId xmlns:a16="http://schemas.microsoft.com/office/drawing/2014/main" id="{E1947D15-E960-455E-A366-2A5E9394158A}"/>
               </a:ext>
             </a:extLst>
           </p:cNvPr>
@@ -2699,7 +2699,7 @@
           <p:cNvPr id="11" name="">
             <a:extLst xmlns:a="http://schemas.openxmlformats.org/drawingml/2006/main">
               <a:ext uri="{FF2B5EF4-FFF2-40B4-BE49-F238E27FC236}">
-                <a16:creationId xmlns:a16="http://schemas.microsoft.com/office/drawing/2014/main" id="{4C549F18-C227-460C-8A21-4F1E917ABAEA}"/>
+                <a16:creationId xmlns:a16="http://schemas.microsoft.com/office/drawing/2014/main" id="{34B66A90-8F0F-4783-9A4F-BC945C5FE65C}"/>
               </a:ext>
             </a:extLst>
           </p:cNvPr>
@@ -2750,7 +2750,7 @@
           <p:cNvPr id="12" name="">
             <a:extLst xmlns:a="http://schemas.openxmlformats.org/drawingml/2006/main">
               <a:ext uri="{FF2B5EF4-FFF2-40B4-BE49-F238E27FC236}">
-                <a16:creationId xmlns:a16="http://schemas.microsoft.com/office/drawing/2014/main" id="{6C7ECF9D-283C-42AF-A89B-BE8B865DB665}"/>
+                <a16:creationId xmlns:a16="http://schemas.microsoft.com/office/drawing/2014/main" id="{1B8A557A-90D5-4F97-B8AC-2B05DDA75BDF}"/>
               </a:ext>
             </a:extLst>
           </p:cNvPr>
@@ -2801,7 +2801,7 @@
           <p:cNvPr id="13" name="">
             <a:extLst xmlns:a="http://schemas.openxmlformats.org/drawingml/2006/main">
               <a:ext uri="{FF2B5EF4-FFF2-40B4-BE49-F238E27FC236}">
-                <a16:creationId xmlns:a16="http://schemas.microsoft.com/office/drawing/2014/main" id="{64ED9A73-9DCE-4AB8-B089-C989D03640BE}"/>
+                <a16:creationId xmlns:a16="http://schemas.microsoft.com/office/drawing/2014/main" id="{CC6D2C2B-8FCF-40BC-93D6-56EEBCFFDFC9}"/>
               </a:ext>
             </a:extLst>
           </p:cNvPr>
@@ -2836,7 +2836,7 @@
           <p:cNvPr id="14" name="">
             <a:extLst xmlns:a="http://schemas.openxmlformats.org/drawingml/2006/main">
               <a:ext uri="{FF2B5EF4-FFF2-40B4-BE49-F238E27FC236}">
-                <a16:creationId xmlns:a16="http://schemas.microsoft.com/office/drawing/2014/main" id="{5291DD6E-7C25-4BE2-9194-220DE057AA6F}"/>
+                <a16:creationId xmlns:a16="http://schemas.microsoft.com/office/drawing/2014/main" id="{96A5870D-CDF6-494B-AF35-23A93AD6039B}"/>
               </a:ext>
             </a:extLst>
           </p:cNvPr>
@@ -2871,7 +2871,7 @@
           <p:cNvPr id="15" name="">
             <a:extLst xmlns:a="http://schemas.openxmlformats.org/drawingml/2006/main">
               <a:ext uri="{FF2B5EF4-FFF2-40B4-BE49-F238E27FC236}">
-                <a16:creationId xmlns:a16="http://schemas.microsoft.com/office/drawing/2014/main" id="{281FEA7E-D89E-4BC0-9AF3-50335F777EF6}"/>
+                <a16:creationId xmlns:a16="http://schemas.microsoft.com/office/drawing/2014/main" id="{E12AF900-B53F-47BF-BE81-D0A0B4F46B7C}"/>
               </a:ext>
             </a:extLst>
           </p:cNvPr>
@@ -2922,7 +2922,7 @@
           <p:cNvPr id="16" name="">
             <a:extLst xmlns:a="http://schemas.openxmlformats.org/drawingml/2006/main">
               <a:ext uri="{FF2B5EF4-FFF2-40B4-BE49-F238E27FC236}">
-                <a16:creationId xmlns:a16="http://schemas.microsoft.com/office/drawing/2014/main" id="{B4FFE740-9B81-4905-A068-458A05AEDAAD}"/>
+                <a16:creationId xmlns:a16="http://schemas.microsoft.com/office/drawing/2014/main" id="{6EA6F88D-010A-46BC-91EA-02195484E055}"/>
               </a:ext>
             </a:extLst>
           </p:cNvPr>
@@ -2973,7 +2973,7 @@
           <p:cNvPr id="17" name="">
             <a:extLst xmlns:a="http://schemas.openxmlformats.org/drawingml/2006/main">
               <a:ext uri="{FF2B5EF4-FFF2-40B4-BE49-F238E27FC236}">
-                <a16:creationId xmlns:a16="http://schemas.microsoft.com/office/drawing/2014/main" id="{20650684-3E9A-48AB-9D53-33F4685E7F24}"/>
+                <a16:creationId xmlns:a16="http://schemas.microsoft.com/office/drawing/2014/main" id="{61EBD488-04A3-4D1D-98E4-AE956DEAFB9D}"/>
               </a:ext>
             </a:extLst>
           </p:cNvPr>
@@ -3008,7 +3008,7 @@
           <p:cNvPr id="18" name="">
             <a:extLst xmlns:a="http://schemas.openxmlformats.org/drawingml/2006/main">
               <a:ext uri="{FF2B5EF4-FFF2-40B4-BE49-F238E27FC236}">
-                <a16:creationId xmlns:a16="http://schemas.microsoft.com/office/drawing/2014/main" id="{F40394BA-F7E7-4574-A7BF-00996D4045DF}"/>
+                <a16:creationId xmlns:a16="http://schemas.microsoft.com/office/drawing/2014/main" id="{F6294C5D-CC18-4810-A550-5B658F0203C4}"/>
               </a:ext>
             </a:extLst>
           </p:cNvPr>
@@ -3043,7 +3043,7 @@
           <p:cNvPr id="19" name="">
             <a:extLst xmlns:a="http://schemas.openxmlformats.org/drawingml/2006/main">
               <a:ext uri="{FF2B5EF4-FFF2-40B4-BE49-F238E27FC236}">
-                <a16:creationId xmlns:a16="http://schemas.microsoft.com/office/drawing/2014/main" id="{A0EBF56F-8905-490A-A060-0E6E4CD77587}"/>
+                <a16:creationId xmlns:a16="http://schemas.microsoft.com/office/drawing/2014/main" id="{B3DE43EC-E9C4-45D0-BA6D-9684EC6C69B8}"/>
               </a:ext>
             </a:extLst>
           </p:cNvPr>
@@ -3094,7 +3094,7 @@
           <p:cNvPr id="20" name="">
             <a:extLst xmlns:a="http://schemas.openxmlformats.org/drawingml/2006/main">
               <a:ext uri="{FF2B5EF4-FFF2-40B4-BE49-F238E27FC236}">
-                <a16:creationId xmlns:a16="http://schemas.microsoft.com/office/drawing/2014/main" id="{ADA46C98-EE62-4F68-B4BA-3BCA9735B4FA}"/>
+                <a16:creationId xmlns:a16="http://schemas.microsoft.com/office/drawing/2014/main" id="{5408BB35-82C6-4AE1-B252-4A69B23FDC1B}"/>
               </a:ext>
             </a:extLst>
           </p:cNvPr>
@@ -3145,7 +3145,7 @@
           <p:cNvPr id="21" name="">
             <a:extLst xmlns:a="http://schemas.openxmlformats.org/drawingml/2006/main">
               <a:ext uri="{FF2B5EF4-FFF2-40B4-BE49-F238E27FC236}">
-                <a16:creationId xmlns:a16="http://schemas.microsoft.com/office/drawing/2014/main" id="{6CCA7696-0EDF-4ECB-9731-0508C27DF30D}"/>
+                <a16:creationId xmlns:a16="http://schemas.microsoft.com/office/drawing/2014/main" id="{8B9692B0-BB7F-4A5C-983C-54BEF1B6E1A7}"/>
               </a:ext>
             </a:extLst>
           </p:cNvPr>
@@ -3180,7 +3180,7 @@
           <p:cNvPr id="22" name="">
             <a:extLst xmlns:a="http://schemas.openxmlformats.org/drawingml/2006/main">
               <a:ext uri="{FF2B5EF4-FFF2-40B4-BE49-F238E27FC236}">
-                <a16:creationId xmlns:a16="http://schemas.microsoft.com/office/drawing/2014/main" id="{D7C4E75A-0C1E-4DB4-8817-7B84AA16020F}"/>
+                <a16:creationId xmlns:a16="http://schemas.microsoft.com/office/drawing/2014/main" id="{73A3228E-FCF2-4306-95C9-70D22202C309}"/>
               </a:ext>
             </a:extLst>
           </p:cNvPr>
@@ -3215,7 +3215,7 @@
           <p:cNvPr id="23" name="">
             <a:extLst xmlns:a="http://schemas.openxmlformats.org/drawingml/2006/main">
               <a:ext uri="{FF2B5EF4-FFF2-40B4-BE49-F238E27FC236}">
-                <a16:creationId xmlns:a16="http://schemas.microsoft.com/office/drawing/2014/main" id="{DF0724BA-B00D-4FD7-9D4C-6A2B760BCF30}"/>
+                <a16:creationId xmlns:a16="http://schemas.microsoft.com/office/drawing/2014/main" id="{82A01028-01DB-43C1-8DE3-33D4C39C8113}"/>
               </a:ext>
             </a:extLst>
           </p:cNvPr>
@@ -3266,7 +3266,7 @@
           <p:cNvPr id="24" name="">
             <a:extLst xmlns:a="http://schemas.openxmlformats.org/drawingml/2006/main">
               <a:ext uri="{FF2B5EF4-FFF2-40B4-BE49-F238E27FC236}">
-                <a16:creationId xmlns:a16="http://schemas.microsoft.com/office/drawing/2014/main" id="{332D6A9E-4FF6-4699-AD77-1D94910BFD29}"/>
+                <a16:creationId xmlns:a16="http://schemas.microsoft.com/office/drawing/2014/main" id="{0F708AE5-6679-4478-94CE-AAB99135E3E7}"/>
               </a:ext>
             </a:extLst>
           </p:cNvPr>
@@ -3315,7 +3315,7 @@
     </p:spTree>
     <p:extLst>
       <p:ext uri="{BB962C8B-B14F-4D97-AF65-F5344CB8AC3E}">
-        <p14:creationId xmlns:p14="http://schemas.microsoft.com/office/powerpoint/2010/main" val="369562516"/>
+        <p14:creationId xmlns:p14="http://schemas.microsoft.com/office/powerpoint/2010/main" val="538692199"/>
       </p:ext>
     </p:extLst>
   </p:cSld>
@@ -3339,7 +3339,7 @@
           <p:cNvPr id="1" name="Slide Number Placeholder 5">
             <a:extLst xmlns:a="http://schemas.openxmlformats.org/drawingml/2006/main">
               <a:ext uri="{FF2B5EF4-FFF2-40B4-BE49-F238E27FC236}">
-                <a16:creationId xmlns:a16="http://schemas.microsoft.com/office/drawing/2014/main" id="{EBA25663-28C7-4899-833E-A1FF244700B5}"/>
+                <a16:creationId xmlns:a16="http://schemas.microsoft.com/office/drawing/2014/main" id="{A4FB032A-3EC5-473E-95EF-14E6ABFA23A7}"/>
               </a:ext>
             </a:extLst>
           </p:cNvPr>
@@ -3371,7 +3371,7 @@
           <p:cNvPr id="2" name="">
             <a:extLst xmlns:a="http://schemas.openxmlformats.org/drawingml/2006/main">
               <a:ext uri="{FF2B5EF4-FFF2-40B4-BE49-F238E27FC236}">
-                <a16:creationId xmlns:a16="http://schemas.microsoft.com/office/drawing/2014/main" id="{4F4D51F3-3157-4617-863D-0D2B215E6081}"/>
+                <a16:creationId xmlns:a16="http://schemas.microsoft.com/office/drawing/2014/main" id="{03AE577D-F238-4673-B236-CCCAE0F88B05}"/>
               </a:ext>
             </a:extLst>
           </p:cNvPr>
@@ -3404,7 +3404,7 @@
           <p:cNvPr id="3" name="">
             <a:extLst xmlns:a="http://schemas.openxmlformats.org/drawingml/2006/main">
               <a:ext uri="{FF2B5EF4-FFF2-40B4-BE49-F238E27FC236}">
-                <a16:creationId xmlns:a16="http://schemas.microsoft.com/office/drawing/2014/main" id="{FF487DE9-5798-4FC8-9210-0BD1243C6BC0}"/>
+                <a16:creationId xmlns:a16="http://schemas.microsoft.com/office/drawing/2014/main" id="{B57326A6-B8D2-4C1B-9D37-278E9BB11D03}"/>
               </a:ext>
             </a:extLst>
           </p:cNvPr>
@@ -3437,7 +3437,7 @@
           <p:cNvPr id="4" name="">
             <a:extLst xmlns:a="http://schemas.openxmlformats.org/drawingml/2006/main">
               <a:ext uri="{FF2B5EF4-FFF2-40B4-BE49-F238E27FC236}">
-                <a16:creationId xmlns:a16="http://schemas.microsoft.com/office/drawing/2014/main" id="{FEDB58E4-C9E2-46CD-A242-9BF4BC2DA864}"/>
+                <a16:creationId xmlns:a16="http://schemas.microsoft.com/office/drawing/2014/main" id="{B2D19A3E-376F-4277-8D5F-623949CB288D}"/>
               </a:ext>
             </a:extLst>
           </p:cNvPr>
@@ -3488,7 +3488,7 @@
           <p:cNvPr id="5" name="">
             <a:extLst xmlns:a="http://schemas.openxmlformats.org/drawingml/2006/main">
               <a:ext uri="{FF2B5EF4-FFF2-40B4-BE49-F238E27FC236}">
-                <a16:creationId xmlns:a16="http://schemas.microsoft.com/office/drawing/2014/main" id="{C3DC90D1-4BF5-4E1B-9469-7B3FF9601C07}"/>
+                <a16:creationId xmlns:a16="http://schemas.microsoft.com/office/drawing/2014/main" id="{B11780BA-C77A-495C-84B1-900FB51F6C41}"/>
               </a:ext>
             </a:extLst>
           </p:cNvPr>
@@ -3523,7 +3523,7 @@
           <p:cNvPr id="6" name="">
             <a:extLst xmlns:a="http://schemas.openxmlformats.org/drawingml/2006/main">
               <a:ext uri="{FF2B5EF4-FFF2-40B4-BE49-F238E27FC236}">
-                <a16:creationId xmlns:a16="http://schemas.microsoft.com/office/drawing/2014/main" id="{F242EA76-6F34-433B-A3C4-26A8CF654ADF}"/>
+                <a16:creationId xmlns:a16="http://schemas.microsoft.com/office/drawing/2014/main" id="{5C4E048C-B149-4C98-9C88-98B578208728}"/>
               </a:ext>
             </a:extLst>
           </p:cNvPr>
@@ -3558,7 +3558,7 @@
           <p:cNvPr id="7" name="">
             <a:extLst xmlns:a="http://schemas.openxmlformats.org/drawingml/2006/main">
               <a:ext uri="{FF2B5EF4-FFF2-40B4-BE49-F238E27FC236}">
-                <a16:creationId xmlns:a16="http://schemas.microsoft.com/office/drawing/2014/main" id="{102A7495-5C67-4BB2-A79A-5092B0A9D1CC}"/>
+                <a16:creationId xmlns:a16="http://schemas.microsoft.com/office/drawing/2014/main" id="{E94D249C-B2D1-435D-AD7B-229EAF94CDDD}"/>
               </a:ext>
             </a:extLst>
           </p:cNvPr>
@@ -3609,7 +3609,7 @@
           <p:cNvPr id="8" name="">
             <a:extLst xmlns:a="http://schemas.openxmlformats.org/drawingml/2006/main">
               <a:ext uri="{FF2B5EF4-FFF2-40B4-BE49-F238E27FC236}">
-                <a16:creationId xmlns:a16="http://schemas.microsoft.com/office/drawing/2014/main" id="{D98046F2-7700-43B8-AEB6-F43BE35A0630}"/>
+                <a16:creationId xmlns:a16="http://schemas.microsoft.com/office/drawing/2014/main" id="{A49695D6-8D80-4C60-8A5E-22BFF40BE0D4}"/>
               </a:ext>
             </a:extLst>
           </p:cNvPr>
@@ -3697,14 +3697,14 @@
         </p:xfrm>
         <a:graphic xmlns:a="http://schemas.openxmlformats.org/drawingml/2006/main">
           <a:graphicData uri="http://schemas.openxmlformats.org/drawingml/2006/chart">
-            <c:chart xmlns:r="http://schemas.openxmlformats.org/officeDocument/2006/relationships" xmlns:c="http://schemas.openxmlformats.org/drawingml/2006/chart" r:id="R0cf22714a784402c"/>
+            <c:chart xmlns:r="http://schemas.openxmlformats.org/officeDocument/2006/relationships" xmlns:c="http://schemas.openxmlformats.org/drawingml/2006/chart" r:id="R6be9e9b7c7b140e4"/>
           </a:graphicData>
         </a:graphic>
       </p:graphicFrame>
     </p:spTree>
     <p:extLst>
       <p:ext uri="{BB962C8B-B14F-4D97-AF65-F5344CB8AC3E}">
-        <p14:creationId xmlns:p14="http://schemas.microsoft.com/office/powerpoint/2010/main" val="198506748"/>
+        <p14:creationId xmlns:p14="http://schemas.microsoft.com/office/powerpoint/2010/main" val="192582394"/>
       </p:ext>
     </p:extLst>
   </p:cSld>
@@ -3728,7 +3728,7 @@
           <p:cNvPr id="1" name="Slide Number Placeholder 5">
             <a:extLst xmlns:a="http://schemas.openxmlformats.org/drawingml/2006/main">
               <a:ext uri="{FF2B5EF4-FFF2-40B4-BE49-F238E27FC236}">
-                <a16:creationId xmlns:a16="http://schemas.microsoft.com/office/drawing/2014/main" id="{EBA25663-28C7-4899-833E-A1FF244700B5}"/>
+                <a16:creationId xmlns:a16="http://schemas.microsoft.com/office/drawing/2014/main" id="{A4FB032A-3EC5-473E-95EF-14E6ABFA23A7}"/>
               </a:ext>
             </a:extLst>
           </p:cNvPr>
@@ -3760,7 +3760,7 @@
           <p:cNvPr id="2" name="">
             <a:extLst xmlns:a="http://schemas.openxmlformats.org/drawingml/2006/main">
               <a:ext uri="{FF2B5EF4-FFF2-40B4-BE49-F238E27FC236}">
-                <a16:creationId xmlns:a16="http://schemas.microsoft.com/office/drawing/2014/main" id="{7EAE3FF4-099C-4445-8AB3-FAB200671055}"/>
+                <a16:creationId xmlns:a16="http://schemas.microsoft.com/office/drawing/2014/main" id="{FA8E15D1-1376-460D-92D3-AFB264E0C0E0}"/>
               </a:ext>
             </a:extLst>
           </p:cNvPr>
@@ -3793,7 +3793,7 @@
           <p:cNvPr id="3" name="">
             <a:extLst xmlns:a="http://schemas.openxmlformats.org/drawingml/2006/main">
               <a:ext uri="{FF2B5EF4-FFF2-40B4-BE49-F238E27FC236}">
-                <a16:creationId xmlns:a16="http://schemas.microsoft.com/office/drawing/2014/main" id="{45C664D2-39F0-4EBA-81B2-F5B5D960AD18}"/>
+                <a16:creationId xmlns:a16="http://schemas.microsoft.com/office/drawing/2014/main" id="{4691D657-4E11-4BA5-90DC-A84A8EF9DA9F}"/>
               </a:ext>
             </a:extLst>
           </p:cNvPr>
@@ -3826,7 +3826,7 @@
           <p:cNvPr id="4" name="">
             <a:extLst xmlns:a="http://schemas.openxmlformats.org/drawingml/2006/main">
               <a:ext uri="{FF2B5EF4-FFF2-40B4-BE49-F238E27FC236}">
-                <a16:creationId xmlns:a16="http://schemas.microsoft.com/office/drawing/2014/main" id="{4B3511A4-ED56-49B1-BBC0-5BF01D290B3A}"/>
+                <a16:creationId xmlns:a16="http://schemas.microsoft.com/office/drawing/2014/main" id="{5EFA7EAD-A6E1-4DEA-B538-5068179B0C95}"/>
               </a:ext>
             </a:extLst>
           </p:cNvPr>
@@ -3877,7 +3877,7 @@
           <p:cNvPr id="5" name="">
             <a:extLst xmlns:a="http://schemas.openxmlformats.org/drawingml/2006/main">
               <a:ext uri="{FF2B5EF4-FFF2-40B4-BE49-F238E27FC236}">
-                <a16:creationId xmlns:a16="http://schemas.microsoft.com/office/drawing/2014/main" id="{322A51CA-D4DC-4C6A-BB6D-4B427D95A586}"/>
+                <a16:creationId xmlns:a16="http://schemas.microsoft.com/office/drawing/2014/main" id="{0617575F-0AAC-4B23-AAEA-145DC073AC20}"/>
               </a:ext>
             </a:extLst>
           </p:cNvPr>
@@ -3912,7 +3912,7 @@
           <p:cNvPr id="6" name="">
             <a:extLst xmlns:a="http://schemas.openxmlformats.org/drawingml/2006/main">
               <a:ext uri="{FF2B5EF4-FFF2-40B4-BE49-F238E27FC236}">
-                <a16:creationId xmlns:a16="http://schemas.microsoft.com/office/drawing/2014/main" id="{0DF0C6EA-7615-4D7D-BF4C-E0AC43430B49}"/>
+                <a16:creationId xmlns:a16="http://schemas.microsoft.com/office/drawing/2014/main" id="{9155FB5B-5498-4AE1-AEAD-233FC794A845}"/>
               </a:ext>
             </a:extLst>
           </p:cNvPr>
@@ -3947,7 +3947,7 @@
           <p:cNvPr id="7" name="">
             <a:extLst xmlns:a="http://schemas.openxmlformats.org/drawingml/2006/main">
               <a:ext uri="{FF2B5EF4-FFF2-40B4-BE49-F238E27FC236}">
-                <a16:creationId xmlns:a16="http://schemas.microsoft.com/office/drawing/2014/main" id="{2CFB7640-FAF9-4834-A2F1-D2F02B5FBAAD}"/>
+                <a16:creationId xmlns:a16="http://schemas.microsoft.com/office/drawing/2014/main" id="{414C9CCA-B4B6-47B0-9240-F4E8E4716E14}"/>
               </a:ext>
             </a:extLst>
           </p:cNvPr>
@@ -3998,7 +3998,7 @@
           <p:cNvPr id="8" name="">
             <a:extLst xmlns:a="http://schemas.openxmlformats.org/drawingml/2006/main">
               <a:ext uri="{FF2B5EF4-FFF2-40B4-BE49-F238E27FC236}">
-                <a16:creationId xmlns:a16="http://schemas.microsoft.com/office/drawing/2014/main" id="{089A397A-A328-467D-80A6-AEC984162956}"/>
+                <a16:creationId xmlns:a16="http://schemas.microsoft.com/office/drawing/2014/main" id="{D5E6F263-B6BF-4C5E-9BE4-DF34D24AA628}"/>
               </a:ext>
             </a:extLst>
           </p:cNvPr>
@@ -4069,7 +4069,7 @@
                   <a:srgbClr val="334155"/>
                 </a:solidFill>
               </a:rPr>
-              <a:t>3. Self-serve analytics export shipped to general availability after the final rollout guardrails cleared.</a:t>
+              <a:t>3. Support backlog dropped below 24 hours for the first time in six weeks after the triage rotation change.</a:t>
             </a:r>
           </a:p>
         </p:txBody>
@@ -4079,7 +4079,7 @@
           <p:cNvPr id="9" name="">
             <a:extLst xmlns:a="http://schemas.openxmlformats.org/drawingml/2006/main">
               <a:ext uri="{FF2B5EF4-FFF2-40B4-BE49-F238E27FC236}">
-                <a16:creationId xmlns:a16="http://schemas.microsoft.com/office/drawing/2014/main" id="{5D09CAB2-0FA6-4D76-921B-3852B0EEC9CC}"/>
+                <a16:creationId xmlns:a16="http://schemas.microsoft.com/office/drawing/2014/main" id="{A4F75FE6-822C-4E4B-8798-36E462CBE62E}"/>
               </a:ext>
             </a:extLst>
           </p:cNvPr>
@@ -4114,7 +4114,7 @@
           <p:cNvPr id="10" name="">
             <a:extLst xmlns:a="http://schemas.openxmlformats.org/drawingml/2006/main">
               <a:ext uri="{FF2B5EF4-FFF2-40B4-BE49-F238E27FC236}">
-                <a16:creationId xmlns:a16="http://schemas.microsoft.com/office/drawing/2014/main" id="{34DB249E-86E2-4224-A847-BCABE9D07A3A}"/>
+                <a16:creationId xmlns:a16="http://schemas.microsoft.com/office/drawing/2014/main" id="{254A0C08-0CB3-45B8-9011-F054B8D1B9D1}"/>
               </a:ext>
             </a:extLst>
           </p:cNvPr>
@@ -4149,7 +4149,7 @@
           <p:cNvPr id="11" name="">
             <a:extLst xmlns:a="http://schemas.openxmlformats.org/drawingml/2006/main">
               <a:ext uri="{FF2B5EF4-FFF2-40B4-BE49-F238E27FC236}">
-                <a16:creationId xmlns:a16="http://schemas.microsoft.com/office/drawing/2014/main" id="{7937C500-EA6E-4EC9-80C5-3D8E0C55C22C}"/>
+                <a16:creationId xmlns:a16="http://schemas.microsoft.com/office/drawing/2014/main" id="{09B8B8E7-5E04-44E2-B78B-FE245040602E}"/>
               </a:ext>
             </a:extLst>
           </p:cNvPr>
@@ -4200,7 +4200,7 @@
           <p:cNvPr id="12" name="">
             <a:extLst xmlns:a="http://schemas.openxmlformats.org/drawingml/2006/main">
               <a:ext uri="{FF2B5EF4-FFF2-40B4-BE49-F238E27FC236}">
-                <a16:creationId xmlns:a16="http://schemas.microsoft.com/office/drawing/2014/main" id="{3CE7CE73-2533-4D0A-B1E3-6EA3504E06F1}"/>
+                <a16:creationId xmlns:a16="http://schemas.microsoft.com/office/drawing/2014/main" id="{8EBDD53B-C6F3-4FCD-90B9-DDD33508083B}"/>
               </a:ext>
             </a:extLst>
           </p:cNvPr>
@@ -4271,7 +4271,7 @@
                   <a:srgbClr val="334155"/>
                 </a:solidFill>
               </a:rPr>
-              <a:t>3. The mobile crash regression fix is still waiting on final QA signoff.</a:t>
+              <a:t>3. Finance flagged June vendor spend as slightly ahead of plan because of the analytics infrastructure migration.</a:t>
             </a:r>
           </a:p>
         </p:txBody>
@@ -4279,7 +4279,7 @@
     </p:spTree>
     <p:extLst>
       <p:ext uri="{BB962C8B-B14F-4D97-AF65-F5344CB8AC3E}">
-        <p14:creationId xmlns:p14="http://schemas.microsoft.com/office/powerpoint/2010/main" val="1830808544"/>
+        <p14:creationId xmlns:p14="http://schemas.microsoft.com/office/powerpoint/2010/main" val="798786057"/>
       </p:ext>
     </p:extLst>
   </p:cSld>
@@ -4303,7 +4303,7 @@
           <p:cNvPr id="1" name="Slide Number Placeholder 5">
             <a:extLst xmlns:a="http://schemas.openxmlformats.org/drawingml/2006/main">
               <a:ext uri="{FF2B5EF4-FFF2-40B4-BE49-F238E27FC236}">
-                <a16:creationId xmlns:a16="http://schemas.microsoft.com/office/drawing/2014/main" id="{EBA25663-28C7-4899-833E-A1FF244700B5}"/>
+                <a16:creationId xmlns:a16="http://schemas.microsoft.com/office/drawing/2014/main" id="{A4FB032A-3EC5-473E-95EF-14E6ABFA23A7}"/>
               </a:ext>
             </a:extLst>
           </p:cNvPr>
@@ -4335,7 +4335,7 @@
           <p:cNvPr id="2" name="">
             <a:extLst xmlns:a="http://schemas.openxmlformats.org/drawingml/2006/main">
               <a:ext uri="{FF2B5EF4-FFF2-40B4-BE49-F238E27FC236}">
-                <a16:creationId xmlns:a16="http://schemas.microsoft.com/office/drawing/2014/main" id="{87A57180-32F3-4F84-999E-E8D72B506DAD}"/>
+                <a16:creationId xmlns:a16="http://schemas.microsoft.com/office/drawing/2014/main" id="{7AAED019-709A-4BBC-8499-F58C0F87D350}"/>
               </a:ext>
             </a:extLst>
           </p:cNvPr>
@@ -4368,7 +4368,7 @@
           <p:cNvPr id="3" name="">
             <a:extLst xmlns:a="http://schemas.openxmlformats.org/drawingml/2006/main">
               <a:ext uri="{FF2B5EF4-FFF2-40B4-BE49-F238E27FC236}">
-                <a16:creationId xmlns:a16="http://schemas.microsoft.com/office/drawing/2014/main" id="{2B31BDF0-3DC9-4A81-9F5C-09CBC6304F2D}"/>
+                <a16:creationId xmlns:a16="http://schemas.microsoft.com/office/drawing/2014/main" id="{E7D51792-71CC-427A-ABAA-4ABC74151E94}"/>
               </a:ext>
             </a:extLst>
           </p:cNvPr>
@@ -4401,7 +4401,7 @@
           <p:cNvPr id="4" name="">
             <a:extLst xmlns:a="http://schemas.openxmlformats.org/drawingml/2006/main">
               <a:ext uri="{FF2B5EF4-FFF2-40B4-BE49-F238E27FC236}">
-                <a16:creationId xmlns:a16="http://schemas.microsoft.com/office/drawing/2014/main" id="{3DF46012-054D-4239-AC91-D6137742F8C5}"/>
+                <a16:creationId xmlns:a16="http://schemas.microsoft.com/office/drawing/2014/main" id="{31FC8B3F-F069-426A-9C25-A630C5181083}"/>
               </a:ext>
             </a:extLst>
           </p:cNvPr>
@@ -4452,7 +4452,7 @@
           <p:cNvPr id="5" name="">
             <a:extLst xmlns:a="http://schemas.openxmlformats.org/drawingml/2006/main">
               <a:ext uri="{FF2B5EF4-FFF2-40B4-BE49-F238E27FC236}">
-                <a16:creationId xmlns:a16="http://schemas.microsoft.com/office/drawing/2014/main" id="{A1067CA4-E58F-4FA5-B0E4-5899FC18759E}"/>
+                <a16:creationId xmlns:a16="http://schemas.microsoft.com/office/drawing/2014/main" id="{97C8F495-7FA0-4E6B-AA78-1C49A01C5870}"/>
               </a:ext>
             </a:extLst>
           </p:cNvPr>
@@ -4487,7 +4487,7 @@
           <p:cNvPr id="6" name="">
             <a:extLst xmlns:a="http://schemas.openxmlformats.org/drawingml/2006/main">
               <a:ext uri="{FF2B5EF4-FFF2-40B4-BE49-F238E27FC236}">
-                <a16:creationId xmlns:a16="http://schemas.microsoft.com/office/drawing/2014/main" id="{46C3D53C-61EA-4393-B815-7EEAA54C91CC}"/>
+                <a16:creationId xmlns:a16="http://schemas.microsoft.com/office/drawing/2014/main" id="{91D25DF5-9815-4AF9-9170-68DC786D4505}"/>
               </a:ext>
             </a:extLst>
           </p:cNvPr>
@@ -4522,7 +4522,7 @@
           <p:cNvPr id="7" name="">
             <a:extLst xmlns:a="http://schemas.openxmlformats.org/drawingml/2006/main">
               <a:ext uri="{FF2B5EF4-FFF2-40B4-BE49-F238E27FC236}">
-                <a16:creationId xmlns:a16="http://schemas.microsoft.com/office/drawing/2014/main" id="{BCA32905-5CA2-49EB-8736-614E7A19FEF7}"/>
+                <a16:creationId xmlns:a16="http://schemas.microsoft.com/office/drawing/2014/main" id="{0AB0CAC0-A757-485C-97CF-C5CB8D9A91B5}"/>
               </a:ext>
             </a:extLst>
           </p:cNvPr>
@@ -4573,7 +4573,7 @@
           <p:cNvPr id="8" name="">
             <a:extLst xmlns:a="http://schemas.openxmlformats.org/drawingml/2006/main">
               <a:ext uri="{FF2B5EF4-FFF2-40B4-BE49-F238E27FC236}">
-                <a16:creationId xmlns:a16="http://schemas.microsoft.com/office/drawing/2014/main" id="{1A48F8E6-613E-4DFC-B467-735C9452F98E}"/>
+                <a16:creationId xmlns:a16="http://schemas.microsoft.com/office/drawing/2014/main" id="{7E22FD77-BDD7-48DE-86FD-F727DEDA1E00}"/>
               </a:ext>
             </a:extLst>
           </p:cNvPr>
@@ -4669,7 +4669,7 @@
           <p:cNvPr id="9" name="">
             <a:extLst xmlns:a="http://schemas.openxmlformats.org/drawingml/2006/main">
               <a:ext uri="{FF2B5EF4-FFF2-40B4-BE49-F238E27FC236}">
-                <a16:creationId xmlns:a16="http://schemas.microsoft.com/office/drawing/2014/main" id="{1593EA78-EEDE-474A-AC57-8552EEC37587}"/>
+                <a16:creationId xmlns:a16="http://schemas.microsoft.com/office/drawing/2014/main" id="{DC359527-34F7-4753-8825-9175C27C9358}"/>
               </a:ext>
             </a:extLst>
           </p:cNvPr>
@@ -4704,7 +4704,7 @@
           <p:cNvPr id="10" name="">
             <a:extLst xmlns:a="http://schemas.openxmlformats.org/drawingml/2006/main">
               <a:ext uri="{FF2B5EF4-FFF2-40B4-BE49-F238E27FC236}">
-                <a16:creationId xmlns:a16="http://schemas.microsoft.com/office/drawing/2014/main" id="{6A995771-5741-4EDB-B12D-118BD3C4AA0B}"/>
+                <a16:creationId xmlns:a16="http://schemas.microsoft.com/office/drawing/2014/main" id="{9DF7C254-AF54-4837-B416-9D4AAD4ACBB6}"/>
               </a:ext>
             </a:extLst>
           </p:cNvPr>
@@ -4739,7 +4739,7 @@
           <p:cNvPr id="11" name="">
             <a:extLst xmlns:a="http://schemas.openxmlformats.org/drawingml/2006/main">
               <a:ext uri="{FF2B5EF4-FFF2-40B4-BE49-F238E27FC236}">
-                <a16:creationId xmlns:a16="http://schemas.microsoft.com/office/drawing/2014/main" id="{7069CC77-D251-4D6C-8DBF-F2DD98FAE02D}"/>
+                <a16:creationId xmlns:a16="http://schemas.microsoft.com/office/drawing/2014/main" id="{D2629878-F73D-4556-A5D9-C02D5E8CA110}"/>
               </a:ext>
             </a:extLst>
           </p:cNvPr>
@@ -4790,7 +4790,7 @@
           <p:cNvPr id="12" name="">
             <a:extLst xmlns:a="http://schemas.openxmlformats.org/drawingml/2006/main">
               <a:ext uri="{FF2B5EF4-FFF2-40B4-BE49-F238E27FC236}">
-                <a16:creationId xmlns:a16="http://schemas.microsoft.com/office/drawing/2014/main" id="{07D02E83-15FF-40E0-BFAD-5516094451AE}"/>
+                <a16:creationId xmlns:a16="http://schemas.microsoft.com/office/drawing/2014/main" id="{5AB8D10C-C3D6-4241-8B40-55AB3488AE45}"/>
               </a:ext>
             </a:extLst>
           </p:cNvPr>
@@ -4869,7 +4869,7 @@
     </p:spTree>
     <p:extLst>
       <p:ext uri="{BB962C8B-B14F-4D97-AF65-F5344CB8AC3E}">
-        <p14:creationId xmlns:p14="http://schemas.microsoft.com/office/powerpoint/2010/main" val="190686683"/>
+        <p14:creationId xmlns:p14="http://schemas.microsoft.com/office/powerpoint/2010/main" val="1679256193"/>
       </p:ext>
     </p:extLst>
   </p:cSld>

</xml_diff>

<commit_message>
Add live Slack adapter and scheduled briefing runner
</commit_message>
<xml_diff>
--- a/outputs/executive-briefing-machine-demo/executive-briefing-demo.pptx
+++ b/outputs/executive-briefing-machine-demo/executive-briefing-demo.pptx
@@ -2,17 +2,17 @@
 <file path=ppt/presentation.xml><?xml version="1.0" encoding="utf-8"?>
 <p:presentation xmlns:p="http://schemas.openxmlformats.org/presentationml/2006/main">
   <p:sldMasterIdLst>
-    <p:sldMasterId xmlns:r="http://schemas.openxmlformats.org/officeDocument/2006/relationships" id="2147483648" r:id="R22aad39d52c4476a"/>
+    <p:sldMasterId xmlns:r="http://schemas.openxmlformats.org/officeDocument/2006/relationships" id="2147483648" r:id="Raa382a26039643e7"/>
   </p:sldMasterIdLst>
   <p:notesMasterIdLst>
-    <p:notesMasterId xmlns:r="http://schemas.openxmlformats.org/officeDocument/2006/relationships" r:id="R09127fae92ed4be3"/>
+    <p:notesMasterId xmlns:r="http://schemas.openxmlformats.org/officeDocument/2006/relationships" r:id="R601971fe2c7944ae"/>
   </p:notesMasterIdLst>
   <p:sldIdLst>
-    <p:sldId xmlns:r="http://schemas.openxmlformats.org/officeDocument/2006/relationships" id="256" r:id="R7dc1f00ffc304d9d"/>
-    <p:sldId xmlns:r="http://schemas.openxmlformats.org/officeDocument/2006/relationships" id="257" r:id="R1319853b892642ca"/>
-    <p:sldId xmlns:r="http://schemas.openxmlformats.org/officeDocument/2006/relationships" id="258" r:id="Reac96d31f6414c76"/>
-    <p:sldId xmlns:r="http://schemas.openxmlformats.org/officeDocument/2006/relationships" id="259" r:id="R3139205e3d3b4013"/>
-    <p:sldId xmlns:r="http://schemas.openxmlformats.org/officeDocument/2006/relationships" id="260" r:id="Re885fb9238784981"/>
+    <p:sldId xmlns:r="http://schemas.openxmlformats.org/officeDocument/2006/relationships" id="256" r:id="R1cf1ed61b2684339"/>
+    <p:sldId xmlns:r="http://schemas.openxmlformats.org/officeDocument/2006/relationships" id="257" r:id="R7507bc7f04cb4a11"/>
+    <p:sldId xmlns:r="http://schemas.openxmlformats.org/officeDocument/2006/relationships" id="258" r:id="R341532d5546c4f1a"/>
+    <p:sldId xmlns:r="http://schemas.openxmlformats.org/officeDocument/2006/relationships" id="259" r:id="Ra5ba41cc9ba84407"/>
+    <p:sldId xmlns:r="http://schemas.openxmlformats.org/officeDocument/2006/relationships" id="260" r:id="Rd4cdfb3e36aa4181"/>
   </p:sldIdLst>
   <p:sldSz cx="12192000" cy="6858000"/>
   <p:notesSz cx="6858000" cy="9144000"/>
@@ -721,7 +721,7 @@
           <p:cNvPr id="1" name="Title 1">
             <a:extLst xmlns:a="http://schemas.openxmlformats.org/drawingml/2006/main">
               <a:ext uri="{FF2B5EF4-FFF2-40B4-BE49-F238E27FC236}">
-                <a16:creationId xmlns:a16="http://schemas.microsoft.com/office/drawing/2014/main" id="{5D6607B5-A12B-40F7-AFBA-3051487DFF19}"/>
+                <a16:creationId xmlns:a16="http://schemas.microsoft.com/office/drawing/2014/main" id="{586420F6-B558-43A1-A804-35E0A503AE17}"/>
               </a:ext>
             </a:extLst>
           </p:cNvPr>
@@ -752,7 +752,7 @@
           <p:cNvPr id="2" name="Subtitle 2">
             <a:extLst xmlns:a="http://schemas.openxmlformats.org/drawingml/2006/main">
               <a:ext uri="{FF2B5EF4-FFF2-40B4-BE49-F238E27FC236}">
-                <a16:creationId xmlns:a16="http://schemas.microsoft.com/office/drawing/2014/main" id="{0B0C3C5C-D3FC-4B17-ADF3-1452B1071AFC}"/>
+                <a16:creationId xmlns:a16="http://schemas.microsoft.com/office/drawing/2014/main" id="{C00613D8-B0C0-4122-A1A9-2CC82AB46362}"/>
               </a:ext>
             </a:extLst>
           </p:cNvPr>
@@ -815,7 +815,7 @@
           <p:cNvPr id="3" name="Date Placeholder 3">
             <a:extLst xmlns:a="http://schemas.openxmlformats.org/drawingml/2006/main">
               <a:ext uri="{FF2B5EF4-FFF2-40B4-BE49-F238E27FC236}">
-                <a16:creationId xmlns:a16="http://schemas.microsoft.com/office/drawing/2014/main" id="{5EFF3265-1718-4D45-B612-0191F6B55479}"/>
+                <a16:creationId xmlns:a16="http://schemas.microsoft.com/office/drawing/2014/main" id="{FF4A766B-5C6E-4C80-9FCE-7F15455F059A}"/>
               </a:ext>
             </a:extLst>
           </p:cNvPr>
@@ -836,7 +836,7 @@
           <p:cNvPr id="4" name="Footer Placeholder 4">
             <a:extLst xmlns:a="http://schemas.openxmlformats.org/drawingml/2006/main">
               <a:ext uri="{FF2B5EF4-FFF2-40B4-BE49-F238E27FC236}">
-                <a16:creationId xmlns:a16="http://schemas.microsoft.com/office/drawing/2014/main" id="{2E01B156-63A3-491B-9FF6-B50EEBEBD63A}"/>
+                <a16:creationId xmlns:a16="http://schemas.microsoft.com/office/drawing/2014/main" id="{8613A6C4-F784-4EC9-B723-8D8CEB635AF1}"/>
               </a:ext>
             </a:extLst>
           </p:cNvPr>
@@ -857,7 +857,7 @@
           <p:cNvPr id="5" name="Slide Number Placeholder 5">
             <a:extLst xmlns:a="http://schemas.openxmlformats.org/drawingml/2006/main">
               <a:ext uri="{FF2B5EF4-FFF2-40B4-BE49-F238E27FC236}">
-                <a16:creationId xmlns:a16="http://schemas.microsoft.com/office/drawing/2014/main" id="{A4FB032A-3EC5-473E-95EF-14E6ABFA23A7}"/>
+                <a16:creationId xmlns:a16="http://schemas.microsoft.com/office/drawing/2014/main" id="{2ABBF3EC-52F3-4D5D-88DE-CE0FBD0B3A4D}"/>
               </a:ext>
             </a:extLst>
           </p:cNvPr>
@@ -900,7 +900,7 @@
           <p:cNvPr id="1" name="Slide Number Placeholder 5">
             <a:extLst xmlns:a="http://schemas.openxmlformats.org/drawingml/2006/main">
               <a:ext uri="{FF2B5EF4-FFF2-40B4-BE49-F238E27FC236}">
-                <a16:creationId xmlns:a16="http://schemas.microsoft.com/office/drawing/2014/main" id="{C39FFE53-6569-4E06-B264-8E9E38B50BF9}"/>
+                <a16:creationId xmlns:a16="http://schemas.microsoft.com/office/drawing/2014/main" id="{06512020-74D0-46B9-911A-580AFA0BCA19}"/>
               </a:ext>
             </a:extLst>
           </p:cNvPr>
@@ -939,7 +939,7 @@
   </p:cSld>
   <p:clrMap bg1="lt1" tx1="dk1" bg2="lt2" tx2="dk2" accent1="accent1" accent2="accent2" accent3="accent3" accent4="accent4" accent5="accent5" accent6="accent6" hlink="hlink" folHlink="folHlink"/>
   <p:sldLayoutIdLst>
-    <p:sldLayoutId xmlns:r="http://schemas.openxmlformats.org/officeDocument/2006/relationships" id="2147483649" r:id="R4a5f7961dc0a4e0e"/>
+    <p:sldLayoutId xmlns:r="http://schemas.openxmlformats.org/officeDocument/2006/relationships" id="2147483649" r:id="Rfcaabc32cdd24107"/>
   </p:sldLayoutIdLst>
   <p:txStyles>
     <p:titleStyle>
@@ -1540,7 +1540,7 @@
           <p:cNvPr id="1" name="Slide Number Placeholder 5">
             <a:extLst xmlns:a="http://schemas.openxmlformats.org/drawingml/2006/main">
               <a:ext uri="{FF2B5EF4-FFF2-40B4-BE49-F238E27FC236}">
-                <a16:creationId xmlns:a16="http://schemas.microsoft.com/office/drawing/2014/main" id="{A4FB032A-3EC5-473E-95EF-14E6ABFA23A7}"/>
+                <a16:creationId xmlns:a16="http://schemas.microsoft.com/office/drawing/2014/main" id="{2ABBF3EC-52F3-4D5D-88DE-CE0FBD0B3A4D}"/>
               </a:ext>
             </a:extLst>
           </p:cNvPr>
@@ -1572,7 +1572,7 @@
           <p:cNvPr id="2" name="">
             <a:extLst xmlns:a="http://schemas.openxmlformats.org/drawingml/2006/main">
               <a:ext uri="{FF2B5EF4-FFF2-40B4-BE49-F238E27FC236}">
-                <a16:creationId xmlns:a16="http://schemas.microsoft.com/office/drawing/2014/main" id="{52849F57-0305-414B-9C17-503BCF30A4FA}"/>
+                <a16:creationId xmlns:a16="http://schemas.microsoft.com/office/drawing/2014/main" id="{BC4852AB-12B7-4302-9A9D-A1211B8D2F67}"/>
               </a:ext>
             </a:extLst>
           </p:cNvPr>
@@ -1605,7 +1605,7 @@
           <p:cNvPr id="3" name="">
             <a:extLst xmlns:a="http://schemas.openxmlformats.org/drawingml/2006/main">
               <a:ext uri="{FF2B5EF4-FFF2-40B4-BE49-F238E27FC236}">
-                <a16:creationId xmlns:a16="http://schemas.microsoft.com/office/drawing/2014/main" id="{FE04CF9C-6B15-46E0-B3E1-B7D171D75728}"/>
+                <a16:creationId xmlns:a16="http://schemas.microsoft.com/office/drawing/2014/main" id="{5A396260-0431-4D58-8D55-0C6617CE6DD4}"/>
               </a:ext>
             </a:extLst>
           </p:cNvPr>
@@ -1638,7 +1638,7 @@
           <p:cNvPr id="4" name="">
             <a:extLst xmlns:a="http://schemas.openxmlformats.org/drawingml/2006/main">
               <a:ext uri="{FF2B5EF4-FFF2-40B4-BE49-F238E27FC236}">
-                <a16:creationId xmlns:a16="http://schemas.microsoft.com/office/drawing/2014/main" id="{32453FD8-A33A-4A14-B266-6EC81683A7DB}"/>
+                <a16:creationId xmlns:a16="http://schemas.microsoft.com/office/drawing/2014/main" id="{9B8FD63B-DAA3-4283-B9CD-32FEB8AF159E}"/>
               </a:ext>
             </a:extLst>
           </p:cNvPr>
@@ -1689,7 +1689,7 @@
           <p:cNvPr id="5" name="">
             <a:extLst xmlns:a="http://schemas.openxmlformats.org/drawingml/2006/main">
               <a:ext uri="{FF2B5EF4-FFF2-40B4-BE49-F238E27FC236}">
-                <a16:creationId xmlns:a16="http://schemas.microsoft.com/office/drawing/2014/main" id="{113BE01D-BD90-48BC-A364-2E08048D8959}"/>
+                <a16:creationId xmlns:a16="http://schemas.microsoft.com/office/drawing/2014/main" id="{78F7A7AB-42B3-4A11-BFCC-CCDEC91F4CB2}"/>
               </a:ext>
             </a:extLst>
           </p:cNvPr>
@@ -1740,7 +1740,7 @@
           <p:cNvPr id="6" name="">
             <a:extLst xmlns:a="http://schemas.openxmlformats.org/drawingml/2006/main">
               <a:ext uri="{FF2B5EF4-FFF2-40B4-BE49-F238E27FC236}">
-                <a16:creationId xmlns:a16="http://schemas.microsoft.com/office/drawing/2014/main" id="{1754F990-5343-4453-907F-1C9DE6F8AC55}"/>
+                <a16:creationId xmlns:a16="http://schemas.microsoft.com/office/drawing/2014/main" id="{FABFA8AC-2B06-4067-88D9-D276FEB68236}"/>
               </a:ext>
             </a:extLst>
           </p:cNvPr>
@@ -1775,7 +1775,7 @@
           <p:cNvPr id="7" name="">
             <a:extLst xmlns:a="http://schemas.openxmlformats.org/drawingml/2006/main">
               <a:ext uri="{FF2B5EF4-FFF2-40B4-BE49-F238E27FC236}">
-                <a16:creationId xmlns:a16="http://schemas.microsoft.com/office/drawing/2014/main" id="{3EFD4FE3-EE78-49C0-B66C-33D7302B5C84}"/>
+                <a16:creationId xmlns:a16="http://schemas.microsoft.com/office/drawing/2014/main" id="{5102EE5D-30BC-4828-AB49-EBB5768876D0}"/>
               </a:ext>
             </a:extLst>
           </p:cNvPr>
@@ -1810,7 +1810,7 @@
           <p:cNvPr id="8" name="">
             <a:extLst xmlns:a="http://schemas.openxmlformats.org/drawingml/2006/main">
               <a:ext uri="{FF2B5EF4-FFF2-40B4-BE49-F238E27FC236}">
-                <a16:creationId xmlns:a16="http://schemas.microsoft.com/office/drawing/2014/main" id="{47719D48-6D03-49BD-A1FE-5884DA4D53E1}"/>
+                <a16:creationId xmlns:a16="http://schemas.microsoft.com/office/drawing/2014/main" id="{0438B947-72C5-4C22-98BB-86E98C5DEABE}"/>
               </a:ext>
             </a:extLst>
           </p:cNvPr>
@@ -1861,7 +1861,7 @@
           <p:cNvPr id="9" name="">
             <a:extLst xmlns:a="http://schemas.openxmlformats.org/drawingml/2006/main">
               <a:ext uri="{FF2B5EF4-FFF2-40B4-BE49-F238E27FC236}">
-                <a16:creationId xmlns:a16="http://schemas.microsoft.com/office/drawing/2014/main" id="{E72C1D47-353D-4062-8FB7-2B99F8A4E0DD}"/>
+                <a16:creationId xmlns:a16="http://schemas.microsoft.com/office/drawing/2014/main" id="{31F12B20-1E6A-40CD-BDD2-CCD9964E8007}"/>
               </a:ext>
             </a:extLst>
           </p:cNvPr>
@@ -1927,7 +1927,7 @@
           <p:cNvPr id="10" name="">
             <a:extLst xmlns:a="http://schemas.openxmlformats.org/drawingml/2006/main">
               <a:ext uri="{FF2B5EF4-FFF2-40B4-BE49-F238E27FC236}">
-                <a16:creationId xmlns:a16="http://schemas.microsoft.com/office/drawing/2014/main" id="{BF1C89E7-A2C4-41D2-837D-50719BDE8B1D}"/>
+                <a16:creationId xmlns:a16="http://schemas.microsoft.com/office/drawing/2014/main" id="{D93F9971-133E-4A55-BBF8-885A097A6349}"/>
               </a:ext>
             </a:extLst>
           </p:cNvPr>
@@ -1962,7 +1962,7 @@
           <p:cNvPr id="11" name="">
             <a:extLst xmlns:a="http://schemas.openxmlformats.org/drawingml/2006/main">
               <a:ext uri="{FF2B5EF4-FFF2-40B4-BE49-F238E27FC236}">
-                <a16:creationId xmlns:a16="http://schemas.microsoft.com/office/drawing/2014/main" id="{77CBAB87-9715-49E7-A1E2-59C44829004D}"/>
+                <a16:creationId xmlns:a16="http://schemas.microsoft.com/office/drawing/2014/main" id="{6845BD06-718A-45CF-A939-4431193AE267}"/>
               </a:ext>
             </a:extLst>
           </p:cNvPr>
@@ -1997,7 +1997,7 @@
           <p:cNvPr id="12" name="">
             <a:extLst xmlns:a="http://schemas.openxmlformats.org/drawingml/2006/main">
               <a:ext uri="{FF2B5EF4-FFF2-40B4-BE49-F238E27FC236}">
-                <a16:creationId xmlns:a16="http://schemas.microsoft.com/office/drawing/2014/main" id="{3D015C8A-C3B9-4E81-A219-7F25869D3A36}"/>
+                <a16:creationId xmlns:a16="http://schemas.microsoft.com/office/drawing/2014/main" id="{3983F299-6108-4C99-A139-D5D19D75EFEF}"/>
               </a:ext>
             </a:extLst>
           </p:cNvPr>
@@ -2048,7 +2048,7 @@
           <p:cNvPr id="13" name="">
             <a:extLst xmlns:a="http://schemas.openxmlformats.org/drawingml/2006/main">
               <a:ext uri="{FF2B5EF4-FFF2-40B4-BE49-F238E27FC236}">
-                <a16:creationId xmlns:a16="http://schemas.microsoft.com/office/drawing/2014/main" id="{4BE5DD4D-596C-43CD-9E9F-2477F779108D}"/>
+                <a16:creationId xmlns:a16="http://schemas.microsoft.com/office/drawing/2014/main" id="{D479E14C-35A7-4C8C-B912-666C8BB4F431}"/>
               </a:ext>
             </a:extLst>
           </p:cNvPr>
@@ -2114,7 +2114,7 @@
           <p:cNvPr id="14" name="">
             <a:extLst xmlns:a="http://schemas.openxmlformats.org/drawingml/2006/main">
               <a:ext uri="{FF2B5EF4-FFF2-40B4-BE49-F238E27FC236}">
-                <a16:creationId xmlns:a16="http://schemas.microsoft.com/office/drawing/2014/main" id="{CD647E5C-83DB-49C1-8C33-FCE7FCF52B0B}"/>
+                <a16:creationId xmlns:a16="http://schemas.microsoft.com/office/drawing/2014/main" id="{55AC70B3-CB85-4E3F-BC2F-74ABD1B748A5}"/>
               </a:ext>
             </a:extLst>
           </p:cNvPr>
@@ -2149,7 +2149,7 @@
           <p:cNvPr id="15" name="">
             <a:extLst xmlns:a="http://schemas.openxmlformats.org/drawingml/2006/main">
               <a:ext uri="{FF2B5EF4-FFF2-40B4-BE49-F238E27FC236}">
-                <a16:creationId xmlns:a16="http://schemas.microsoft.com/office/drawing/2014/main" id="{A6419A76-F700-4C2E-B0D9-A7A017D550DA}"/>
+                <a16:creationId xmlns:a16="http://schemas.microsoft.com/office/drawing/2014/main" id="{8C50D812-89D3-4E27-8D16-2983721B1A29}"/>
               </a:ext>
             </a:extLst>
           </p:cNvPr>
@@ -2184,7 +2184,7 @@
           <p:cNvPr id="16" name="">
             <a:extLst xmlns:a="http://schemas.openxmlformats.org/drawingml/2006/main">
               <a:ext uri="{FF2B5EF4-FFF2-40B4-BE49-F238E27FC236}">
-                <a16:creationId xmlns:a16="http://schemas.microsoft.com/office/drawing/2014/main" id="{070443B3-EEB9-4802-BD54-308801A0B49E}"/>
+                <a16:creationId xmlns:a16="http://schemas.microsoft.com/office/drawing/2014/main" id="{9B837D7E-837C-4FB6-BDA6-CEA9D8C50B87}"/>
               </a:ext>
             </a:extLst>
           </p:cNvPr>
@@ -2235,7 +2235,7 @@
           <p:cNvPr id="17" name="">
             <a:extLst xmlns:a="http://schemas.openxmlformats.org/drawingml/2006/main">
               <a:ext uri="{FF2B5EF4-FFF2-40B4-BE49-F238E27FC236}">
-                <a16:creationId xmlns:a16="http://schemas.microsoft.com/office/drawing/2014/main" id="{FC7A8385-6469-42BA-88B0-EA5C82911ADA}"/>
+                <a16:creationId xmlns:a16="http://schemas.microsoft.com/office/drawing/2014/main" id="{61FA2509-1912-4E8E-BBC6-BACF3335AB1B}"/>
               </a:ext>
             </a:extLst>
           </p:cNvPr>
@@ -2284,7 +2284,7 @@
     </p:spTree>
     <p:extLst>
       <p:ext uri="{BB962C8B-B14F-4D97-AF65-F5344CB8AC3E}">
-        <p14:creationId xmlns:p14="http://schemas.microsoft.com/office/powerpoint/2010/main" val="1445099010"/>
+        <p14:creationId xmlns:p14="http://schemas.microsoft.com/office/powerpoint/2010/main" val="640480104"/>
       </p:ext>
     </p:extLst>
   </p:cSld>
@@ -2308,7 +2308,7 @@
           <p:cNvPr id="1" name="Slide Number Placeholder 5">
             <a:extLst xmlns:a="http://schemas.openxmlformats.org/drawingml/2006/main">
               <a:ext uri="{FF2B5EF4-FFF2-40B4-BE49-F238E27FC236}">
-                <a16:creationId xmlns:a16="http://schemas.microsoft.com/office/drawing/2014/main" id="{A4FB032A-3EC5-473E-95EF-14E6ABFA23A7}"/>
+                <a16:creationId xmlns:a16="http://schemas.microsoft.com/office/drawing/2014/main" id="{2ABBF3EC-52F3-4D5D-88DE-CE0FBD0B3A4D}"/>
               </a:ext>
             </a:extLst>
           </p:cNvPr>
@@ -2340,7 +2340,7 @@
           <p:cNvPr id="2" name="">
             <a:extLst xmlns:a="http://schemas.openxmlformats.org/drawingml/2006/main">
               <a:ext uri="{FF2B5EF4-FFF2-40B4-BE49-F238E27FC236}">
-                <a16:creationId xmlns:a16="http://schemas.microsoft.com/office/drawing/2014/main" id="{DF73B052-E88D-4DF9-A6D8-E810DBFF2983}"/>
+                <a16:creationId xmlns:a16="http://schemas.microsoft.com/office/drawing/2014/main" id="{D4DFCE2E-3724-44E1-BC7A-D85DA922801F}"/>
               </a:ext>
             </a:extLst>
           </p:cNvPr>
@@ -2373,7 +2373,7 @@
           <p:cNvPr id="3" name="">
             <a:extLst xmlns:a="http://schemas.openxmlformats.org/drawingml/2006/main">
               <a:ext uri="{FF2B5EF4-FFF2-40B4-BE49-F238E27FC236}">
-                <a16:creationId xmlns:a16="http://schemas.microsoft.com/office/drawing/2014/main" id="{7B105DE8-DF01-4EFF-A9BD-1ED9C9A8C972}"/>
+                <a16:creationId xmlns:a16="http://schemas.microsoft.com/office/drawing/2014/main" id="{0A24785C-9FA7-465A-8C5B-4964DBEF0443}"/>
               </a:ext>
             </a:extLst>
           </p:cNvPr>
@@ -2406,7 +2406,7 @@
           <p:cNvPr id="4" name="">
             <a:extLst xmlns:a="http://schemas.openxmlformats.org/drawingml/2006/main">
               <a:ext uri="{FF2B5EF4-FFF2-40B4-BE49-F238E27FC236}">
-                <a16:creationId xmlns:a16="http://schemas.microsoft.com/office/drawing/2014/main" id="{413A60B1-17F5-4AED-A125-D44F73B66F3B}"/>
+                <a16:creationId xmlns:a16="http://schemas.microsoft.com/office/drawing/2014/main" id="{8E27683B-0761-4886-98C9-EC98E73E1942}"/>
               </a:ext>
             </a:extLst>
           </p:cNvPr>
@@ -2457,7 +2457,7 @@
           <p:cNvPr id="5" name="">
             <a:extLst xmlns:a="http://schemas.openxmlformats.org/drawingml/2006/main">
               <a:ext uri="{FF2B5EF4-FFF2-40B4-BE49-F238E27FC236}">
-                <a16:creationId xmlns:a16="http://schemas.microsoft.com/office/drawing/2014/main" id="{3F87070D-F4FA-4012-8821-F87F601FD418}"/>
+                <a16:creationId xmlns:a16="http://schemas.microsoft.com/office/drawing/2014/main" id="{2524F808-A827-43AF-BB47-6B0F74ED82A3}"/>
               </a:ext>
             </a:extLst>
           </p:cNvPr>
@@ -2492,7 +2492,7 @@
           <p:cNvPr id="6" name="">
             <a:extLst xmlns:a="http://schemas.openxmlformats.org/drawingml/2006/main">
               <a:ext uri="{FF2B5EF4-FFF2-40B4-BE49-F238E27FC236}">
-                <a16:creationId xmlns:a16="http://schemas.microsoft.com/office/drawing/2014/main" id="{6D65AA1A-64BC-45A9-8B8E-BD71E11C436A}"/>
+                <a16:creationId xmlns:a16="http://schemas.microsoft.com/office/drawing/2014/main" id="{A5BD9FF0-BFC7-48E4-9181-8E646854530D}"/>
               </a:ext>
             </a:extLst>
           </p:cNvPr>
@@ -2527,7 +2527,7 @@
           <p:cNvPr id="7" name="">
             <a:extLst xmlns:a="http://schemas.openxmlformats.org/drawingml/2006/main">
               <a:ext uri="{FF2B5EF4-FFF2-40B4-BE49-F238E27FC236}">
-                <a16:creationId xmlns:a16="http://schemas.microsoft.com/office/drawing/2014/main" id="{126A7142-3A3D-4DE8-B29D-FD170BBBD5A1}"/>
+                <a16:creationId xmlns:a16="http://schemas.microsoft.com/office/drawing/2014/main" id="{ED806B7B-1241-4D04-B293-2D1E99784498}"/>
               </a:ext>
             </a:extLst>
           </p:cNvPr>
@@ -2578,7 +2578,7 @@
           <p:cNvPr id="8" name="">
             <a:extLst xmlns:a="http://schemas.openxmlformats.org/drawingml/2006/main">
               <a:ext uri="{FF2B5EF4-FFF2-40B4-BE49-F238E27FC236}">
-                <a16:creationId xmlns:a16="http://schemas.microsoft.com/office/drawing/2014/main" id="{F811AF18-204A-425B-99D3-402B4AC3160F}"/>
+                <a16:creationId xmlns:a16="http://schemas.microsoft.com/office/drawing/2014/main" id="{F543B42C-732F-461A-855D-933A248D0C49}"/>
               </a:ext>
             </a:extLst>
           </p:cNvPr>
@@ -2629,7 +2629,7 @@
           <p:cNvPr id="9" name="">
             <a:extLst xmlns:a="http://schemas.openxmlformats.org/drawingml/2006/main">
               <a:ext uri="{FF2B5EF4-FFF2-40B4-BE49-F238E27FC236}">
-                <a16:creationId xmlns:a16="http://schemas.microsoft.com/office/drawing/2014/main" id="{CFF4BF3E-58EC-4FB8-9B52-179480001A00}"/>
+                <a16:creationId xmlns:a16="http://schemas.microsoft.com/office/drawing/2014/main" id="{2D3F36DA-0486-42BC-93E0-E41CAC84167B}"/>
               </a:ext>
             </a:extLst>
           </p:cNvPr>
@@ -2664,7 +2664,7 @@
           <p:cNvPr id="10" name="">
             <a:extLst xmlns:a="http://schemas.openxmlformats.org/drawingml/2006/main">
               <a:ext uri="{FF2B5EF4-FFF2-40B4-BE49-F238E27FC236}">
-                <a16:creationId xmlns:a16="http://schemas.microsoft.com/office/drawing/2014/main" id="{E1947D15-E960-455E-A366-2A5E9394158A}"/>
+                <a16:creationId xmlns:a16="http://schemas.microsoft.com/office/drawing/2014/main" id="{27691D16-547C-4D62-A758-DF7CEC79AE9A}"/>
               </a:ext>
             </a:extLst>
           </p:cNvPr>
@@ -2699,7 +2699,7 @@
           <p:cNvPr id="11" name="">
             <a:extLst xmlns:a="http://schemas.openxmlformats.org/drawingml/2006/main">
               <a:ext uri="{FF2B5EF4-FFF2-40B4-BE49-F238E27FC236}">
-                <a16:creationId xmlns:a16="http://schemas.microsoft.com/office/drawing/2014/main" id="{34B66A90-8F0F-4783-9A4F-BC945C5FE65C}"/>
+                <a16:creationId xmlns:a16="http://schemas.microsoft.com/office/drawing/2014/main" id="{993B566C-08BC-4799-85E8-252F7C464836}"/>
               </a:ext>
             </a:extLst>
           </p:cNvPr>
@@ -2750,7 +2750,7 @@
           <p:cNvPr id="12" name="">
             <a:extLst xmlns:a="http://schemas.openxmlformats.org/drawingml/2006/main">
               <a:ext uri="{FF2B5EF4-FFF2-40B4-BE49-F238E27FC236}">
-                <a16:creationId xmlns:a16="http://schemas.microsoft.com/office/drawing/2014/main" id="{1B8A557A-90D5-4F97-B8AC-2B05DDA75BDF}"/>
+                <a16:creationId xmlns:a16="http://schemas.microsoft.com/office/drawing/2014/main" id="{0DE75597-6C3F-47FE-AF69-1774B3BE21F8}"/>
               </a:ext>
             </a:extLst>
           </p:cNvPr>
@@ -2801,7 +2801,7 @@
           <p:cNvPr id="13" name="">
             <a:extLst xmlns:a="http://schemas.openxmlformats.org/drawingml/2006/main">
               <a:ext uri="{FF2B5EF4-FFF2-40B4-BE49-F238E27FC236}">
-                <a16:creationId xmlns:a16="http://schemas.microsoft.com/office/drawing/2014/main" id="{CC6D2C2B-8FCF-40BC-93D6-56EEBCFFDFC9}"/>
+                <a16:creationId xmlns:a16="http://schemas.microsoft.com/office/drawing/2014/main" id="{D11DA134-DF8A-4CBD-A40D-96C81DFFCCD0}"/>
               </a:ext>
             </a:extLst>
           </p:cNvPr>
@@ -2836,7 +2836,7 @@
           <p:cNvPr id="14" name="">
             <a:extLst xmlns:a="http://schemas.openxmlformats.org/drawingml/2006/main">
               <a:ext uri="{FF2B5EF4-FFF2-40B4-BE49-F238E27FC236}">
-                <a16:creationId xmlns:a16="http://schemas.microsoft.com/office/drawing/2014/main" id="{96A5870D-CDF6-494B-AF35-23A93AD6039B}"/>
+                <a16:creationId xmlns:a16="http://schemas.microsoft.com/office/drawing/2014/main" id="{B06AFF12-B800-4E47-807B-D36B2AF1E8EC}"/>
               </a:ext>
             </a:extLst>
           </p:cNvPr>
@@ -2871,7 +2871,7 @@
           <p:cNvPr id="15" name="">
             <a:extLst xmlns:a="http://schemas.openxmlformats.org/drawingml/2006/main">
               <a:ext uri="{FF2B5EF4-FFF2-40B4-BE49-F238E27FC236}">
-                <a16:creationId xmlns:a16="http://schemas.microsoft.com/office/drawing/2014/main" id="{E12AF900-B53F-47BF-BE81-D0A0B4F46B7C}"/>
+                <a16:creationId xmlns:a16="http://schemas.microsoft.com/office/drawing/2014/main" id="{3FAFE327-015D-45B7-9D1D-BF1EB04F6DCC}"/>
               </a:ext>
             </a:extLst>
           </p:cNvPr>
@@ -2922,7 +2922,7 @@
           <p:cNvPr id="16" name="">
             <a:extLst xmlns:a="http://schemas.openxmlformats.org/drawingml/2006/main">
               <a:ext uri="{FF2B5EF4-FFF2-40B4-BE49-F238E27FC236}">
-                <a16:creationId xmlns:a16="http://schemas.microsoft.com/office/drawing/2014/main" id="{6EA6F88D-010A-46BC-91EA-02195484E055}"/>
+                <a16:creationId xmlns:a16="http://schemas.microsoft.com/office/drawing/2014/main" id="{BE9A8CCE-6847-4C2C-A5FE-273562FF9C8B}"/>
               </a:ext>
             </a:extLst>
           </p:cNvPr>
@@ -2973,7 +2973,7 @@
           <p:cNvPr id="17" name="">
             <a:extLst xmlns:a="http://schemas.openxmlformats.org/drawingml/2006/main">
               <a:ext uri="{FF2B5EF4-FFF2-40B4-BE49-F238E27FC236}">
-                <a16:creationId xmlns:a16="http://schemas.microsoft.com/office/drawing/2014/main" id="{61EBD488-04A3-4D1D-98E4-AE956DEAFB9D}"/>
+                <a16:creationId xmlns:a16="http://schemas.microsoft.com/office/drawing/2014/main" id="{4A702563-836E-4B4D-BC24-5A24C3374954}"/>
               </a:ext>
             </a:extLst>
           </p:cNvPr>
@@ -3008,7 +3008,7 @@
           <p:cNvPr id="18" name="">
             <a:extLst xmlns:a="http://schemas.openxmlformats.org/drawingml/2006/main">
               <a:ext uri="{FF2B5EF4-FFF2-40B4-BE49-F238E27FC236}">
-                <a16:creationId xmlns:a16="http://schemas.microsoft.com/office/drawing/2014/main" id="{F6294C5D-CC18-4810-A550-5B658F0203C4}"/>
+                <a16:creationId xmlns:a16="http://schemas.microsoft.com/office/drawing/2014/main" id="{BE5FB15A-7A23-4BF7-8A45-7CDEE75934A3}"/>
               </a:ext>
             </a:extLst>
           </p:cNvPr>
@@ -3043,7 +3043,7 @@
           <p:cNvPr id="19" name="">
             <a:extLst xmlns:a="http://schemas.openxmlformats.org/drawingml/2006/main">
               <a:ext uri="{FF2B5EF4-FFF2-40B4-BE49-F238E27FC236}">
-                <a16:creationId xmlns:a16="http://schemas.microsoft.com/office/drawing/2014/main" id="{B3DE43EC-E9C4-45D0-BA6D-9684EC6C69B8}"/>
+                <a16:creationId xmlns:a16="http://schemas.microsoft.com/office/drawing/2014/main" id="{4F8F5F0E-61D3-410A-8389-34BADBBAD868}"/>
               </a:ext>
             </a:extLst>
           </p:cNvPr>
@@ -3094,7 +3094,7 @@
           <p:cNvPr id="20" name="">
             <a:extLst xmlns:a="http://schemas.openxmlformats.org/drawingml/2006/main">
               <a:ext uri="{FF2B5EF4-FFF2-40B4-BE49-F238E27FC236}">
-                <a16:creationId xmlns:a16="http://schemas.microsoft.com/office/drawing/2014/main" id="{5408BB35-82C6-4AE1-B252-4A69B23FDC1B}"/>
+                <a16:creationId xmlns:a16="http://schemas.microsoft.com/office/drawing/2014/main" id="{84D763A5-8997-443E-809D-E6B0A3919FD5}"/>
               </a:ext>
             </a:extLst>
           </p:cNvPr>
@@ -3145,7 +3145,7 @@
           <p:cNvPr id="21" name="">
             <a:extLst xmlns:a="http://schemas.openxmlformats.org/drawingml/2006/main">
               <a:ext uri="{FF2B5EF4-FFF2-40B4-BE49-F238E27FC236}">
-                <a16:creationId xmlns:a16="http://schemas.microsoft.com/office/drawing/2014/main" id="{8B9692B0-BB7F-4A5C-983C-54BEF1B6E1A7}"/>
+                <a16:creationId xmlns:a16="http://schemas.microsoft.com/office/drawing/2014/main" id="{304CB18B-5DBC-4CD6-B25C-F27FC1FF959D}"/>
               </a:ext>
             </a:extLst>
           </p:cNvPr>
@@ -3180,7 +3180,7 @@
           <p:cNvPr id="22" name="">
             <a:extLst xmlns:a="http://schemas.openxmlformats.org/drawingml/2006/main">
               <a:ext uri="{FF2B5EF4-FFF2-40B4-BE49-F238E27FC236}">
-                <a16:creationId xmlns:a16="http://schemas.microsoft.com/office/drawing/2014/main" id="{73A3228E-FCF2-4306-95C9-70D22202C309}"/>
+                <a16:creationId xmlns:a16="http://schemas.microsoft.com/office/drawing/2014/main" id="{4E76B144-DB45-4AFD-873D-440414C84EDF}"/>
               </a:ext>
             </a:extLst>
           </p:cNvPr>
@@ -3215,7 +3215,7 @@
           <p:cNvPr id="23" name="">
             <a:extLst xmlns:a="http://schemas.openxmlformats.org/drawingml/2006/main">
               <a:ext uri="{FF2B5EF4-FFF2-40B4-BE49-F238E27FC236}">
-                <a16:creationId xmlns:a16="http://schemas.microsoft.com/office/drawing/2014/main" id="{82A01028-01DB-43C1-8DE3-33D4C39C8113}"/>
+                <a16:creationId xmlns:a16="http://schemas.microsoft.com/office/drawing/2014/main" id="{09BB6D1C-8D73-4415-B1AF-675E65CBA460}"/>
               </a:ext>
             </a:extLst>
           </p:cNvPr>
@@ -3266,7 +3266,7 @@
           <p:cNvPr id="24" name="">
             <a:extLst xmlns:a="http://schemas.openxmlformats.org/drawingml/2006/main">
               <a:ext uri="{FF2B5EF4-FFF2-40B4-BE49-F238E27FC236}">
-                <a16:creationId xmlns:a16="http://schemas.microsoft.com/office/drawing/2014/main" id="{0F708AE5-6679-4478-94CE-AAB99135E3E7}"/>
+                <a16:creationId xmlns:a16="http://schemas.microsoft.com/office/drawing/2014/main" id="{34530B0E-12BB-4387-A358-AF7B2EA3E3CB}"/>
               </a:ext>
             </a:extLst>
           </p:cNvPr>
@@ -3315,7 +3315,7 @@
     </p:spTree>
     <p:extLst>
       <p:ext uri="{BB962C8B-B14F-4D97-AF65-F5344CB8AC3E}">
-        <p14:creationId xmlns:p14="http://schemas.microsoft.com/office/powerpoint/2010/main" val="538692199"/>
+        <p14:creationId xmlns:p14="http://schemas.microsoft.com/office/powerpoint/2010/main" val="1552077176"/>
       </p:ext>
     </p:extLst>
   </p:cSld>
@@ -3339,7 +3339,7 @@
           <p:cNvPr id="1" name="Slide Number Placeholder 5">
             <a:extLst xmlns:a="http://schemas.openxmlformats.org/drawingml/2006/main">
               <a:ext uri="{FF2B5EF4-FFF2-40B4-BE49-F238E27FC236}">
-                <a16:creationId xmlns:a16="http://schemas.microsoft.com/office/drawing/2014/main" id="{A4FB032A-3EC5-473E-95EF-14E6ABFA23A7}"/>
+                <a16:creationId xmlns:a16="http://schemas.microsoft.com/office/drawing/2014/main" id="{2ABBF3EC-52F3-4D5D-88DE-CE0FBD0B3A4D}"/>
               </a:ext>
             </a:extLst>
           </p:cNvPr>
@@ -3371,7 +3371,7 @@
           <p:cNvPr id="2" name="">
             <a:extLst xmlns:a="http://schemas.openxmlformats.org/drawingml/2006/main">
               <a:ext uri="{FF2B5EF4-FFF2-40B4-BE49-F238E27FC236}">
-                <a16:creationId xmlns:a16="http://schemas.microsoft.com/office/drawing/2014/main" id="{03AE577D-F238-4673-B236-CCCAE0F88B05}"/>
+                <a16:creationId xmlns:a16="http://schemas.microsoft.com/office/drawing/2014/main" id="{7DF89A35-985D-4670-989F-424C9C5531D5}"/>
               </a:ext>
             </a:extLst>
           </p:cNvPr>
@@ -3404,7 +3404,7 @@
           <p:cNvPr id="3" name="">
             <a:extLst xmlns:a="http://schemas.openxmlformats.org/drawingml/2006/main">
               <a:ext uri="{FF2B5EF4-FFF2-40B4-BE49-F238E27FC236}">
-                <a16:creationId xmlns:a16="http://schemas.microsoft.com/office/drawing/2014/main" id="{B57326A6-B8D2-4C1B-9D37-278E9BB11D03}"/>
+                <a16:creationId xmlns:a16="http://schemas.microsoft.com/office/drawing/2014/main" id="{15289DC0-64E1-45D2-9D67-66D718BE3915}"/>
               </a:ext>
             </a:extLst>
           </p:cNvPr>
@@ -3437,7 +3437,7 @@
           <p:cNvPr id="4" name="">
             <a:extLst xmlns:a="http://schemas.openxmlformats.org/drawingml/2006/main">
               <a:ext uri="{FF2B5EF4-FFF2-40B4-BE49-F238E27FC236}">
-                <a16:creationId xmlns:a16="http://schemas.microsoft.com/office/drawing/2014/main" id="{B2D19A3E-376F-4277-8D5F-623949CB288D}"/>
+                <a16:creationId xmlns:a16="http://schemas.microsoft.com/office/drawing/2014/main" id="{A5023F64-042B-4083-8808-66AEFC839512}"/>
               </a:ext>
             </a:extLst>
           </p:cNvPr>
@@ -3488,7 +3488,7 @@
           <p:cNvPr id="5" name="">
             <a:extLst xmlns:a="http://schemas.openxmlformats.org/drawingml/2006/main">
               <a:ext uri="{FF2B5EF4-FFF2-40B4-BE49-F238E27FC236}">
-                <a16:creationId xmlns:a16="http://schemas.microsoft.com/office/drawing/2014/main" id="{B11780BA-C77A-495C-84B1-900FB51F6C41}"/>
+                <a16:creationId xmlns:a16="http://schemas.microsoft.com/office/drawing/2014/main" id="{370D5128-0FA8-4B95-86FC-1F7E1D32EF6A}"/>
               </a:ext>
             </a:extLst>
           </p:cNvPr>
@@ -3523,7 +3523,7 @@
           <p:cNvPr id="6" name="">
             <a:extLst xmlns:a="http://schemas.openxmlformats.org/drawingml/2006/main">
               <a:ext uri="{FF2B5EF4-FFF2-40B4-BE49-F238E27FC236}">
-                <a16:creationId xmlns:a16="http://schemas.microsoft.com/office/drawing/2014/main" id="{5C4E048C-B149-4C98-9C88-98B578208728}"/>
+                <a16:creationId xmlns:a16="http://schemas.microsoft.com/office/drawing/2014/main" id="{5A276525-A5D5-4EF7-9E4B-EB8AA45BB2AF}"/>
               </a:ext>
             </a:extLst>
           </p:cNvPr>
@@ -3558,7 +3558,7 @@
           <p:cNvPr id="7" name="">
             <a:extLst xmlns:a="http://schemas.openxmlformats.org/drawingml/2006/main">
               <a:ext uri="{FF2B5EF4-FFF2-40B4-BE49-F238E27FC236}">
-                <a16:creationId xmlns:a16="http://schemas.microsoft.com/office/drawing/2014/main" id="{E94D249C-B2D1-435D-AD7B-229EAF94CDDD}"/>
+                <a16:creationId xmlns:a16="http://schemas.microsoft.com/office/drawing/2014/main" id="{5EDF14AF-B70C-416C-98CE-16E67607CFC0}"/>
               </a:ext>
             </a:extLst>
           </p:cNvPr>
@@ -3609,7 +3609,7 @@
           <p:cNvPr id="8" name="">
             <a:extLst xmlns:a="http://schemas.openxmlformats.org/drawingml/2006/main">
               <a:ext uri="{FF2B5EF4-FFF2-40B4-BE49-F238E27FC236}">
-                <a16:creationId xmlns:a16="http://schemas.microsoft.com/office/drawing/2014/main" id="{A49695D6-8D80-4C60-8A5E-22BFF40BE0D4}"/>
+                <a16:creationId xmlns:a16="http://schemas.microsoft.com/office/drawing/2014/main" id="{5299B1CC-187F-4E53-8B3F-EF7AE71608DE}"/>
               </a:ext>
             </a:extLst>
           </p:cNvPr>
@@ -3697,14 +3697,14 @@
         </p:xfrm>
         <a:graphic xmlns:a="http://schemas.openxmlformats.org/drawingml/2006/main">
           <a:graphicData uri="http://schemas.openxmlformats.org/drawingml/2006/chart">
-            <c:chart xmlns:r="http://schemas.openxmlformats.org/officeDocument/2006/relationships" xmlns:c="http://schemas.openxmlformats.org/drawingml/2006/chart" r:id="R6be9e9b7c7b140e4"/>
+            <c:chart xmlns:r="http://schemas.openxmlformats.org/officeDocument/2006/relationships" xmlns:c="http://schemas.openxmlformats.org/drawingml/2006/chart" r:id="R2daf45ea62114f47"/>
           </a:graphicData>
         </a:graphic>
       </p:graphicFrame>
     </p:spTree>
     <p:extLst>
       <p:ext uri="{BB962C8B-B14F-4D97-AF65-F5344CB8AC3E}">
-        <p14:creationId xmlns:p14="http://schemas.microsoft.com/office/powerpoint/2010/main" val="192582394"/>
+        <p14:creationId xmlns:p14="http://schemas.microsoft.com/office/powerpoint/2010/main" val="2043578373"/>
       </p:ext>
     </p:extLst>
   </p:cSld>
@@ -3728,7 +3728,7 @@
           <p:cNvPr id="1" name="Slide Number Placeholder 5">
             <a:extLst xmlns:a="http://schemas.openxmlformats.org/drawingml/2006/main">
               <a:ext uri="{FF2B5EF4-FFF2-40B4-BE49-F238E27FC236}">
-                <a16:creationId xmlns:a16="http://schemas.microsoft.com/office/drawing/2014/main" id="{A4FB032A-3EC5-473E-95EF-14E6ABFA23A7}"/>
+                <a16:creationId xmlns:a16="http://schemas.microsoft.com/office/drawing/2014/main" id="{2ABBF3EC-52F3-4D5D-88DE-CE0FBD0B3A4D}"/>
               </a:ext>
             </a:extLst>
           </p:cNvPr>
@@ -3760,7 +3760,7 @@
           <p:cNvPr id="2" name="">
             <a:extLst xmlns:a="http://schemas.openxmlformats.org/drawingml/2006/main">
               <a:ext uri="{FF2B5EF4-FFF2-40B4-BE49-F238E27FC236}">
-                <a16:creationId xmlns:a16="http://schemas.microsoft.com/office/drawing/2014/main" id="{FA8E15D1-1376-460D-92D3-AFB264E0C0E0}"/>
+                <a16:creationId xmlns:a16="http://schemas.microsoft.com/office/drawing/2014/main" id="{3F27A46D-54B4-4185-83FE-503D4F9B5EEB}"/>
               </a:ext>
             </a:extLst>
           </p:cNvPr>
@@ -3793,7 +3793,7 @@
           <p:cNvPr id="3" name="">
             <a:extLst xmlns:a="http://schemas.openxmlformats.org/drawingml/2006/main">
               <a:ext uri="{FF2B5EF4-FFF2-40B4-BE49-F238E27FC236}">
-                <a16:creationId xmlns:a16="http://schemas.microsoft.com/office/drawing/2014/main" id="{4691D657-4E11-4BA5-90DC-A84A8EF9DA9F}"/>
+                <a16:creationId xmlns:a16="http://schemas.microsoft.com/office/drawing/2014/main" id="{42A1DA23-EEC9-4CAE-98BA-692D58106576}"/>
               </a:ext>
             </a:extLst>
           </p:cNvPr>
@@ -3826,7 +3826,7 @@
           <p:cNvPr id="4" name="">
             <a:extLst xmlns:a="http://schemas.openxmlformats.org/drawingml/2006/main">
               <a:ext uri="{FF2B5EF4-FFF2-40B4-BE49-F238E27FC236}">
-                <a16:creationId xmlns:a16="http://schemas.microsoft.com/office/drawing/2014/main" id="{5EFA7EAD-A6E1-4DEA-B538-5068179B0C95}"/>
+                <a16:creationId xmlns:a16="http://schemas.microsoft.com/office/drawing/2014/main" id="{C36531FD-9415-48B6-AE97-705CB9398F86}"/>
               </a:ext>
             </a:extLst>
           </p:cNvPr>
@@ -3877,7 +3877,7 @@
           <p:cNvPr id="5" name="">
             <a:extLst xmlns:a="http://schemas.openxmlformats.org/drawingml/2006/main">
               <a:ext uri="{FF2B5EF4-FFF2-40B4-BE49-F238E27FC236}">
-                <a16:creationId xmlns:a16="http://schemas.microsoft.com/office/drawing/2014/main" id="{0617575F-0AAC-4B23-AAEA-145DC073AC20}"/>
+                <a16:creationId xmlns:a16="http://schemas.microsoft.com/office/drawing/2014/main" id="{1B112B12-E777-49DA-B459-76772FC72CEC}"/>
               </a:ext>
             </a:extLst>
           </p:cNvPr>
@@ -3912,7 +3912,7 @@
           <p:cNvPr id="6" name="">
             <a:extLst xmlns:a="http://schemas.openxmlformats.org/drawingml/2006/main">
               <a:ext uri="{FF2B5EF4-FFF2-40B4-BE49-F238E27FC236}">
-                <a16:creationId xmlns:a16="http://schemas.microsoft.com/office/drawing/2014/main" id="{9155FB5B-5498-4AE1-AEAD-233FC794A845}"/>
+                <a16:creationId xmlns:a16="http://schemas.microsoft.com/office/drawing/2014/main" id="{1BEE6D06-4803-436D-B2DA-20F227EECEC3}"/>
               </a:ext>
             </a:extLst>
           </p:cNvPr>
@@ -3947,7 +3947,7 @@
           <p:cNvPr id="7" name="">
             <a:extLst xmlns:a="http://schemas.openxmlformats.org/drawingml/2006/main">
               <a:ext uri="{FF2B5EF4-FFF2-40B4-BE49-F238E27FC236}">
-                <a16:creationId xmlns:a16="http://schemas.microsoft.com/office/drawing/2014/main" id="{414C9CCA-B4B6-47B0-9240-F4E8E4716E14}"/>
+                <a16:creationId xmlns:a16="http://schemas.microsoft.com/office/drawing/2014/main" id="{049A3634-FA94-4E1A-A6AC-F22C0FA46932}"/>
               </a:ext>
             </a:extLst>
           </p:cNvPr>
@@ -3998,7 +3998,7 @@
           <p:cNvPr id="8" name="">
             <a:extLst xmlns:a="http://schemas.openxmlformats.org/drawingml/2006/main">
               <a:ext uri="{FF2B5EF4-FFF2-40B4-BE49-F238E27FC236}">
-                <a16:creationId xmlns:a16="http://schemas.microsoft.com/office/drawing/2014/main" id="{D5E6F263-B6BF-4C5E-9BE4-DF34D24AA628}"/>
+                <a16:creationId xmlns:a16="http://schemas.microsoft.com/office/drawing/2014/main" id="{06BE58E4-860F-4228-8549-C61E2E15D201}"/>
               </a:ext>
             </a:extLst>
           </p:cNvPr>
@@ -4079,7 +4079,7 @@
           <p:cNvPr id="9" name="">
             <a:extLst xmlns:a="http://schemas.openxmlformats.org/drawingml/2006/main">
               <a:ext uri="{FF2B5EF4-FFF2-40B4-BE49-F238E27FC236}">
-                <a16:creationId xmlns:a16="http://schemas.microsoft.com/office/drawing/2014/main" id="{A4F75FE6-822C-4E4B-8798-36E462CBE62E}"/>
+                <a16:creationId xmlns:a16="http://schemas.microsoft.com/office/drawing/2014/main" id="{E461E575-C320-4D5B-A439-DEE7E54C8074}"/>
               </a:ext>
             </a:extLst>
           </p:cNvPr>
@@ -4114,7 +4114,7 @@
           <p:cNvPr id="10" name="">
             <a:extLst xmlns:a="http://schemas.openxmlformats.org/drawingml/2006/main">
               <a:ext uri="{FF2B5EF4-FFF2-40B4-BE49-F238E27FC236}">
-                <a16:creationId xmlns:a16="http://schemas.microsoft.com/office/drawing/2014/main" id="{254A0C08-0CB3-45B8-9011-F054B8D1B9D1}"/>
+                <a16:creationId xmlns:a16="http://schemas.microsoft.com/office/drawing/2014/main" id="{2B128BB1-0E5F-4800-B12F-13AE30F835F5}"/>
               </a:ext>
             </a:extLst>
           </p:cNvPr>
@@ -4149,7 +4149,7 @@
           <p:cNvPr id="11" name="">
             <a:extLst xmlns:a="http://schemas.openxmlformats.org/drawingml/2006/main">
               <a:ext uri="{FF2B5EF4-FFF2-40B4-BE49-F238E27FC236}">
-                <a16:creationId xmlns:a16="http://schemas.microsoft.com/office/drawing/2014/main" id="{09B8B8E7-5E04-44E2-B78B-FE245040602E}"/>
+                <a16:creationId xmlns:a16="http://schemas.microsoft.com/office/drawing/2014/main" id="{305C75F2-BE3F-4B3E-A81A-AF670790A5D7}"/>
               </a:ext>
             </a:extLst>
           </p:cNvPr>
@@ -4200,7 +4200,7 @@
           <p:cNvPr id="12" name="">
             <a:extLst xmlns:a="http://schemas.openxmlformats.org/drawingml/2006/main">
               <a:ext uri="{FF2B5EF4-FFF2-40B4-BE49-F238E27FC236}">
-                <a16:creationId xmlns:a16="http://schemas.microsoft.com/office/drawing/2014/main" id="{8EBDD53B-C6F3-4FCD-90B9-DDD33508083B}"/>
+                <a16:creationId xmlns:a16="http://schemas.microsoft.com/office/drawing/2014/main" id="{D6971E39-D559-4D91-9095-C133A8343734}"/>
               </a:ext>
             </a:extLst>
           </p:cNvPr>
@@ -4279,7 +4279,7 @@
     </p:spTree>
     <p:extLst>
       <p:ext uri="{BB962C8B-B14F-4D97-AF65-F5344CB8AC3E}">
-        <p14:creationId xmlns:p14="http://schemas.microsoft.com/office/powerpoint/2010/main" val="798786057"/>
+        <p14:creationId xmlns:p14="http://schemas.microsoft.com/office/powerpoint/2010/main" val="1889012906"/>
       </p:ext>
     </p:extLst>
   </p:cSld>
@@ -4303,7 +4303,7 @@
           <p:cNvPr id="1" name="Slide Number Placeholder 5">
             <a:extLst xmlns:a="http://schemas.openxmlformats.org/drawingml/2006/main">
               <a:ext uri="{FF2B5EF4-FFF2-40B4-BE49-F238E27FC236}">
-                <a16:creationId xmlns:a16="http://schemas.microsoft.com/office/drawing/2014/main" id="{A4FB032A-3EC5-473E-95EF-14E6ABFA23A7}"/>
+                <a16:creationId xmlns:a16="http://schemas.microsoft.com/office/drawing/2014/main" id="{2ABBF3EC-52F3-4D5D-88DE-CE0FBD0B3A4D}"/>
               </a:ext>
             </a:extLst>
           </p:cNvPr>
@@ -4335,7 +4335,7 @@
           <p:cNvPr id="2" name="">
             <a:extLst xmlns:a="http://schemas.openxmlformats.org/drawingml/2006/main">
               <a:ext uri="{FF2B5EF4-FFF2-40B4-BE49-F238E27FC236}">
-                <a16:creationId xmlns:a16="http://schemas.microsoft.com/office/drawing/2014/main" id="{7AAED019-709A-4BBC-8499-F58C0F87D350}"/>
+                <a16:creationId xmlns:a16="http://schemas.microsoft.com/office/drawing/2014/main" id="{2032E1FA-D343-4053-B273-33DCC393200D}"/>
               </a:ext>
             </a:extLst>
           </p:cNvPr>
@@ -4368,7 +4368,7 @@
           <p:cNvPr id="3" name="">
             <a:extLst xmlns:a="http://schemas.openxmlformats.org/drawingml/2006/main">
               <a:ext uri="{FF2B5EF4-FFF2-40B4-BE49-F238E27FC236}">
-                <a16:creationId xmlns:a16="http://schemas.microsoft.com/office/drawing/2014/main" id="{E7D51792-71CC-427A-ABAA-4ABC74151E94}"/>
+                <a16:creationId xmlns:a16="http://schemas.microsoft.com/office/drawing/2014/main" id="{AEF8E1AD-0027-441C-9EB2-8C498C27048B}"/>
               </a:ext>
             </a:extLst>
           </p:cNvPr>
@@ -4401,7 +4401,7 @@
           <p:cNvPr id="4" name="">
             <a:extLst xmlns:a="http://schemas.openxmlformats.org/drawingml/2006/main">
               <a:ext uri="{FF2B5EF4-FFF2-40B4-BE49-F238E27FC236}">
-                <a16:creationId xmlns:a16="http://schemas.microsoft.com/office/drawing/2014/main" id="{31FC8B3F-F069-426A-9C25-A630C5181083}"/>
+                <a16:creationId xmlns:a16="http://schemas.microsoft.com/office/drawing/2014/main" id="{1E2280F4-7D4D-43E1-BDEB-4A5662AAA98E}"/>
               </a:ext>
             </a:extLst>
           </p:cNvPr>
@@ -4452,7 +4452,7 @@
           <p:cNvPr id="5" name="">
             <a:extLst xmlns:a="http://schemas.openxmlformats.org/drawingml/2006/main">
               <a:ext uri="{FF2B5EF4-FFF2-40B4-BE49-F238E27FC236}">
-                <a16:creationId xmlns:a16="http://schemas.microsoft.com/office/drawing/2014/main" id="{97C8F495-7FA0-4E6B-AA78-1C49A01C5870}"/>
+                <a16:creationId xmlns:a16="http://schemas.microsoft.com/office/drawing/2014/main" id="{2C700C52-5206-40BF-810D-E9FA9BD55892}"/>
               </a:ext>
             </a:extLst>
           </p:cNvPr>
@@ -4487,7 +4487,7 @@
           <p:cNvPr id="6" name="">
             <a:extLst xmlns:a="http://schemas.openxmlformats.org/drawingml/2006/main">
               <a:ext uri="{FF2B5EF4-FFF2-40B4-BE49-F238E27FC236}">
-                <a16:creationId xmlns:a16="http://schemas.microsoft.com/office/drawing/2014/main" id="{91D25DF5-9815-4AF9-9170-68DC786D4505}"/>
+                <a16:creationId xmlns:a16="http://schemas.microsoft.com/office/drawing/2014/main" id="{A3D9F26E-1577-4D31-95A2-5F79EE084705}"/>
               </a:ext>
             </a:extLst>
           </p:cNvPr>
@@ -4522,7 +4522,7 @@
           <p:cNvPr id="7" name="">
             <a:extLst xmlns:a="http://schemas.openxmlformats.org/drawingml/2006/main">
               <a:ext uri="{FF2B5EF4-FFF2-40B4-BE49-F238E27FC236}">
-                <a16:creationId xmlns:a16="http://schemas.microsoft.com/office/drawing/2014/main" id="{0AB0CAC0-A757-485C-97CF-C5CB8D9A91B5}"/>
+                <a16:creationId xmlns:a16="http://schemas.microsoft.com/office/drawing/2014/main" id="{4C0E209A-E9E3-4E78-AAB7-290946D24E09}"/>
               </a:ext>
             </a:extLst>
           </p:cNvPr>
@@ -4573,7 +4573,7 @@
           <p:cNvPr id="8" name="">
             <a:extLst xmlns:a="http://schemas.openxmlformats.org/drawingml/2006/main">
               <a:ext uri="{FF2B5EF4-FFF2-40B4-BE49-F238E27FC236}">
-                <a16:creationId xmlns:a16="http://schemas.microsoft.com/office/drawing/2014/main" id="{7E22FD77-BDD7-48DE-86FD-F727DEDA1E00}"/>
+                <a16:creationId xmlns:a16="http://schemas.microsoft.com/office/drawing/2014/main" id="{94BD946C-CF7D-4849-99AF-47378B2ADCCD}"/>
               </a:ext>
             </a:extLst>
           </p:cNvPr>
@@ -4669,7 +4669,7 @@
           <p:cNvPr id="9" name="">
             <a:extLst xmlns:a="http://schemas.openxmlformats.org/drawingml/2006/main">
               <a:ext uri="{FF2B5EF4-FFF2-40B4-BE49-F238E27FC236}">
-                <a16:creationId xmlns:a16="http://schemas.microsoft.com/office/drawing/2014/main" id="{DC359527-34F7-4753-8825-9175C27C9358}"/>
+                <a16:creationId xmlns:a16="http://schemas.microsoft.com/office/drawing/2014/main" id="{7AA1977D-13E5-410D-BDDF-E7CD85418012}"/>
               </a:ext>
             </a:extLst>
           </p:cNvPr>
@@ -4704,7 +4704,7 @@
           <p:cNvPr id="10" name="">
             <a:extLst xmlns:a="http://schemas.openxmlformats.org/drawingml/2006/main">
               <a:ext uri="{FF2B5EF4-FFF2-40B4-BE49-F238E27FC236}">
-                <a16:creationId xmlns:a16="http://schemas.microsoft.com/office/drawing/2014/main" id="{9DF7C254-AF54-4837-B416-9D4AAD4ACBB6}"/>
+                <a16:creationId xmlns:a16="http://schemas.microsoft.com/office/drawing/2014/main" id="{7CDE0BFF-928E-4FF4-A091-BA87FBE2A7A2}"/>
               </a:ext>
             </a:extLst>
           </p:cNvPr>
@@ -4739,7 +4739,7 @@
           <p:cNvPr id="11" name="">
             <a:extLst xmlns:a="http://schemas.openxmlformats.org/drawingml/2006/main">
               <a:ext uri="{FF2B5EF4-FFF2-40B4-BE49-F238E27FC236}">
-                <a16:creationId xmlns:a16="http://schemas.microsoft.com/office/drawing/2014/main" id="{D2629878-F73D-4556-A5D9-C02D5E8CA110}"/>
+                <a16:creationId xmlns:a16="http://schemas.microsoft.com/office/drawing/2014/main" id="{3C4DD9B1-CDEE-48FC-972B-02D08B3EE36C}"/>
               </a:ext>
             </a:extLst>
           </p:cNvPr>
@@ -4790,7 +4790,7 @@
           <p:cNvPr id="12" name="">
             <a:extLst xmlns:a="http://schemas.openxmlformats.org/drawingml/2006/main">
               <a:ext uri="{FF2B5EF4-FFF2-40B4-BE49-F238E27FC236}">
-                <a16:creationId xmlns:a16="http://schemas.microsoft.com/office/drawing/2014/main" id="{5AB8D10C-C3D6-4241-8B40-55AB3488AE45}"/>
+                <a16:creationId xmlns:a16="http://schemas.microsoft.com/office/drawing/2014/main" id="{80A36D49-6559-4FEC-B95E-51D23BDCD8C7}"/>
               </a:ext>
             </a:extLst>
           </p:cNvPr>
@@ -4869,7 +4869,7 @@
     </p:spTree>
     <p:extLst>
       <p:ext uri="{BB962C8B-B14F-4D97-AF65-F5344CB8AC3E}">
-        <p14:creationId xmlns:p14="http://schemas.microsoft.com/office/powerpoint/2010/main" val="1679256193"/>
+        <p14:creationId xmlns:p14="http://schemas.microsoft.com/office/powerpoint/2010/main" val="311834423"/>
       </p:ext>
     </p:extLst>
   </p:cSld>

</xml_diff>

<commit_message>
Tighten live Slack filtering for executive briefing
</commit_message>
<xml_diff>
--- a/outputs/executive-briefing-machine-demo/executive-briefing-demo.pptx
+++ b/outputs/executive-briefing-machine-demo/executive-briefing-demo.pptx
@@ -2,17 +2,17 @@
 <file path=ppt/presentation.xml><?xml version="1.0" encoding="utf-8"?>
 <p:presentation xmlns:p="http://schemas.openxmlformats.org/presentationml/2006/main">
   <p:sldMasterIdLst>
-    <p:sldMasterId xmlns:r="http://schemas.openxmlformats.org/officeDocument/2006/relationships" id="2147483648" r:id="Raa382a26039643e7"/>
+    <p:sldMasterId xmlns:r="http://schemas.openxmlformats.org/officeDocument/2006/relationships" id="2147483648" r:id="Rc5e98b62e3a444f1"/>
   </p:sldMasterIdLst>
   <p:notesMasterIdLst>
-    <p:notesMasterId xmlns:r="http://schemas.openxmlformats.org/officeDocument/2006/relationships" r:id="R601971fe2c7944ae"/>
+    <p:notesMasterId xmlns:r="http://schemas.openxmlformats.org/officeDocument/2006/relationships" r:id="R61be6e33ef274d91"/>
   </p:notesMasterIdLst>
   <p:sldIdLst>
-    <p:sldId xmlns:r="http://schemas.openxmlformats.org/officeDocument/2006/relationships" id="256" r:id="R1cf1ed61b2684339"/>
-    <p:sldId xmlns:r="http://schemas.openxmlformats.org/officeDocument/2006/relationships" id="257" r:id="R7507bc7f04cb4a11"/>
-    <p:sldId xmlns:r="http://schemas.openxmlformats.org/officeDocument/2006/relationships" id="258" r:id="R341532d5546c4f1a"/>
-    <p:sldId xmlns:r="http://schemas.openxmlformats.org/officeDocument/2006/relationships" id="259" r:id="Ra5ba41cc9ba84407"/>
-    <p:sldId xmlns:r="http://schemas.openxmlformats.org/officeDocument/2006/relationships" id="260" r:id="Rd4cdfb3e36aa4181"/>
+    <p:sldId xmlns:r="http://schemas.openxmlformats.org/officeDocument/2006/relationships" id="256" r:id="R1a99382a53274223"/>
+    <p:sldId xmlns:r="http://schemas.openxmlformats.org/officeDocument/2006/relationships" id="257" r:id="Ree40299b1e8d42dd"/>
+    <p:sldId xmlns:r="http://schemas.openxmlformats.org/officeDocument/2006/relationships" id="258" r:id="R96f57896eb434e6a"/>
+    <p:sldId xmlns:r="http://schemas.openxmlformats.org/officeDocument/2006/relationships" id="259" r:id="R959904a8fd40454d"/>
+    <p:sldId xmlns:r="http://schemas.openxmlformats.org/officeDocument/2006/relationships" id="260" r:id="R3ca4c0c191d54af8"/>
   </p:sldIdLst>
   <p:sldSz cx="12192000" cy="6858000"/>
   <p:notesSz cx="6858000" cy="9144000"/>
@@ -721,7 +721,7 @@
           <p:cNvPr id="1" name="Title 1">
             <a:extLst xmlns:a="http://schemas.openxmlformats.org/drawingml/2006/main">
               <a:ext uri="{FF2B5EF4-FFF2-40B4-BE49-F238E27FC236}">
-                <a16:creationId xmlns:a16="http://schemas.microsoft.com/office/drawing/2014/main" id="{586420F6-B558-43A1-A804-35E0A503AE17}"/>
+                <a16:creationId xmlns:a16="http://schemas.microsoft.com/office/drawing/2014/main" id="{143BD55D-71F2-4977-BD90-D9A53F9B3750}"/>
               </a:ext>
             </a:extLst>
           </p:cNvPr>
@@ -752,7 +752,7 @@
           <p:cNvPr id="2" name="Subtitle 2">
             <a:extLst xmlns:a="http://schemas.openxmlformats.org/drawingml/2006/main">
               <a:ext uri="{FF2B5EF4-FFF2-40B4-BE49-F238E27FC236}">
-                <a16:creationId xmlns:a16="http://schemas.microsoft.com/office/drawing/2014/main" id="{C00613D8-B0C0-4122-A1A9-2CC82AB46362}"/>
+                <a16:creationId xmlns:a16="http://schemas.microsoft.com/office/drawing/2014/main" id="{0E0E8367-A029-408A-A61A-8804AA5B4F69}"/>
               </a:ext>
             </a:extLst>
           </p:cNvPr>
@@ -815,7 +815,7 @@
           <p:cNvPr id="3" name="Date Placeholder 3">
             <a:extLst xmlns:a="http://schemas.openxmlformats.org/drawingml/2006/main">
               <a:ext uri="{FF2B5EF4-FFF2-40B4-BE49-F238E27FC236}">
-                <a16:creationId xmlns:a16="http://schemas.microsoft.com/office/drawing/2014/main" id="{FF4A766B-5C6E-4C80-9FCE-7F15455F059A}"/>
+                <a16:creationId xmlns:a16="http://schemas.microsoft.com/office/drawing/2014/main" id="{309E8465-A01C-42B5-9553-096EF24FBAB7}"/>
               </a:ext>
             </a:extLst>
           </p:cNvPr>
@@ -836,7 +836,7 @@
           <p:cNvPr id="4" name="Footer Placeholder 4">
             <a:extLst xmlns:a="http://schemas.openxmlformats.org/drawingml/2006/main">
               <a:ext uri="{FF2B5EF4-FFF2-40B4-BE49-F238E27FC236}">
-                <a16:creationId xmlns:a16="http://schemas.microsoft.com/office/drawing/2014/main" id="{8613A6C4-F784-4EC9-B723-8D8CEB635AF1}"/>
+                <a16:creationId xmlns:a16="http://schemas.microsoft.com/office/drawing/2014/main" id="{C9F2E805-3AF8-422F-A53E-ADC0D6907EC0}"/>
               </a:ext>
             </a:extLst>
           </p:cNvPr>
@@ -857,7 +857,7 @@
           <p:cNvPr id="5" name="Slide Number Placeholder 5">
             <a:extLst xmlns:a="http://schemas.openxmlformats.org/drawingml/2006/main">
               <a:ext uri="{FF2B5EF4-FFF2-40B4-BE49-F238E27FC236}">
-                <a16:creationId xmlns:a16="http://schemas.microsoft.com/office/drawing/2014/main" id="{2ABBF3EC-52F3-4D5D-88DE-CE0FBD0B3A4D}"/>
+                <a16:creationId xmlns:a16="http://schemas.microsoft.com/office/drawing/2014/main" id="{CDDE4EB3-21C4-46D4-95F1-3948D7A0E82C}"/>
               </a:ext>
             </a:extLst>
           </p:cNvPr>
@@ -900,7 +900,7 @@
           <p:cNvPr id="1" name="Slide Number Placeholder 5">
             <a:extLst xmlns:a="http://schemas.openxmlformats.org/drawingml/2006/main">
               <a:ext uri="{FF2B5EF4-FFF2-40B4-BE49-F238E27FC236}">
-                <a16:creationId xmlns:a16="http://schemas.microsoft.com/office/drawing/2014/main" id="{06512020-74D0-46B9-911A-580AFA0BCA19}"/>
+                <a16:creationId xmlns:a16="http://schemas.microsoft.com/office/drawing/2014/main" id="{77077693-AB21-494B-B274-DD6DE17926A6}"/>
               </a:ext>
             </a:extLst>
           </p:cNvPr>
@@ -939,7 +939,7 @@
   </p:cSld>
   <p:clrMap bg1="lt1" tx1="dk1" bg2="lt2" tx2="dk2" accent1="accent1" accent2="accent2" accent3="accent3" accent4="accent4" accent5="accent5" accent6="accent6" hlink="hlink" folHlink="folHlink"/>
   <p:sldLayoutIdLst>
-    <p:sldLayoutId xmlns:r="http://schemas.openxmlformats.org/officeDocument/2006/relationships" id="2147483649" r:id="Rfcaabc32cdd24107"/>
+    <p:sldLayoutId xmlns:r="http://schemas.openxmlformats.org/officeDocument/2006/relationships" id="2147483649" r:id="R242ef0c965f74e16"/>
   </p:sldLayoutIdLst>
   <p:txStyles>
     <p:titleStyle>
@@ -1540,7 +1540,7 @@
           <p:cNvPr id="1" name="Slide Number Placeholder 5">
             <a:extLst xmlns:a="http://schemas.openxmlformats.org/drawingml/2006/main">
               <a:ext uri="{FF2B5EF4-FFF2-40B4-BE49-F238E27FC236}">
-                <a16:creationId xmlns:a16="http://schemas.microsoft.com/office/drawing/2014/main" id="{2ABBF3EC-52F3-4D5D-88DE-CE0FBD0B3A4D}"/>
+                <a16:creationId xmlns:a16="http://schemas.microsoft.com/office/drawing/2014/main" id="{CDDE4EB3-21C4-46D4-95F1-3948D7A0E82C}"/>
               </a:ext>
             </a:extLst>
           </p:cNvPr>
@@ -1572,7 +1572,7 @@
           <p:cNvPr id="2" name="">
             <a:extLst xmlns:a="http://schemas.openxmlformats.org/drawingml/2006/main">
               <a:ext uri="{FF2B5EF4-FFF2-40B4-BE49-F238E27FC236}">
-                <a16:creationId xmlns:a16="http://schemas.microsoft.com/office/drawing/2014/main" id="{BC4852AB-12B7-4302-9A9D-A1211B8D2F67}"/>
+                <a16:creationId xmlns:a16="http://schemas.microsoft.com/office/drawing/2014/main" id="{3A2321D7-6DEC-4CEB-91C5-55A125814D2C}"/>
               </a:ext>
             </a:extLst>
           </p:cNvPr>
@@ -1605,7 +1605,7 @@
           <p:cNvPr id="3" name="">
             <a:extLst xmlns:a="http://schemas.openxmlformats.org/drawingml/2006/main">
               <a:ext uri="{FF2B5EF4-FFF2-40B4-BE49-F238E27FC236}">
-                <a16:creationId xmlns:a16="http://schemas.microsoft.com/office/drawing/2014/main" id="{5A396260-0431-4D58-8D55-0C6617CE6DD4}"/>
+                <a16:creationId xmlns:a16="http://schemas.microsoft.com/office/drawing/2014/main" id="{E9725449-18FB-4991-AC16-A8EE4CEF060F}"/>
               </a:ext>
             </a:extLst>
           </p:cNvPr>
@@ -1638,7 +1638,7 @@
           <p:cNvPr id="4" name="">
             <a:extLst xmlns:a="http://schemas.openxmlformats.org/drawingml/2006/main">
               <a:ext uri="{FF2B5EF4-FFF2-40B4-BE49-F238E27FC236}">
-                <a16:creationId xmlns:a16="http://schemas.microsoft.com/office/drawing/2014/main" id="{9B8FD63B-DAA3-4283-B9CD-32FEB8AF159E}"/>
+                <a16:creationId xmlns:a16="http://schemas.microsoft.com/office/drawing/2014/main" id="{410ACC6A-96FC-46A0-8952-C4295DBE3116}"/>
               </a:ext>
             </a:extLst>
           </p:cNvPr>
@@ -1689,7 +1689,7 @@
           <p:cNvPr id="5" name="">
             <a:extLst xmlns:a="http://schemas.openxmlformats.org/drawingml/2006/main">
               <a:ext uri="{FF2B5EF4-FFF2-40B4-BE49-F238E27FC236}">
-                <a16:creationId xmlns:a16="http://schemas.microsoft.com/office/drawing/2014/main" id="{78F7A7AB-42B3-4A11-BFCC-CCDEC91F4CB2}"/>
+                <a16:creationId xmlns:a16="http://schemas.microsoft.com/office/drawing/2014/main" id="{9614750B-1E9A-4EB7-B23C-81743A5F9913}"/>
               </a:ext>
             </a:extLst>
           </p:cNvPr>
@@ -1740,7 +1740,7 @@
           <p:cNvPr id="6" name="">
             <a:extLst xmlns:a="http://schemas.openxmlformats.org/drawingml/2006/main">
               <a:ext uri="{FF2B5EF4-FFF2-40B4-BE49-F238E27FC236}">
-                <a16:creationId xmlns:a16="http://schemas.microsoft.com/office/drawing/2014/main" id="{FABFA8AC-2B06-4067-88D9-D276FEB68236}"/>
+                <a16:creationId xmlns:a16="http://schemas.microsoft.com/office/drawing/2014/main" id="{4F8DF2DF-77EC-4081-A7CA-600F5E4B7DF2}"/>
               </a:ext>
             </a:extLst>
           </p:cNvPr>
@@ -1775,7 +1775,7 @@
           <p:cNvPr id="7" name="">
             <a:extLst xmlns:a="http://schemas.openxmlformats.org/drawingml/2006/main">
               <a:ext uri="{FF2B5EF4-FFF2-40B4-BE49-F238E27FC236}">
-                <a16:creationId xmlns:a16="http://schemas.microsoft.com/office/drawing/2014/main" id="{5102EE5D-30BC-4828-AB49-EBB5768876D0}"/>
+                <a16:creationId xmlns:a16="http://schemas.microsoft.com/office/drawing/2014/main" id="{F0C0FA56-7819-4166-9936-41AF12477DAA}"/>
               </a:ext>
             </a:extLst>
           </p:cNvPr>
@@ -1810,7 +1810,7 @@
           <p:cNvPr id="8" name="">
             <a:extLst xmlns:a="http://schemas.openxmlformats.org/drawingml/2006/main">
               <a:ext uri="{FF2B5EF4-FFF2-40B4-BE49-F238E27FC236}">
-                <a16:creationId xmlns:a16="http://schemas.microsoft.com/office/drawing/2014/main" id="{0438B947-72C5-4C22-98BB-86E98C5DEABE}"/>
+                <a16:creationId xmlns:a16="http://schemas.microsoft.com/office/drawing/2014/main" id="{3B62F76F-EF5C-449F-8B5D-1F2315C84280}"/>
               </a:ext>
             </a:extLst>
           </p:cNvPr>
@@ -1861,7 +1861,7 @@
           <p:cNvPr id="9" name="">
             <a:extLst xmlns:a="http://schemas.openxmlformats.org/drawingml/2006/main">
               <a:ext uri="{FF2B5EF4-FFF2-40B4-BE49-F238E27FC236}">
-                <a16:creationId xmlns:a16="http://schemas.microsoft.com/office/drawing/2014/main" id="{31F12B20-1E6A-40CD-BDD2-CCD9964E8007}"/>
+                <a16:creationId xmlns:a16="http://schemas.microsoft.com/office/drawing/2014/main" id="{B870CE2C-526C-4B05-9E0A-71E4D31F4CFF}"/>
               </a:ext>
             </a:extLst>
           </p:cNvPr>
@@ -1927,7 +1927,7 @@
           <p:cNvPr id="10" name="">
             <a:extLst xmlns:a="http://schemas.openxmlformats.org/drawingml/2006/main">
               <a:ext uri="{FF2B5EF4-FFF2-40B4-BE49-F238E27FC236}">
-                <a16:creationId xmlns:a16="http://schemas.microsoft.com/office/drawing/2014/main" id="{D93F9971-133E-4A55-BBF8-885A097A6349}"/>
+                <a16:creationId xmlns:a16="http://schemas.microsoft.com/office/drawing/2014/main" id="{F342505B-E488-42AD-BDA8-5A43F36CDCBD}"/>
               </a:ext>
             </a:extLst>
           </p:cNvPr>
@@ -1962,7 +1962,7 @@
           <p:cNvPr id="11" name="">
             <a:extLst xmlns:a="http://schemas.openxmlformats.org/drawingml/2006/main">
               <a:ext uri="{FF2B5EF4-FFF2-40B4-BE49-F238E27FC236}">
-                <a16:creationId xmlns:a16="http://schemas.microsoft.com/office/drawing/2014/main" id="{6845BD06-718A-45CF-A939-4431193AE267}"/>
+                <a16:creationId xmlns:a16="http://schemas.microsoft.com/office/drawing/2014/main" id="{49019C16-6983-4B24-B1DB-824BDC6C22DC}"/>
               </a:ext>
             </a:extLst>
           </p:cNvPr>
@@ -1997,7 +1997,7 @@
           <p:cNvPr id="12" name="">
             <a:extLst xmlns:a="http://schemas.openxmlformats.org/drawingml/2006/main">
               <a:ext uri="{FF2B5EF4-FFF2-40B4-BE49-F238E27FC236}">
-                <a16:creationId xmlns:a16="http://schemas.microsoft.com/office/drawing/2014/main" id="{3983F299-6108-4C99-A139-D5D19D75EFEF}"/>
+                <a16:creationId xmlns:a16="http://schemas.microsoft.com/office/drawing/2014/main" id="{5D3D4824-C1DC-42CE-BB89-20935D8910CA}"/>
               </a:ext>
             </a:extLst>
           </p:cNvPr>
@@ -2048,7 +2048,7 @@
           <p:cNvPr id="13" name="">
             <a:extLst xmlns:a="http://schemas.openxmlformats.org/drawingml/2006/main">
               <a:ext uri="{FF2B5EF4-FFF2-40B4-BE49-F238E27FC236}">
-                <a16:creationId xmlns:a16="http://schemas.microsoft.com/office/drawing/2014/main" id="{D479E14C-35A7-4C8C-B912-666C8BB4F431}"/>
+                <a16:creationId xmlns:a16="http://schemas.microsoft.com/office/drawing/2014/main" id="{C3677959-850E-43EC-912D-CF2DB596DA9E}"/>
               </a:ext>
             </a:extLst>
           </p:cNvPr>
@@ -2114,7 +2114,7 @@
           <p:cNvPr id="14" name="">
             <a:extLst xmlns:a="http://schemas.openxmlformats.org/drawingml/2006/main">
               <a:ext uri="{FF2B5EF4-FFF2-40B4-BE49-F238E27FC236}">
-                <a16:creationId xmlns:a16="http://schemas.microsoft.com/office/drawing/2014/main" id="{55AC70B3-CB85-4E3F-BC2F-74ABD1B748A5}"/>
+                <a16:creationId xmlns:a16="http://schemas.microsoft.com/office/drawing/2014/main" id="{4EDBB86A-A811-4FD3-BCFF-194B9DCBB5CB}"/>
               </a:ext>
             </a:extLst>
           </p:cNvPr>
@@ -2149,7 +2149,7 @@
           <p:cNvPr id="15" name="">
             <a:extLst xmlns:a="http://schemas.openxmlformats.org/drawingml/2006/main">
               <a:ext uri="{FF2B5EF4-FFF2-40B4-BE49-F238E27FC236}">
-                <a16:creationId xmlns:a16="http://schemas.microsoft.com/office/drawing/2014/main" id="{8C50D812-89D3-4E27-8D16-2983721B1A29}"/>
+                <a16:creationId xmlns:a16="http://schemas.microsoft.com/office/drawing/2014/main" id="{0CB40B44-AEB0-4D66-B3EA-8A55FEF5E9EA}"/>
               </a:ext>
             </a:extLst>
           </p:cNvPr>
@@ -2184,7 +2184,7 @@
           <p:cNvPr id="16" name="">
             <a:extLst xmlns:a="http://schemas.openxmlformats.org/drawingml/2006/main">
               <a:ext uri="{FF2B5EF4-FFF2-40B4-BE49-F238E27FC236}">
-                <a16:creationId xmlns:a16="http://schemas.microsoft.com/office/drawing/2014/main" id="{9B837D7E-837C-4FB6-BDA6-CEA9D8C50B87}"/>
+                <a16:creationId xmlns:a16="http://schemas.microsoft.com/office/drawing/2014/main" id="{E099A17A-A563-4C0E-9B05-77093D4D3A68}"/>
               </a:ext>
             </a:extLst>
           </p:cNvPr>
@@ -2235,7 +2235,7 @@
           <p:cNvPr id="17" name="">
             <a:extLst xmlns:a="http://schemas.openxmlformats.org/drawingml/2006/main">
               <a:ext uri="{FF2B5EF4-FFF2-40B4-BE49-F238E27FC236}">
-                <a16:creationId xmlns:a16="http://schemas.microsoft.com/office/drawing/2014/main" id="{61FA2509-1912-4E8E-BBC6-BACF3335AB1B}"/>
+                <a16:creationId xmlns:a16="http://schemas.microsoft.com/office/drawing/2014/main" id="{0D38A792-8606-44FE-A47C-635DC27113CC}"/>
               </a:ext>
             </a:extLst>
           </p:cNvPr>
@@ -2284,7 +2284,7 @@
     </p:spTree>
     <p:extLst>
       <p:ext uri="{BB962C8B-B14F-4D97-AF65-F5344CB8AC3E}">
-        <p14:creationId xmlns:p14="http://schemas.microsoft.com/office/powerpoint/2010/main" val="640480104"/>
+        <p14:creationId xmlns:p14="http://schemas.microsoft.com/office/powerpoint/2010/main" val="1105302138"/>
       </p:ext>
     </p:extLst>
   </p:cSld>
@@ -2308,7 +2308,7 @@
           <p:cNvPr id="1" name="Slide Number Placeholder 5">
             <a:extLst xmlns:a="http://schemas.openxmlformats.org/drawingml/2006/main">
               <a:ext uri="{FF2B5EF4-FFF2-40B4-BE49-F238E27FC236}">
-                <a16:creationId xmlns:a16="http://schemas.microsoft.com/office/drawing/2014/main" id="{2ABBF3EC-52F3-4D5D-88DE-CE0FBD0B3A4D}"/>
+                <a16:creationId xmlns:a16="http://schemas.microsoft.com/office/drawing/2014/main" id="{CDDE4EB3-21C4-46D4-95F1-3948D7A0E82C}"/>
               </a:ext>
             </a:extLst>
           </p:cNvPr>
@@ -2340,7 +2340,7 @@
           <p:cNvPr id="2" name="">
             <a:extLst xmlns:a="http://schemas.openxmlformats.org/drawingml/2006/main">
               <a:ext uri="{FF2B5EF4-FFF2-40B4-BE49-F238E27FC236}">
-                <a16:creationId xmlns:a16="http://schemas.microsoft.com/office/drawing/2014/main" id="{D4DFCE2E-3724-44E1-BC7A-D85DA922801F}"/>
+                <a16:creationId xmlns:a16="http://schemas.microsoft.com/office/drawing/2014/main" id="{D4B3AA2A-78C9-4BE6-962C-95AEFA808EAF}"/>
               </a:ext>
             </a:extLst>
           </p:cNvPr>
@@ -2373,7 +2373,7 @@
           <p:cNvPr id="3" name="">
             <a:extLst xmlns:a="http://schemas.openxmlformats.org/drawingml/2006/main">
               <a:ext uri="{FF2B5EF4-FFF2-40B4-BE49-F238E27FC236}">
-                <a16:creationId xmlns:a16="http://schemas.microsoft.com/office/drawing/2014/main" id="{0A24785C-9FA7-465A-8C5B-4964DBEF0443}"/>
+                <a16:creationId xmlns:a16="http://schemas.microsoft.com/office/drawing/2014/main" id="{8265D358-38BE-4FD0-95AB-401C109F2507}"/>
               </a:ext>
             </a:extLst>
           </p:cNvPr>
@@ -2406,7 +2406,7 @@
           <p:cNvPr id="4" name="">
             <a:extLst xmlns:a="http://schemas.openxmlformats.org/drawingml/2006/main">
               <a:ext uri="{FF2B5EF4-FFF2-40B4-BE49-F238E27FC236}">
-                <a16:creationId xmlns:a16="http://schemas.microsoft.com/office/drawing/2014/main" id="{8E27683B-0761-4886-98C9-EC98E73E1942}"/>
+                <a16:creationId xmlns:a16="http://schemas.microsoft.com/office/drawing/2014/main" id="{4A1012E0-D612-4012-82B3-D75AB56FBB67}"/>
               </a:ext>
             </a:extLst>
           </p:cNvPr>
@@ -2457,7 +2457,7 @@
           <p:cNvPr id="5" name="">
             <a:extLst xmlns:a="http://schemas.openxmlformats.org/drawingml/2006/main">
               <a:ext uri="{FF2B5EF4-FFF2-40B4-BE49-F238E27FC236}">
-                <a16:creationId xmlns:a16="http://schemas.microsoft.com/office/drawing/2014/main" id="{2524F808-A827-43AF-BB47-6B0F74ED82A3}"/>
+                <a16:creationId xmlns:a16="http://schemas.microsoft.com/office/drawing/2014/main" id="{15A3D49D-D8E6-4E64-91CD-CE2248D811FD}"/>
               </a:ext>
             </a:extLst>
           </p:cNvPr>
@@ -2492,7 +2492,7 @@
           <p:cNvPr id="6" name="">
             <a:extLst xmlns:a="http://schemas.openxmlformats.org/drawingml/2006/main">
               <a:ext uri="{FF2B5EF4-FFF2-40B4-BE49-F238E27FC236}">
-                <a16:creationId xmlns:a16="http://schemas.microsoft.com/office/drawing/2014/main" id="{A5BD9FF0-BFC7-48E4-9181-8E646854530D}"/>
+                <a16:creationId xmlns:a16="http://schemas.microsoft.com/office/drawing/2014/main" id="{31BEF9EB-06D9-48F8-BDC6-DBB017193720}"/>
               </a:ext>
             </a:extLst>
           </p:cNvPr>
@@ -2527,7 +2527,7 @@
           <p:cNvPr id="7" name="">
             <a:extLst xmlns:a="http://schemas.openxmlformats.org/drawingml/2006/main">
               <a:ext uri="{FF2B5EF4-FFF2-40B4-BE49-F238E27FC236}">
-                <a16:creationId xmlns:a16="http://schemas.microsoft.com/office/drawing/2014/main" id="{ED806B7B-1241-4D04-B293-2D1E99784498}"/>
+                <a16:creationId xmlns:a16="http://schemas.microsoft.com/office/drawing/2014/main" id="{790D5386-0D09-48AB-A799-946ECF00E727}"/>
               </a:ext>
             </a:extLst>
           </p:cNvPr>
@@ -2578,7 +2578,7 @@
           <p:cNvPr id="8" name="">
             <a:extLst xmlns:a="http://schemas.openxmlformats.org/drawingml/2006/main">
               <a:ext uri="{FF2B5EF4-FFF2-40B4-BE49-F238E27FC236}">
-                <a16:creationId xmlns:a16="http://schemas.microsoft.com/office/drawing/2014/main" id="{F543B42C-732F-461A-855D-933A248D0C49}"/>
+                <a16:creationId xmlns:a16="http://schemas.microsoft.com/office/drawing/2014/main" id="{BDE1B577-E962-45FF-9883-47A6A4D6E407}"/>
               </a:ext>
             </a:extLst>
           </p:cNvPr>
@@ -2629,7 +2629,7 @@
           <p:cNvPr id="9" name="">
             <a:extLst xmlns:a="http://schemas.openxmlformats.org/drawingml/2006/main">
               <a:ext uri="{FF2B5EF4-FFF2-40B4-BE49-F238E27FC236}">
-                <a16:creationId xmlns:a16="http://schemas.microsoft.com/office/drawing/2014/main" id="{2D3F36DA-0486-42BC-93E0-E41CAC84167B}"/>
+                <a16:creationId xmlns:a16="http://schemas.microsoft.com/office/drawing/2014/main" id="{49DA913E-B64A-473D-9E4F-1F1A3DB47A17}"/>
               </a:ext>
             </a:extLst>
           </p:cNvPr>
@@ -2664,7 +2664,7 @@
           <p:cNvPr id="10" name="">
             <a:extLst xmlns:a="http://schemas.openxmlformats.org/drawingml/2006/main">
               <a:ext uri="{FF2B5EF4-FFF2-40B4-BE49-F238E27FC236}">
-                <a16:creationId xmlns:a16="http://schemas.microsoft.com/office/drawing/2014/main" id="{27691D16-547C-4D62-A758-DF7CEC79AE9A}"/>
+                <a16:creationId xmlns:a16="http://schemas.microsoft.com/office/drawing/2014/main" id="{836C875C-E8A9-440E-B345-DC1AEECD0C60}"/>
               </a:ext>
             </a:extLst>
           </p:cNvPr>
@@ -2699,7 +2699,7 @@
           <p:cNvPr id="11" name="">
             <a:extLst xmlns:a="http://schemas.openxmlformats.org/drawingml/2006/main">
               <a:ext uri="{FF2B5EF4-FFF2-40B4-BE49-F238E27FC236}">
-                <a16:creationId xmlns:a16="http://schemas.microsoft.com/office/drawing/2014/main" id="{993B566C-08BC-4799-85E8-252F7C464836}"/>
+                <a16:creationId xmlns:a16="http://schemas.microsoft.com/office/drawing/2014/main" id="{86D9D333-E916-4410-8E60-A0893D4A1D03}"/>
               </a:ext>
             </a:extLst>
           </p:cNvPr>
@@ -2750,7 +2750,7 @@
           <p:cNvPr id="12" name="">
             <a:extLst xmlns:a="http://schemas.openxmlformats.org/drawingml/2006/main">
               <a:ext uri="{FF2B5EF4-FFF2-40B4-BE49-F238E27FC236}">
-                <a16:creationId xmlns:a16="http://schemas.microsoft.com/office/drawing/2014/main" id="{0DE75597-6C3F-47FE-AF69-1774B3BE21F8}"/>
+                <a16:creationId xmlns:a16="http://schemas.microsoft.com/office/drawing/2014/main" id="{6D3E3111-DF22-453C-A576-0E81AC3E2B1F}"/>
               </a:ext>
             </a:extLst>
           </p:cNvPr>
@@ -2801,7 +2801,7 @@
           <p:cNvPr id="13" name="">
             <a:extLst xmlns:a="http://schemas.openxmlformats.org/drawingml/2006/main">
               <a:ext uri="{FF2B5EF4-FFF2-40B4-BE49-F238E27FC236}">
-                <a16:creationId xmlns:a16="http://schemas.microsoft.com/office/drawing/2014/main" id="{D11DA134-DF8A-4CBD-A40D-96C81DFFCCD0}"/>
+                <a16:creationId xmlns:a16="http://schemas.microsoft.com/office/drawing/2014/main" id="{DF63D30B-A3DF-4143-A6E5-3366B3841EA0}"/>
               </a:ext>
             </a:extLst>
           </p:cNvPr>
@@ -2836,7 +2836,7 @@
           <p:cNvPr id="14" name="">
             <a:extLst xmlns:a="http://schemas.openxmlformats.org/drawingml/2006/main">
               <a:ext uri="{FF2B5EF4-FFF2-40B4-BE49-F238E27FC236}">
-                <a16:creationId xmlns:a16="http://schemas.microsoft.com/office/drawing/2014/main" id="{B06AFF12-B800-4E47-807B-D36B2AF1E8EC}"/>
+                <a16:creationId xmlns:a16="http://schemas.microsoft.com/office/drawing/2014/main" id="{A4643343-78A0-4545-A535-A4849D9A4A37}"/>
               </a:ext>
             </a:extLst>
           </p:cNvPr>
@@ -2871,7 +2871,7 @@
           <p:cNvPr id="15" name="">
             <a:extLst xmlns:a="http://schemas.openxmlformats.org/drawingml/2006/main">
               <a:ext uri="{FF2B5EF4-FFF2-40B4-BE49-F238E27FC236}">
-                <a16:creationId xmlns:a16="http://schemas.microsoft.com/office/drawing/2014/main" id="{3FAFE327-015D-45B7-9D1D-BF1EB04F6DCC}"/>
+                <a16:creationId xmlns:a16="http://schemas.microsoft.com/office/drawing/2014/main" id="{193D0AA5-1929-495F-A38B-D9A02628A81C}"/>
               </a:ext>
             </a:extLst>
           </p:cNvPr>
@@ -2922,7 +2922,7 @@
           <p:cNvPr id="16" name="">
             <a:extLst xmlns:a="http://schemas.openxmlformats.org/drawingml/2006/main">
               <a:ext uri="{FF2B5EF4-FFF2-40B4-BE49-F238E27FC236}">
-                <a16:creationId xmlns:a16="http://schemas.microsoft.com/office/drawing/2014/main" id="{BE9A8CCE-6847-4C2C-A5FE-273562FF9C8B}"/>
+                <a16:creationId xmlns:a16="http://schemas.microsoft.com/office/drawing/2014/main" id="{10E42479-DCBF-4F88-BDA9-434A69B2AD10}"/>
               </a:ext>
             </a:extLst>
           </p:cNvPr>
@@ -2973,7 +2973,7 @@
           <p:cNvPr id="17" name="">
             <a:extLst xmlns:a="http://schemas.openxmlformats.org/drawingml/2006/main">
               <a:ext uri="{FF2B5EF4-FFF2-40B4-BE49-F238E27FC236}">
-                <a16:creationId xmlns:a16="http://schemas.microsoft.com/office/drawing/2014/main" id="{4A702563-836E-4B4D-BC24-5A24C3374954}"/>
+                <a16:creationId xmlns:a16="http://schemas.microsoft.com/office/drawing/2014/main" id="{007B86F5-6CBE-45BF-8711-CEBF688B35AB}"/>
               </a:ext>
             </a:extLst>
           </p:cNvPr>
@@ -3008,7 +3008,7 @@
           <p:cNvPr id="18" name="">
             <a:extLst xmlns:a="http://schemas.openxmlformats.org/drawingml/2006/main">
               <a:ext uri="{FF2B5EF4-FFF2-40B4-BE49-F238E27FC236}">
-                <a16:creationId xmlns:a16="http://schemas.microsoft.com/office/drawing/2014/main" id="{BE5FB15A-7A23-4BF7-8A45-7CDEE75934A3}"/>
+                <a16:creationId xmlns:a16="http://schemas.microsoft.com/office/drawing/2014/main" id="{DEA1FB5A-F482-446B-AAF0-29DB9EA7CB5F}"/>
               </a:ext>
             </a:extLst>
           </p:cNvPr>
@@ -3043,7 +3043,7 @@
           <p:cNvPr id="19" name="">
             <a:extLst xmlns:a="http://schemas.openxmlformats.org/drawingml/2006/main">
               <a:ext uri="{FF2B5EF4-FFF2-40B4-BE49-F238E27FC236}">
-                <a16:creationId xmlns:a16="http://schemas.microsoft.com/office/drawing/2014/main" id="{4F8F5F0E-61D3-410A-8389-34BADBBAD868}"/>
+                <a16:creationId xmlns:a16="http://schemas.microsoft.com/office/drawing/2014/main" id="{D942582C-9062-44B3-9A25-A19C2087FEB4}"/>
               </a:ext>
             </a:extLst>
           </p:cNvPr>
@@ -3094,7 +3094,7 @@
           <p:cNvPr id="20" name="">
             <a:extLst xmlns:a="http://schemas.openxmlformats.org/drawingml/2006/main">
               <a:ext uri="{FF2B5EF4-FFF2-40B4-BE49-F238E27FC236}">
-                <a16:creationId xmlns:a16="http://schemas.microsoft.com/office/drawing/2014/main" id="{84D763A5-8997-443E-809D-E6B0A3919FD5}"/>
+                <a16:creationId xmlns:a16="http://schemas.microsoft.com/office/drawing/2014/main" id="{260CF243-BDDA-4EE1-B846-E8E4B4098C05}"/>
               </a:ext>
             </a:extLst>
           </p:cNvPr>
@@ -3145,7 +3145,7 @@
           <p:cNvPr id="21" name="">
             <a:extLst xmlns:a="http://schemas.openxmlformats.org/drawingml/2006/main">
               <a:ext uri="{FF2B5EF4-FFF2-40B4-BE49-F238E27FC236}">
-                <a16:creationId xmlns:a16="http://schemas.microsoft.com/office/drawing/2014/main" id="{304CB18B-5DBC-4CD6-B25C-F27FC1FF959D}"/>
+                <a16:creationId xmlns:a16="http://schemas.microsoft.com/office/drawing/2014/main" id="{F5D1FC7A-2761-447C-8714-4A3E33560215}"/>
               </a:ext>
             </a:extLst>
           </p:cNvPr>
@@ -3180,7 +3180,7 @@
           <p:cNvPr id="22" name="">
             <a:extLst xmlns:a="http://schemas.openxmlformats.org/drawingml/2006/main">
               <a:ext uri="{FF2B5EF4-FFF2-40B4-BE49-F238E27FC236}">
-                <a16:creationId xmlns:a16="http://schemas.microsoft.com/office/drawing/2014/main" id="{4E76B144-DB45-4AFD-873D-440414C84EDF}"/>
+                <a16:creationId xmlns:a16="http://schemas.microsoft.com/office/drawing/2014/main" id="{BC7CECB6-9C10-42A3-80BD-07420DE88B31}"/>
               </a:ext>
             </a:extLst>
           </p:cNvPr>
@@ -3215,7 +3215,7 @@
           <p:cNvPr id="23" name="">
             <a:extLst xmlns:a="http://schemas.openxmlformats.org/drawingml/2006/main">
               <a:ext uri="{FF2B5EF4-FFF2-40B4-BE49-F238E27FC236}">
-                <a16:creationId xmlns:a16="http://schemas.microsoft.com/office/drawing/2014/main" id="{09BB6D1C-8D73-4415-B1AF-675E65CBA460}"/>
+                <a16:creationId xmlns:a16="http://schemas.microsoft.com/office/drawing/2014/main" id="{2887C040-2A83-4E7F-AB35-D29F79AADFB3}"/>
               </a:ext>
             </a:extLst>
           </p:cNvPr>
@@ -3266,7 +3266,7 @@
           <p:cNvPr id="24" name="">
             <a:extLst xmlns:a="http://schemas.openxmlformats.org/drawingml/2006/main">
               <a:ext uri="{FF2B5EF4-FFF2-40B4-BE49-F238E27FC236}">
-                <a16:creationId xmlns:a16="http://schemas.microsoft.com/office/drawing/2014/main" id="{34530B0E-12BB-4387-A358-AF7B2EA3E3CB}"/>
+                <a16:creationId xmlns:a16="http://schemas.microsoft.com/office/drawing/2014/main" id="{AC666814-3A81-4B94-9418-2CD8908ADC8F}"/>
               </a:ext>
             </a:extLst>
           </p:cNvPr>
@@ -3315,7 +3315,7 @@
     </p:spTree>
     <p:extLst>
       <p:ext uri="{BB962C8B-B14F-4D97-AF65-F5344CB8AC3E}">
-        <p14:creationId xmlns:p14="http://schemas.microsoft.com/office/powerpoint/2010/main" val="1552077176"/>
+        <p14:creationId xmlns:p14="http://schemas.microsoft.com/office/powerpoint/2010/main" val="1548747518"/>
       </p:ext>
     </p:extLst>
   </p:cSld>
@@ -3339,7 +3339,7 @@
           <p:cNvPr id="1" name="Slide Number Placeholder 5">
             <a:extLst xmlns:a="http://schemas.openxmlformats.org/drawingml/2006/main">
               <a:ext uri="{FF2B5EF4-FFF2-40B4-BE49-F238E27FC236}">
-                <a16:creationId xmlns:a16="http://schemas.microsoft.com/office/drawing/2014/main" id="{2ABBF3EC-52F3-4D5D-88DE-CE0FBD0B3A4D}"/>
+                <a16:creationId xmlns:a16="http://schemas.microsoft.com/office/drawing/2014/main" id="{CDDE4EB3-21C4-46D4-95F1-3948D7A0E82C}"/>
               </a:ext>
             </a:extLst>
           </p:cNvPr>
@@ -3371,7 +3371,7 @@
           <p:cNvPr id="2" name="">
             <a:extLst xmlns:a="http://schemas.openxmlformats.org/drawingml/2006/main">
               <a:ext uri="{FF2B5EF4-FFF2-40B4-BE49-F238E27FC236}">
-                <a16:creationId xmlns:a16="http://schemas.microsoft.com/office/drawing/2014/main" id="{7DF89A35-985D-4670-989F-424C9C5531D5}"/>
+                <a16:creationId xmlns:a16="http://schemas.microsoft.com/office/drawing/2014/main" id="{15D42C7A-31D8-4E1E-BC1A-BA2B388FB70D}"/>
               </a:ext>
             </a:extLst>
           </p:cNvPr>
@@ -3404,7 +3404,7 @@
           <p:cNvPr id="3" name="">
             <a:extLst xmlns:a="http://schemas.openxmlformats.org/drawingml/2006/main">
               <a:ext uri="{FF2B5EF4-FFF2-40B4-BE49-F238E27FC236}">
-                <a16:creationId xmlns:a16="http://schemas.microsoft.com/office/drawing/2014/main" id="{15289DC0-64E1-45D2-9D67-66D718BE3915}"/>
+                <a16:creationId xmlns:a16="http://schemas.microsoft.com/office/drawing/2014/main" id="{869A9CEB-FB1C-4649-907A-FCDDCA61AAA0}"/>
               </a:ext>
             </a:extLst>
           </p:cNvPr>
@@ -3437,7 +3437,7 @@
           <p:cNvPr id="4" name="">
             <a:extLst xmlns:a="http://schemas.openxmlformats.org/drawingml/2006/main">
               <a:ext uri="{FF2B5EF4-FFF2-40B4-BE49-F238E27FC236}">
-                <a16:creationId xmlns:a16="http://schemas.microsoft.com/office/drawing/2014/main" id="{A5023F64-042B-4083-8808-66AEFC839512}"/>
+                <a16:creationId xmlns:a16="http://schemas.microsoft.com/office/drawing/2014/main" id="{32C6039C-A7C0-43E6-B7E4-CF87AED5C570}"/>
               </a:ext>
             </a:extLst>
           </p:cNvPr>
@@ -3488,7 +3488,7 @@
           <p:cNvPr id="5" name="">
             <a:extLst xmlns:a="http://schemas.openxmlformats.org/drawingml/2006/main">
               <a:ext uri="{FF2B5EF4-FFF2-40B4-BE49-F238E27FC236}">
-                <a16:creationId xmlns:a16="http://schemas.microsoft.com/office/drawing/2014/main" id="{370D5128-0FA8-4B95-86FC-1F7E1D32EF6A}"/>
+                <a16:creationId xmlns:a16="http://schemas.microsoft.com/office/drawing/2014/main" id="{1B685CFA-0D91-4222-89F7-0B8978D83F66}"/>
               </a:ext>
             </a:extLst>
           </p:cNvPr>
@@ -3523,7 +3523,7 @@
           <p:cNvPr id="6" name="">
             <a:extLst xmlns:a="http://schemas.openxmlformats.org/drawingml/2006/main">
               <a:ext uri="{FF2B5EF4-FFF2-40B4-BE49-F238E27FC236}">
-                <a16:creationId xmlns:a16="http://schemas.microsoft.com/office/drawing/2014/main" id="{5A276525-A5D5-4EF7-9E4B-EB8AA45BB2AF}"/>
+                <a16:creationId xmlns:a16="http://schemas.microsoft.com/office/drawing/2014/main" id="{6E3A7A10-95E4-41D5-B106-54F6075818F4}"/>
               </a:ext>
             </a:extLst>
           </p:cNvPr>
@@ -3558,7 +3558,7 @@
           <p:cNvPr id="7" name="">
             <a:extLst xmlns:a="http://schemas.openxmlformats.org/drawingml/2006/main">
               <a:ext uri="{FF2B5EF4-FFF2-40B4-BE49-F238E27FC236}">
-                <a16:creationId xmlns:a16="http://schemas.microsoft.com/office/drawing/2014/main" id="{5EDF14AF-B70C-416C-98CE-16E67607CFC0}"/>
+                <a16:creationId xmlns:a16="http://schemas.microsoft.com/office/drawing/2014/main" id="{08937F2C-9079-4225-AE39-02393166E274}"/>
               </a:ext>
             </a:extLst>
           </p:cNvPr>
@@ -3609,7 +3609,7 @@
           <p:cNvPr id="8" name="">
             <a:extLst xmlns:a="http://schemas.openxmlformats.org/drawingml/2006/main">
               <a:ext uri="{FF2B5EF4-FFF2-40B4-BE49-F238E27FC236}">
-                <a16:creationId xmlns:a16="http://schemas.microsoft.com/office/drawing/2014/main" id="{5299B1CC-187F-4E53-8B3F-EF7AE71608DE}"/>
+                <a16:creationId xmlns:a16="http://schemas.microsoft.com/office/drawing/2014/main" id="{A7EBECE2-11AF-4125-81BE-49262758390D}"/>
               </a:ext>
             </a:extLst>
           </p:cNvPr>
@@ -3697,14 +3697,14 @@
         </p:xfrm>
         <a:graphic xmlns:a="http://schemas.openxmlformats.org/drawingml/2006/main">
           <a:graphicData uri="http://schemas.openxmlformats.org/drawingml/2006/chart">
-            <c:chart xmlns:r="http://schemas.openxmlformats.org/officeDocument/2006/relationships" xmlns:c="http://schemas.openxmlformats.org/drawingml/2006/chart" r:id="R2daf45ea62114f47"/>
+            <c:chart xmlns:r="http://schemas.openxmlformats.org/officeDocument/2006/relationships" xmlns:c="http://schemas.openxmlformats.org/drawingml/2006/chart" r:id="R319cf1fd1bc44b19"/>
           </a:graphicData>
         </a:graphic>
       </p:graphicFrame>
     </p:spTree>
     <p:extLst>
       <p:ext uri="{BB962C8B-B14F-4D97-AF65-F5344CB8AC3E}">
-        <p14:creationId xmlns:p14="http://schemas.microsoft.com/office/powerpoint/2010/main" val="2043578373"/>
+        <p14:creationId xmlns:p14="http://schemas.microsoft.com/office/powerpoint/2010/main" val="35307839"/>
       </p:ext>
     </p:extLst>
   </p:cSld>
@@ -3728,7 +3728,7 @@
           <p:cNvPr id="1" name="Slide Number Placeholder 5">
             <a:extLst xmlns:a="http://schemas.openxmlformats.org/drawingml/2006/main">
               <a:ext uri="{FF2B5EF4-FFF2-40B4-BE49-F238E27FC236}">
-                <a16:creationId xmlns:a16="http://schemas.microsoft.com/office/drawing/2014/main" id="{2ABBF3EC-52F3-4D5D-88DE-CE0FBD0B3A4D}"/>
+                <a16:creationId xmlns:a16="http://schemas.microsoft.com/office/drawing/2014/main" id="{CDDE4EB3-21C4-46D4-95F1-3948D7A0E82C}"/>
               </a:ext>
             </a:extLst>
           </p:cNvPr>
@@ -3760,7 +3760,7 @@
           <p:cNvPr id="2" name="">
             <a:extLst xmlns:a="http://schemas.openxmlformats.org/drawingml/2006/main">
               <a:ext uri="{FF2B5EF4-FFF2-40B4-BE49-F238E27FC236}">
-                <a16:creationId xmlns:a16="http://schemas.microsoft.com/office/drawing/2014/main" id="{3F27A46D-54B4-4185-83FE-503D4F9B5EEB}"/>
+                <a16:creationId xmlns:a16="http://schemas.microsoft.com/office/drawing/2014/main" id="{21050319-FF84-4D2D-A9AD-19E026F0D3F0}"/>
               </a:ext>
             </a:extLst>
           </p:cNvPr>
@@ -3793,7 +3793,7 @@
           <p:cNvPr id="3" name="">
             <a:extLst xmlns:a="http://schemas.openxmlformats.org/drawingml/2006/main">
               <a:ext uri="{FF2B5EF4-FFF2-40B4-BE49-F238E27FC236}">
-                <a16:creationId xmlns:a16="http://schemas.microsoft.com/office/drawing/2014/main" id="{42A1DA23-EEC9-4CAE-98BA-692D58106576}"/>
+                <a16:creationId xmlns:a16="http://schemas.microsoft.com/office/drawing/2014/main" id="{F1C540E4-753D-4616-980F-EB3C4A43DE81}"/>
               </a:ext>
             </a:extLst>
           </p:cNvPr>
@@ -3826,7 +3826,7 @@
           <p:cNvPr id="4" name="">
             <a:extLst xmlns:a="http://schemas.openxmlformats.org/drawingml/2006/main">
               <a:ext uri="{FF2B5EF4-FFF2-40B4-BE49-F238E27FC236}">
-                <a16:creationId xmlns:a16="http://schemas.microsoft.com/office/drawing/2014/main" id="{C36531FD-9415-48B6-AE97-705CB9398F86}"/>
+                <a16:creationId xmlns:a16="http://schemas.microsoft.com/office/drawing/2014/main" id="{CF5C4D3E-4D47-4D1C-BE18-C1D759F03AEC}"/>
               </a:ext>
             </a:extLst>
           </p:cNvPr>
@@ -3877,7 +3877,7 @@
           <p:cNvPr id="5" name="">
             <a:extLst xmlns:a="http://schemas.openxmlformats.org/drawingml/2006/main">
               <a:ext uri="{FF2B5EF4-FFF2-40B4-BE49-F238E27FC236}">
-                <a16:creationId xmlns:a16="http://schemas.microsoft.com/office/drawing/2014/main" id="{1B112B12-E777-49DA-B459-76772FC72CEC}"/>
+                <a16:creationId xmlns:a16="http://schemas.microsoft.com/office/drawing/2014/main" id="{D477D667-0C14-4DFC-AC4F-FD9B49FC6920}"/>
               </a:ext>
             </a:extLst>
           </p:cNvPr>
@@ -3912,7 +3912,7 @@
           <p:cNvPr id="6" name="">
             <a:extLst xmlns:a="http://schemas.openxmlformats.org/drawingml/2006/main">
               <a:ext uri="{FF2B5EF4-FFF2-40B4-BE49-F238E27FC236}">
-                <a16:creationId xmlns:a16="http://schemas.microsoft.com/office/drawing/2014/main" id="{1BEE6D06-4803-436D-B2DA-20F227EECEC3}"/>
+                <a16:creationId xmlns:a16="http://schemas.microsoft.com/office/drawing/2014/main" id="{8688BE70-D992-47B8-8FC9-E4EC1CA39A01}"/>
               </a:ext>
             </a:extLst>
           </p:cNvPr>
@@ -3947,7 +3947,7 @@
           <p:cNvPr id="7" name="">
             <a:extLst xmlns:a="http://schemas.openxmlformats.org/drawingml/2006/main">
               <a:ext uri="{FF2B5EF4-FFF2-40B4-BE49-F238E27FC236}">
-                <a16:creationId xmlns:a16="http://schemas.microsoft.com/office/drawing/2014/main" id="{049A3634-FA94-4E1A-A6AC-F22C0FA46932}"/>
+                <a16:creationId xmlns:a16="http://schemas.microsoft.com/office/drawing/2014/main" id="{06589336-EFD9-4544-9E50-88EDA1CD8D96}"/>
               </a:ext>
             </a:extLst>
           </p:cNvPr>
@@ -3998,7 +3998,7 @@
           <p:cNvPr id="8" name="">
             <a:extLst xmlns:a="http://schemas.openxmlformats.org/drawingml/2006/main">
               <a:ext uri="{FF2B5EF4-FFF2-40B4-BE49-F238E27FC236}">
-                <a16:creationId xmlns:a16="http://schemas.microsoft.com/office/drawing/2014/main" id="{06BE58E4-860F-4228-8549-C61E2E15D201}"/>
+                <a16:creationId xmlns:a16="http://schemas.microsoft.com/office/drawing/2014/main" id="{5A4956B3-0639-4995-A1A1-DFAE86754BBC}"/>
               </a:ext>
             </a:extLst>
           </p:cNvPr>
@@ -4039,7 +4039,7 @@
                   <a:srgbClr val="334155"/>
                 </a:solidFill>
               </a:rPr>
-              <a:t>1. Growth team rolled out the onboarding checklist experiment to 40% of new workspaces and activation improved by 6 percentage points in the pilot group.</a:t>
+              <a:t>1. The board will care most about whether enterprise pipeline supports the Q3 revenue target.</a:t>
             </a:r>
           </a:p>
           <a:p xmlns:a="http://schemas.openxmlformats.org/drawingml/2006/main">
@@ -4054,7 +4054,7 @@
                   <a:srgbClr val="334155"/>
                 </a:solidFill>
               </a:rPr>
-              <a:t>2. Northstar expanded to an annual plan, adding $48k ARR after the joint sales and success push closed this week.</a:t>
+              <a:t>2. Keep net burn under $230k while continuing to invest in product reliability.</a:t>
             </a:r>
           </a:p>
           <a:p xmlns:a="http://schemas.openxmlformats.org/drawingml/2006/main">
@@ -4069,7 +4069,7 @@
                   <a:srgbClr val="334155"/>
                 </a:solidFill>
               </a:rPr>
-              <a:t>3. Support backlog dropped below 24 hours for the first time in six weeks after the triage rotation change.</a:t>
+              <a:t>3. Make the narrative concrete: growth is working, but reliability and enterprise readiness still need disciplined execution.</a:t>
             </a:r>
           </a:p>
         </p:txBody>
@@ -4079,7 +4079,7 @@
           <p:cNvPr id="9" name="">
             <a:extLst xmlns:a="http://schemas.openxmlformats.org/drawingml/2006/main">
               <a:ext uri="{FF2B5EF4-FFF2-40B4-BE49-F238E27FC236}">
-                <a16:creationId xmlns:a16="http://schemas.microsoft.com/office/drawing/2014/main" id="{E461E575-C320-4D5B-A439-DEE7E54C8074}"/>
+                <a16:creationId xmlns:a16="http://schemas.microsoft.com/office/drawing/2014/main" id="{973CE8A6-1787-41C6-B029-CA1BD6577A88}"/>
               </a:ext>
             </a:extLst>
           </p:cNvPr>
@@ -4114,7 +4114,7 @@
           <p:cNvPr id="10" name="">
             <a:extLst xmlns:a="http://schemas.openxmlformats.org/drawingml/2006/main">
               <a:ext uri="{FF2B5EF4-FFF2-40B4-BE49-F238E27FC236}">
-                <a16:creationId xmlns:a16="http://schemas.microsoft.com/office/drawing/2014/main" id="{2B128BB1-0E5F-4800-B12F-13AE30F835F5}"/>
+                <a16:creationId xmlns:a16="http://schemas.microsoft.com/office/drawing/2014/main" id="{70D4C189-F70E-4DF2-A012-13C8D2BBB52A}"/>
               </a:ext>
             </a:extLst>
           </p:cNvPr>
@@ -4149,7 +4149,7 @@
           <p:cNvPr id="11" name="">
             <a:extLst xmlns:a="http://schemas.openxmlformats.org/drawingml/2006/main">
               <a:ext uri="{FF2B5EF4-FFF2-40B4-BE49-F238E27FC236}">
-                <a16:creationId xmlns:a16="http://schemas.microsoft.com/office/drawing/2014/main" id="{305C75F2-BE3F-4B3E-A81A-AF670790A5D7}"/>
+                <a16:creationId xmlns:a16="http://schemas.microsoft.com/office/drawing/2014/main" id="{6588E65F-E31C-4C29-9857-BFF0A2B40C75}"/>
               </a:ext>
             </a:extLst>
           </p:cNvPr>
@@ -4200,7 +4200,7 @@
           <p:cNvPr id="12" name="">
             <a:extLst xmlns:a="http://schemas.openxmlformats.org/drawingml/2006/main">
               <a:ext uri="{FF2B5EF4-FFF2-40B4-BE49-F238E27FC236}">
-                <a16:creationId xmlns:a16="http://schemas.microsoft.com/office/drawing/2014/main" id="{D6971E39-D559-4D91-9095-C133A8343734}"/>
+                <a16:creationId xmlns:a16="http://schemas.microsoft.com/office/drawing/2014/main" id="{8B183B0F-70CA-4136-A6D4-6EC108C67AD8}"/>
               </a:ext>
             </a:extLst>
           </p:cNvPr>
@@ -4236,42 +4236,7 @@
           <a:lstStyle xmlns:a="http://schemas.openxmlformats.org/drawingml/2006/main"/>
           <a:p xmlns:a="http://schemas.openxmlformats.org/drawingml/2006/main">
             <a:r>
-              <a:rPr sz="1200" b="0">
-                <a:solidFill>
-                  <a:srgbClr val="334155"/>
-                </a:solidFill>
-              </a:rPr>
-              <a:t>1. Two enterprise deals are blocked on security questionnaire turnaround and legal review.</a:t>
-            </a:r>
-          </a:p>
-          <a:p xmlns:a="http://schemas.openxmlformats.org/drawingml/2006/main">
-            <a:r>
               <a:t/>
-            </a:r>
-          </a:p>
-          <a:p xmlns:a="http://schemas.openxmlformats.org/drawingml/2006/main">
-            <a:r>
-              <a:rPr sz="1200" b="0">
-                <a:solidFill>
-                  <a:srgbClr val="334155"/>
-                </a:solidFill>
-              </a:rPr>
-              <a:t>2. The iOS 3.12 release introduced a crash regression affecting 4.7% of mobile sessions.</a:t>
-            </a:r>
-          </a:p>
-          <a:p xmlns:a="http://schemas.openxmlformats.org/drawingml/2006/main">
-            <a:r>
-              <a:t/>
-            </a:r>
-          </a:p>
-          <a:p xmlns:a="http://schemas.openxmlformats.org/drawingml/2006/main">
-            <a:r>
-              <a:rPr sz="1200" b="0">
-                <a:solidFill>
-                  <a:srgbClr val="334155"/>
-                </a:solidFill>
-              </a:rPr>
-              <a:t>3. Finance flagged June vendor spend as slightly ahead of plan because of the analytics infrastructure migration.</a:t>
             </a:r>
           </a:p>
         </p:txBody>
@@ -4279,7 +4244,7 @@
     </p:spTree>
     <p:extLst>
       <p:ext uri="{BB962C8B-B14F-4D97-AF65-F5344CB8AC3E}">
-        <p14:creationId xmlns:p14="http://schemas.microsoft.com/office/powerpoint/2010/main" val="1889012906"/>
+        <p14:creationId xmlns:p14="http://schemas.microsoft.com/office/powerpoint/2010/main" val="1766696813"/>
       </p:ext>
     </p:extLst>
   </p:cSld>
@@ -4303,7 +4268,7 @@
           <p:cNvPr id="1" name="Slide Number Placeholder 5">
             <a:extLst xmlns:a="http://schemas.openxmlformats.org/drawingml/2006/main">
               <a:ext uri="{FF2B5EF4-FFF2-40B4-BE49-F238E27FC236}">
-                <a16:creationId xmlns:a16="http://schemas.microsoft.com/office/drawing/2014/main" id="{2ABBF3EC-52F3-4D5D-88DE-CE0FBD0B3A4D}"/>
+                <a16:creationId xmlns:a16="http://schemas.microsoft.com/office/drawing/2014/main" id="{CDDE4EB3-21C4-46D4-95F1-3948D7A0E82C}"/>
               </a:ext>
             </a:extLst>
           </p:cNvPr>
@@ -4335,7 +4300,7 @@
           <p:cNvPr id="2" name="">
             <a:extLst xmlns:a="http://schemas.openxmlformats.org/drawingml/2006/main">
               <a:ext uri="{FF2B5EF4-FFF2-40B4-BE49-F238E27FC236}">
-                <a16:creationId xmlns:a16="http://schemas.microsoft.com/office/drawing/2014/main" id="{2032E1FA-D343-4053-B273-33DCC393200D}"/>
+                <a16:creationId xmlns:a16="http://schemas.microsoft.com/office/drawing/2014/main" id="{9D62D453-B01B-443C-9486-7E2C3BF82EDD}"/>
               </a:ext>
             </a:extLst>
           </p:cNvPr>
@@ -4368,7 +4333,7 @@
           <p:cNvPr id="3" name="">
             <a:extLst xmlns:a="http://schemas.openxmlformats.org/drawingml/2006/main">
               <a:ext uri="{FF2B5EF4-FFF2-40B4-BE49-F238E27FC236}">
-                <a16:creationId xmlns:a16="http://schemas.microsoft.com/office/drawing/2014/main" id="{AEF8E1AD-0027-441C-9EB2-8C498C27048B}"/>
+                <a16:creationId xmlns:a16="http://schemas.microsoft.com/office/drawing/2014/main" id="{E6CBF5C4-5CCF-484C-83E7-CFE0AD3820C5}"/>
               </a:ext>
             </a:extLst>
           </p:cNvPr>
@@ -4401,7 +4366,7 @@
           <p:cNvPr id="4" name="">
             <a:extLst xmlns:a="http://schemas.openxmlformats.org/drawingml/2006/main">
               <a:ext uri="{FF2B5EF4-FFF2-40B4-BE49-F238E27FC236}">
-                <a16:creationId xmlns:a16="http://schemas.microsoft.com/office/drawing/2014/main" id="{1E2280F4-7D4D-43E1-BDEB-4A5662AAA98E}"/>
+                <a16:creationId xmlns:a16="http://schemas.microsoft.com/office/drawing/2014/main" id="{0E3D8348-8E0E-4348-A8E2-2812EDCA6C54}"/>
               </a:ext>
             </a:extLst>
           </p:cNvPr>
@@ -4452,7 +4417,7 @@
           <p:cNvPr id="5" name="">
             <a:extLst xmlns:a="http://schemas.openxmlformats.org/drawingml/2006/main">
               <a:ext uri="{FF2B5EF4-FFF2-40B4-BE49-F238E27FC236}">
-                <a16:creationId xmlns:a16="http://schemas.microsoft.com/office/drawing/2014/main" id="{2C700C52-5206-40BF-810D-E9FA9BD55892}"/>
+                <a16:creationId xmlns:a16="http://schemas.microsoft.com/office/drawing/2014/main" id="{0B479B66-4FE8-4757-B00D-79D680BF6225}"/>
               </a:ext>
             </a:extLst>
           </p:cNvPr>
@@ -4487,7 +4452,7 @@
           <p:cNvPr id="6" name="">
             <a:extLst xmlns:a="http://schemas.openxmlformats.org/drawingml/2006/main">
               <a:ext uri="{FF2B5EF4-FFF2-40B4-BE49-F238E27FC236}">
-                <a16:creationId xmlns:a16="http://schemas.microsoft.com/office/drawing/2014/main" id="{A3D9F26E-1577-4D31-95A2-5F79EE084705}"/>
+                <a16:creationId xmlns:a16="http://schemas.microsoft.com/office/drawing/2014/main" id="{0D40D3B5-E2E5-4A70-B6BD-92407C65805F}"/>
               </a:ext>
             </a:extLst>
           </p:cNvPr>
@@ -4522,7 +4487,7 @@
           <p:cNvPr id="7" name="">
             <a:extLst xmlns:a="http://schemas.openxmlformats.org/drawingml/2006/main">
               <a:ext uri="{FF2B5EF4-FFF2-40B4-BE49-F238E27FC236}">
-                <a16:creationId xmlns:a16="http://schemas.microsoft.com/office/drawing/2014/main" id="{4C0E209A-E9E3-4E78-AAB7-290946D24E09}"/>
+                <a16:creationId xmlns:a16="http://schemas.microsoft.com/office/drawing/2014/main" id="{9D89DE02-F848-4D72-85FE-F167B2652474}"/>
               </a:ext>
             </a:extLst>
           </p:cNvPr>
@@ -4573,7 +4538,7 @@
           <p:cNvPr id="8" name="">
             <a:extLst xmlns:a="http://schemas.openxmlformats.org/drawingml/2006/main">
               <a:ext uri="{FF2B5EF4-FFF2-40B4-BE49-F238E27FC236}">
-                <a16:creationId xmlns:a16="http://schemas.microsoft.com/office/drawing/2014/main" id="{94BD946C-CF7D-4849-99AF-47378B2ADCCD}"/>
+                <a16:creationId xmlns:a16="http://schemas.microsoft.com/office/drawing/2014/main" id="{7C18BED3-AEF2-4475-9D96-E25347FE00EE}"/>
               </a:ext>
             </a:extLst>
           </p:cNvPr>
@@ -4614,7 +4579,7 @@
                   <a:srgbClr val="334155"/>
                 </a:solidFill>
               </a:rPr>
-              <a:t>1. Approve short-term legal support for enterprise security reviews.</a:t>
+              <a:t>1. The board will care most about whether enterprise pipeline supports the Q3 revenue target.</a:t>
             </a:r>
           </a:p>
           <a:p xmlns:a="http://schemas.openxmlformats.org/drawingml/2006/main">
@@ -4629,37 +4594,7 @@
                   <a:srgbClr val="334155"/>
                 </a:solidFill>
               </a:rPr>
-              <a:t>2. Prioritize the mobile crash hotfix ahead of lower-priority roadmap work.</a:t>
-            </a:r>
-          </a:p>
-          <a:p xmlns:a="http://schemas.openxmlformats.org/drawingml/2006/main">
-            <a:r>
-              <a:t/>
-            </a:r>
-          </a:p>
-          <a:p xmlns:a="http://schemas.openxmlformats.org/drawingml/2006/main">
-            <a:r>
-              <a:rPr sz="1200" b="0">
-                <a:solidFill>
-                  <a:srgbClr val="334155"/>
-                </a:solidFill>
-              </a:rPr>
-              <a:t>3. The board will care most about whether enterprise pipeline supports the Q3 revenue target.</a:t>
-            </a:r>
-          </a:p>
-          <a:p xmlns:a="http://schemas.openxmlformats.org/drawingml/2006/main">
-            <a:r>
-              <a:t/>
-            </a:r>
-          </a:p>
-          <a:p xmlns:a="http://schemas.openxmlformats.org/drawingml/2006/main">
-            <a:r>
-              <a:rPr sz="1200" b="0">
-                <a:solidFill>
-                  <a:srgbClr val="334155"/>
-                </a:solidFill>
-              </a:rPr>
-              <a:t>4. Keep net burn under $230k while continuing to invest in product reliability.</a:t>
+              <a:t>2. Keep net burn under $230k while continuing to invest in product reliability.</a:t>
             </a:r>
           </a:p>
         </p:txBody>
@@ -4669,7 +4604,7 @@
           <p:cNvPr id="9" name="">
             <a:extLst xmlns:a="http://schemas.openxmlformats.org/drawingml/2006/main">
               <a:ext uri="{FF2B5EF4-FFF2-40B4-BE49-F238E27FC236}">
-                <a16:creationId xmlns:a16="http://schemas.microsoft.com/office/drawing/2014/main" id="{7AA1977D-13E5-410D-BDDF-E7CD85418012}"/>
+                <a16:creationId xmlns:a16="http://schemas.microsoft.com/office/drawing/2014/main" id="{01F745A4-D02F-420D-87FF-574ED138F649}"/>
               </a:ext>
             </a:extLst>
           </p:cNvPr>
@@ -4704,7 +4639,7 @@
           <p:cNvPr id="10" name="">
             <a:extLst xmlns:a="http://schemas.openxmlformats.org/drawingml/2006/main">
               <a:ext uri="{FF2B5EF4-FFF2-40B4-BE49-F238E27FC236}">
-                <a16:creationId xmlns:a16="http://schemas.microsoft.com/office/drawing/2014/main" id="{7CDE0BFF-928E-4FF4-A091-BA87FBE2A7A2}"/>
+                <a16:creationId xmlns:a16="http://schemas.microsoft.com/office/drawing/2014/main" id="{8D435FAF-59D8-4170-A6C2-C76EF601E418}"/>
               </a:ext>
             </a:extLst>
           </p:cNvPr>
@@ -4739,7 +4674,7 @@
           <p:cNvPr id="11" name="">
             <a:extLst xmlns:a="http://schemas.openxmlformats.org/drawingml/2006/main">
               <a:ext uri="{FF2B5EF4-FFF2-40B4-BE49-F238E27FC236}">
-                <a16:creationId xmlns:a16="http://schemas.microsoft.com/office/drawing/2014/main" id="{3C4DD9B1-CDEE-48FC-972B-02D08B3EE36C}"/>
+                <a16:creationId xmlns:a16="http://schemas.microsoft.com/office/drawing/2014/main" id="{03596240-FAA2-4585-A63D-292399541332}"/>
               </a:ext>
             </a:extLst>
           </p:cNvPr>
@@ -4790,7 +4725,7 @@
           <p:cNvPr id="12" name="">
             <a:extLst xmlns:a="http://schemas.openxmlformats.org/drawingml/2006/main">
               <a:ext uri="{FF2B5EF4-FFF2-40B4-BE49-F238E27FC236}">
-                <a16:creationId xmlns:a16="http://schemas.microsoft.com/office/drawing/2014/main" id="{80A36D49-6559-4FEC-B95E-51D23BDCD8C7}"/>
+                <a16:creationId xmlns:a16="http://schemas.microsoft.com/office/drawing/2014/main" id="{10EDD33E-6A65-43EB-9F4B-5C75A1B6469B}"/>
               </a:ext>
             </a:extLst>
           </p:cNvPr>
@@ -4869,7 +4804,7 @@
     </p:spTree>
     <p:extLst>
       <p:ext uri="{BB962C8B-B14F-4D97-AF65-F5344CB8AC3E}">
-        <p14:creationId xmlns:p14="http://schemas.microsoft.com/office/powerpoint/2010/main" val="311834423"/>
+        <p14:creationId xmlns:p14="http://schemas.microsoft.com/office/powerpoint/2010/main" val="113339355"/>
       </p:ext>
     </p:extLst>
   </p:cSld>

</xml_diff>

<commit_message>
Tune Slack classifier for consulting signals
</commit_message>
<xml_diff>
--- a/outputs/executive-briefing-machine-demo/executive-briefing-demo.pptx
+++ b/outputs/executive-briefing-machine-demo/executive-briefing-demo.pptx
@@ -2,17 +2,17 @@
 <file path=ppt/presentation.xml><?xml version="1.0" encoding="utf-8"?>
 <p:presentation xmlns:p="http://schemas.openxmlformats.org/presentationml/2006/main">
   <p:sldMasterIdLst>
-    <p:sldMasterId xmlns:r="http://schemas.openxmlformats.org/officeDocument/2006/relationships" id="2147483648" r:id="Rc5e98b62e3a444f1"/>
+    <p:sldMasterId xmlns:r="http://schemas.openxmlformats.org/officeDocument/2006/relationships" id="2147483648" r:id="R8eafe0ec0d6d4c76"/>
   </p:sldMasterIdLst>
   <p:notesMasterIdLst>
-    <p:notesMasterId xmlns:r="http://schemas.openxmlformats.org/officeDocument/2006/relationships" r:id="R61be6e33ef274d91"/>
+    <p:notesMasterId xmlns:r="http://schemas.openxmlformats.org/officeDocument/2006/relationships" r:id="R5f0b76010df846c5"/>
   </p:notesMasterIdLst>
   <p:sldIdLst>
-    <p:sldId xmlns:r="http://schemas.openxmlformats.org/officeDocument/2006/relationships" id="256" r:id="R1a99382a53274223"/>
-    <p:sldId xmlns:r="http://schemas.openxmlformats.org/officeDocument/2006/relationships" id="257" r:id="Ree40299b1e8d42dd"/>
-    <p:sldId xmlns:r="http://schemas.openxmlformats.org/officeDocument/2006/relationships" id="258" r:id="R96f57896eb434e6a"/>
-    <p:sldId xmlns:r="http://schemas.openxmlformats.org/officeDocument/2006/relationships" id="259" r:id="R959904a8fd40454d"/>
-    <p:sldId xmlns:r="http://schemas.openxmlformats.org/officeDocument/2006/relationships" id="260" r:id="R3ca4c0c191d54af8"/>
+    <p:sldId xmlns:r="http://schemas.openxmlformats.org/officeDocument/2006/relationships" id="256" r:id="R24c6bbf9b1e0410f"/>
+    <p:sldId xmlns:r="http://schemas.openxmlformats.org/officeDocument/2006/relationships" id="257" r:id="R531560b276de4cd4"/>
+    <p:sldId xmlns:r="http://schemas.openxmlformats.org/officeDocument/2006/relationships" id="258" r:id="R5a4b59c7f4664cdd"/>
+    <p:sldId xmlns:r="http://schemas.openxmlformats.org/officeDocument/2006/relationships" id="259" r:id="R75fe185507374281"/>
+    <p:sldId xmlns:r="http://schemas.openxmlformats.org/officeDocument/2006/relationships" id="260" r:id="R0a4a3d1ca86d4545"/>
   </p:sldIdLst>
   <p:sldSz cx="12192000" cy="6858000"/>
   <p:notesSz cx="6858000" cy="9144000"/>
@@ -721,7 +721,7 @@
           <p:cNvPr id="1" name="Title 1">
             <a:extLst xmlns:a="http://schemas.openxmlformats.org/drawingml/2006/main">
               <a:ext uri="{FF2B5EF4-FFF2-40B4-BE49-F238E27FC236}">
-                <a16:creationId xmlns:a16="http://schemas.microsoft.com/office/drawing/2014/main" id="{143BD55D-71F2-4977-BD90-D9A53F9B3750}"/>
+                <a16:creationId xmlns:a16="http://schemas.microsoft.com/office/drawing/2014/main" id="{BF5EC6A2-0656-4316-92DC-AC1944886EA3}"/>
               </a:ext>
             </a:extLst>
           </p:cNvPr>
@@ -752,7 +752,7 @@
           <p:cNvPr id="2" name="Subtitle 2">
             <a:extLst xmlns:a="http://schemas.openxmlformats.org/drawingml/2006/main">
               <a:ext uri="{FF2B5EF4-FFF2-40B4-BE49-F238E27FC236}">
-                <a16:creationId xmlns:a16="http://schemas.microsoft.com/office/drawing/2014/main" id="{0E0E8367-A029-408A-A61A-8804AA5B4F69}"/>
+                <a16:creationId xmlns:a16="http://schemas.microsoft.com/office/drawing/2014/main" id="{2BF70191-68D7-4262-B344-8197ABEB2ADA}"/>
               </a:ext>
             </a:extLst>
           </p:cNvPr>
@@ -815,7 +815,7 @@
           <p:cNvPr id="3" name="Date Placeholder 3">
             <a:extLst xmlns:a="http://schemas.openxmlformats.org/drawingml/2006/main">
               <a:ext uri="{FF2B5EF4-FFF2-40B4-BE49-F238E27FC236}">
-                <a16:creationId xmlns:a16="http://schemas.microsoft.com/office/drawing/2014/main" id="{309E8465-A01C-42B5-9553-096EF24FBAB7}"/>
+                <a16:creationId xmlns:a16="http://schemas.microsoft.com/office/drawing/2014/main" id="{C22CFAD8-40CB-427B-BC49-04FF1CE9DC00}"/>
               </a:ext>
             </a:extLst>
           </p:cNvPr>
@@ -836,7 +836,7 @@
           <p:cNvPr id="4" name="Footer Placeholder 4">
             <a:extLst xmlns:a="http://schemas.openxmlformats.org/drawingml/2006/main">
               <a:ext uri="{FF2B5EF4-FFF2-40B4-BE49-F238E27FC236}">
-                <a16:creationId xmlns:a16="http://schemas.microsoft.com/office/drawing/2014/main" id="{C9F2E805-3AF8-422F-A53E-ADC0D6907EC0}"/>
+                <a16:creationId xmlns:a16="http://schemas.microsoft.com/office/drawing/2014/main" id="{5E1AB07B-41BD-4E56-9056-9F8825B69719}"/>
               </a:ext>
             </a:extLst>
           </p:cNvPr>
@@ -857,7 +857,7 @@
           <p:cNvPr id="5" name="Slide Number Placeholder 5">
             <a:extLst xmlns:a="http://schemas.openxmlformats.org/drawingml/2006/main">
               <a:ext uri="{FF2B5EF4-FFF2-40B4-BE49-F238E27FC236}">
-                <a16:creationId xmlns:a16="http://schemas.microsoft.com/office/drawing/2014/main" id="{CDDE4EB3-21C4-46D4-95F1-3948D7A0E82C}"/>
+                <a16:creationId xmlns:a16="http://schemas.microsoft.com/office/drawing/2014/main" id="{F1D126EA-F237-4CFC-A5A9-C2CB178F0336}"/>
               </a:ext>
             </a:extLst>
           </p:cNvPr>
@@ -900,7 +900,7 @@
           <p:cNvPr id="1" name="Slide Number Placeholder 5">
             <a:extLst xmlns:a="http://schemas.openxmlformats.org/drawingml/2006/main">
               <a:ext uri="{FF2B5EF4-FFF2-40B4-BE49-F238E27FC236}">
-                <a16:creationId xmlns:a16="http://schemas.microsoft.com/office/drawing/2014/main" id="{77077693-AB21-494B-B274-DD6DE17926A6}"/>
+                <a16:creationId xmlns:a16="http://schemas.microsoft.com/office/drawing/2014/main" id="{DDB8EC9A-3C35-4BC7-A9C5-567B8714224A}"/>
               </a:ext>
             </a:extLst>
           </p:cNvPr>
@@ -939,7 +939,7 @@
   </p:cSld>
   <p:clrMap bg1="lt1" tx1="dk1" bg2="lt2" tx2="dk2" accent1="accent1" accent2="accent2" accent3="accent3" accent4="accent4" accent5="accent5" accent6="accent6" hlink="hlink" folHlink="folHlink"/>
   <p:sldLayoutIdLst>
-    <p:sldLayoutId xmlns:r="http://schemas.openxmlformats.org/officeDocument/2006/relationships" id="2147483649" r:id="R242ef0c965f74e16"/>
+    <p:sldLayoutId xmlns:r="http://schemas.openxmlformats.org/officeDocument/2006/relationships" id="2147483649" r:id="R86cd31cc3f5741b8"/>
   </p:sldLayoutIdLst>
   <p:txStyles>
     <p:titleStyle>
@@ -1540,7 +1540,7 @@
           <p:cNvPr id="1" name="Slide Number Placeholder 5">
             <a:extLst xmlns:a="http://schemas.openxmlformats.org/drawingml/2006/main">
               <a:ext uri="{FF2B5EF4-FFF2-40B4-BE49-F238E27FC236}">
-                <a16:creationId xmlns:a16="http://schemas.microsoft.com/office/drawing/2014/main" id="{CDDE4EB3-21C4-46D4-95F1-3948D7A0E82C}"/>
+                <a16:creationId xmlns:a16="http://schemas.microsoft.com/office/drawing/2014/main" id="{F1D126EA-F237-4CFC-A5A9-C2CB178F0336}"/>
               </a:ext>
             </a:extLst>
           </p:cNvPr>
@@ -1572,7 +1572,7 @@
           <p:cNvPr id="2" name="">
             <a:extLst xmlns:a="http://schemas.openxmlformats.org/drawingml/2006/main">
               <a:ext uri="{FF2B5EF4-FFF2-40B4-BE49-F238E27FC236}">
-                <a16:creationId xmlns:a16="http://schemas.microsoft.com/office/drawing/2014/main" id="{3A2321D7-6DEC-4CEB-91C5-55A125814D2C}"/>
+                <a16:creationId xmlns:a16="http://schemas.microsoft.com/office/drawing/2014/main" id="{0987DCDF-B84E-4DF6-8176-E5410B6BE3A8}"/>
               </a:ext>
             </a:extLst>
           </p:cNvPr>
@@ -1605,7 +1605,7 @@
           <p:cNvPr id="3" name="">
             <a:extLst xmlns:a="http://schemas.openxmlformats.org/drawingml/2006/main">
               <a:ext uri="{FF2B5EF4-FFF2-40B4-BE49-F238E27FC236}">
-                <a16:creationId xmlns:a16="http://schemas.microsoft.com/office/drawing/2014/main" id="{E9725449-18FB-4991-AC16-A8EE4CEF060F}"/>
+                <a16:creationId xmlns:a16="http://schemas.microsoft.com/office/drawing/2014/main" id="{B386ED9E-E036-4EEE-B01E-E6165369BE85}"/>
               </a:ext>
             </a:extLst>
           </p:cNvPr>
@@ -1638,7 +1638,7 @@
           <p:cNvPr id="4" name="">
             <a:extLst xmlns:a="http://schemas.openxmlformats.org/drawingml/2006/main">
               <a:ext uri="{FF2B5EF4-FFF2-40B4-BE49-F238E27FC236}">
-                <a16:creationId xmlns:a16="http://schemas.microsoft.com/office/drawing/2014/main" id="{410ACC6A-96FC-46A0-8952-C4295DBE3116}"/>
+                <a16:creationId xmlns:a16="http://schemas.microsoft.com/office/drawing/2014/main" id="{E802159A-C037-495E-9EA3-899DDD1B6689}"/>
               </a:ext>
             </a:extLst>
           </p:cNvPr>
@@ -1689,7 +1689,7 @@
           <p:cNvPr id="5" name="">
             <a:extLst xmlns:a="http://schemas.openxmlformats.org/drawingml/2006/main">
               <a:ext uri="{FF2B5EF4-FFF2-40B4-BE49-F238E27FC236}">
-                <a16:creationId xmlns:a16="http://schemas.microsoft.com/office/drawing/2014/main" id="{9614750B-1E9A-4EB7-B23C-81743A5F9913}"/>
+                <a16:creationId xmlns:a16="http://schemas.microsoft.com/office/drawing/2014/main" id="{98A31955-1FD8-4B0D-9E98-FCB83FF8B906}"/>
               </a:ext>
             </a:extLst>
           </p:cNvPr>
@@ -1740,7 +1740,7 @@
           <p:cNvPr id="6" name="">
             <a:extLst xmlns:a="http://schemas.openxmlformats.org/drawingml/2006/main">
               <a:ext uri="{FF2B5EF4-FFF2-40B4-BE49-F238E27FC236}">
-                <a16:creationId xmlns:a16="http://schemas.microsoft.com/office/drawing/2014/main" id="{4F8DF2DF-77EC-4081-A7CA-600F5E4B7DF2}"/>
+                <a16:creationId xmlns:a16="http://schemas.microsoft.com/office/drawing/2014/main" id="{143ED7E4-901B-4A19-A30B-7CF663C0FB14}"/>
               </a:ext>
             </a:extLst>
           </p:cNvPr>
@@ -1775,7 +1775,7 @@
           <p:cNvPr id="7" name="">
             <a:extLst xmlns:a="http://schemas.openxmlformats.org/drawingml/2006/main">
               <a:ext uri="{FF2B5EF4-FFF2-40B4-BE49-F238E27FC236}">
-                <a16:creationId xmlns:a16="http://schemas.microsoft.com/office/drawing/2014/main" id="{F0C0FA56-7819-4166-9936-41AF12477DAA}"/>
+                <a16:creationId xmlns:a16="http://schemas.microsoft.com/office/drawing/2014/main" id="{D4D22F85-8C91-4506-BF8F-7D68CBBBAFC5}"/>
               </a:ext>
             </a:extLst>
           </p:cNvPr>
@@ -1810,7 +1810,7 @@
           <p:cNvPr id="8" name="">
             <a:extLst xmlns:a="http://schemas.openxmlformats.org/drawingml/2006/main">
               <a:ext uri="{FF2B5EF4-FFF2-40B4-BE49-F238E27FC236}">
-                <a16:creationId xmlns:a16="http://schemas.microsoft.com/office/drawing/2014/main" id="{3B62F76F-EF5C-449F-8B5D-1F2315C84280}"/>
+                <a16:creationId xmlns:a16="http://schemas.microsoft.com/office/drawing/2014/main" id="{84EB2626-E3BC-409D-9E76-2ED438558A54}"/>
               </a:ext>
             </a:extLst>
           </p:cNvPr>
@@ -1861,7 +1861,7 @@
           <p:cNvPr id="9" name="">
             <a:extLst xmlns:a="http://schemas.openxmlformats.org/drawingml/2006/main">
               <a:ext uri="{FF2B5EF4-FFF2-40B4-BE49-F238E27FC236}">
-                <a16:creationId xmlns:a16="http://schemas.microsoft.com/office/drawing/2014/main" id="{B870CE2C-526C-4B05-9E0A-71E4D31F4CFF}"/>
+                <a16:creationId xmlns:a16="http://schemas.microsoft.com/office/drawing/2014/main" id="{D3A6345E-E09E-49AD-AD6A-CF6BF6D4448C}"/>
               </a:ext>
             </a:extLst>
           </p:cNvPr>
@@ -1927,7 +1927,7 @@
           <p:cNvPr id="10" name="">
             <a:extLst xmlns:a="http://schemas.openxmlformats.org/drawingml/2006/main">
               <a:ext uri="{FF2B5EF4-FFF2-40B4-BE49-F238E27FC236}">
-                <a16:creationId xmlns:a16="http://schemas.microsoft.com/office/drawing/2014/main" id="{F342505B-E488-42AD-BDA8-5A43F36CDCBD}"/>
+                <a16:creationId xmlns:a16="http://schemas.microsoft.com/office/drawing/2014/main" id="{398EC6DC-1789-4E24-8D1F-C8F7BF312952}"/>
               </a:ext>
             </a:extLst>
           </p:cNvPr>
@@ -1962,7 +1962,7 @@
           <p:cNvPr id="11" name="">
             <a:extLst xmlns:a="http://schemas.openxmlformats.org/drawingml/2006/main">
               <a:ext uri="{FF2B5EF4-FFF2-40B4-BE49-F238E27FC236}">
-                <a16:creationId xmlns:a16="http://schemas.microsoft.com/office/drawing/2014/main" id="{49019C16-6983-4B24-B1DB-824BDC6C22DC}"/>
+                <a16:creationId xmlns:a16="http://schemas.microsoft.com/office/drawing/2014/main" id="{91B3D336-AFC8-4524-B42C-B3CDA035E2F1}"/>
               </a:ext>
             </a:extLst>
           </p:cNvPr>
@@ -1997,7 +1997,7 @@
           <p:cNvPr id="12" name="">
             <a:extLst xmlns:a="http://schemas.openxmlformats.org/drawingml/2006/main">
               <a:ext uri="{FF2B5EF4-FFF2-40B4-BE49-F238E27FC236}">
-                <a16:creationId xmlns:a16="http://schemas.microsoft.com/office/drawing/2014/main" id="{5D3D4824-C1DC-42CE-BB89-20935D8910CA}"/>
+                <a16:creationId xmlns:a16="http://schemas.microsoft.com/office/drawing/2014/main" id="{152F78FE-34CD-4513-AC3A-6243B31A9AE8}"/>
               </a:ext>
             </a:extLst>
           </p:cNvPr>
@@ -2048,7 +2048,7 @@
           <p:cNvPr id="13" name="">
             <a:extLst xmlns:a="http://schemas.openxmlformats.org/drawingml/2006/main">
               <a:ext uri="{FF2B5EF4-FFF2-40B4-BE49-F238E27FC236}">
-                <a16:creationId xmlns:a16="http://schemas.microsoft.com/office/drawing/2014/main" id="{C3677959-850E-43EC-912D-CF2DB596DA9E}"/>
+                <a16:creationId xmlns:a16="http://schemas.microsoft.com/office/drawing/2014/main" id="{6B26FDB9-3511-41FE-8558-07779C88B7A0}"/>
               </a:ext>
             </a:extLst>
           </p:cNvPr>
@@ -2114,7 +2114,7 @@
           <p:cNvPr id="14" name="">
             <a:extLst xmlns:a="http://schemas.openxmlformats.org/drawingml/2006/main">
               <a:ext uri="{FF2B5EF4-FFF2-40B4-BE49-F238E27FC236}">
-                <a16:creationId xmlns:a16="http://schemas.microsoft.com/office/drawing/2014/main" id="{4EDBB86A-A811-4FD3-BCFF-194B9DCBB5CB}"/>
+                <a16:creationId xmlns:a16="http://schemas.microsoft.com/office/drawing/2014/main" id="{07480DB1-D0AA-46D3-A9E5-0742C55477D7}"/>
               </a:ext>
             </a:extLst>
           </p:cNvPr>
@@ -2149,7 +2149,7 @@
           <p:cNvPr id="15" name="">
             <a:extLst xmlns:a="http://schemas.openxmlformats.org/drawingml/2006/main">
               <a:ext uri="{FF2B5EF4-FFF2-40B4-BE49-F238E27FC236}">
-                <a16:creationId xmlns:a16="http://schemas.microsoft.com/office/drawing/2014/main" id="{0CB40B44-AEB0-4D66-B3EA-8A55FEF5E9EA}"/>
+                <a16:creationId xmlns:a16="http://schemas.microsoft.com/office/drawing/2014/main" id="{62D6F971-B892-402B-AFDD-4E494C689BDF}"/>
               </a:ext>
             </a:extLst>
           </p:cNvPr>
@@ -2184,7 +2184,7 @@
           <p:cNvPr id="16" name="">
             <a:extLst xmlns:a="http://schemas.openxmlformats.org/drawingml/2006/main">
               <a:ext uri="{FF2B5EF4-FFF2-40B4-BE49-F238E27FC236}">
-                <a16:creationId xmlns:a16="http://schemas.microsoft.com/office/drawing/2014/main" id="{E099A17A-A563-4C0E-9B05-77093D4D3A68}"/>
+                <a16:creationId xmlns:a16="http://schemas.microsoft.com/office/drawing/2014/main" id="{0FA631CB-53CF-4CE1-B2E7-EBCA7A6AFA6B}"/>
               </a:ext>
             </a:extLst>
           </p:cNvPr>
@@ -2235,7 +2235,7 @@
           <p:cNvPr id="17" name="">
             <a:extLst xmlns:a="http://schemas.openxmlformats.org/drawingml/2006/main">
               <a:ext uri="{FF2B5EF4-FFF2-40B4-BE49-F238E27FC236}">
-                <a16:creationId xmlns:a16="http://schemas.microsoft.com/office/drawing/2014/main" id="{0D38A792-8606-44FE-A47C-635DC27113CC}"/>
+                <a16:creationId xmlns:a16="http://schemas.microsoft.com/office/drawing/2014/main" id="{7A3BDB74-45B1-486F-8F00-63D94A9D2224}"/>
               </a:ext>
             </a:extLst>
           </p:cNvPr>
@@ -2284,7 +2284,7 @@
     </p:spTree>
     <p:extLst>
       <p:ext uri="{BB962C8B-B14F-4D97-AF65-F5344CB8AC3E}">
-        <p14:creationId xmlns:p14="http://schemas.microsoft.com/office/powerpoint/2010/main" val="1105302138"/>
+        <p14:creationId xmlns:p14="http://schemas.microsoft.com/office/powerpoint/2010/main" val="670442820"/>
       </p:ext>
     </p:extLst>
   </p:cSld>
@@ -2308,7 +2308,7 @@
           <p:cNvPr id="1" name="Slide Number Placeholder 5">
             <a:extLst xmlns:a="http://schemas.openxmlformats.org/drawingml/2006/main">
               <a:ext uri="{FF2B5EF4-FFF2-40B4-BE49-F238E27FC236}">
-                <a16:creationId xmlns:a16="http://schemas.microsoft.com/office/drawing/2014/main" id="{CDDE4EB3-21C4-46D4-95F1-3948D7A0E82C}"/>
+                <a16:creationId xmlns:a16="http://schemas.microsoft.com/office/drawing/2014/main" id="{F1D126EA-F237-4CFC-A5A9-C2CB178F0336}"/>
               </a:ext>
             </a:extLst>
           </p:cNvPr>
@@ -2340,7 +2340,7 @@
           <p:cNvPr id="2" name="">
             <a:extLst xmlns:a="http://schemas.openxmlformats.org/drawingml/2006/main">
               <a:ext uri="{FF2B5EF4-FFF2-40B4-BE49-F238E27FC236}">
-                <a16:creationId xmlns:a16="http://schemas.microsoft.com/office/drawing/2014/main" id="{D4B3AA2A-78C9-4BE6-962C-95AEFA808EAF}"/>
+                <a16:creationId xmlns:a16="http://schemas.microsoft.com/office/drawing/2014/main" id="{C5A364EC-AE5B-4566-8D96-2202FB638BD7}"/>
               </a:ext>
             </a:extLst>
           </p:cNvPr>
@@ -2373,7 +2373,7 @@
           <p:cNvPr id="3" name="">
             <a:extLst xmlns:a="http://schemas.openxmlformats.org/drawingml/2006/main">
               <a:ext uri="{FF2B5EF4-FFF2-40B4-BE49-F238E27FC236}">
-                <a16:creationId xmlns:a16="http://schemas.microsoft.com/office/drawing/2014/main" id="{8265D358-38BE-4FD0-95AB-401C109F2507}"/>
+                <a16:creationId xmlns:a16="http://schemas.microsoft.com/office/drawing/2014/main" id="{2A87045A-5E13-4822-9107-B65734426D6C}"/>
               </a:ext>
             </a:extLst>
           </p:cNvPr>
@@ -2406,7 +2406,7 @@
           <p:cNvPr id="4" name="">
             <a:extLst xmlns:a="http://schemas.openxmlformats.org/drawingml/2006/main">
               <a:ext uri="{FF2B5EF4-FFF2-40B4-BE49-F238E27FC236}">
-                <a16:creationId xmlns:a16="http://schemas.microsoft.com/office/drawing/2014/main" id="{4A1012E0-D612-4012-82B3-D75AB56FBB67}"/>
+                <a16:creationId xmlns:a16="http://schemas.microsoft.com/office/drawing/2014/main" id="{44F9F361-ABB3-442F-98A1-2FC6293CC7E6}"/>
               </a:ext>
             </a:extLst>
           </p:cNvPr>
@@ -2457,7 +2457,7 @@
           <p:cNvPr id="5" name="">
             <a:extLst xmlns:a="http://schemas.openxmlformats.org/drawingml/2006/main">
               <a:ext uri="{FF2B5EF4-FFF2-40B4-BE49-F238E27FC236}">
-                <a16:creationId xmlns:a16="http://schemas.microsoft.com/office/drawing/2014/main" id="{15A3D49D-D8E6-4E64-91CD-CE2248D811FD}"/>
+                <a16:creationId xmlns:a16="http://schemas.microsoft.com/office/drawing/2014/main" id="{D4BE4CCA-00F9-457E-99E3-9B2BBEE46682}"/>
               </a:ext>
             </a:extLst>
           </p:cNvPr>
@@ -2492,7 +2492,7 @@
           <p:cNvPr id="6" name="">
             <a:extLst xmlns:a="http://schemas.openxmlformats.org/drawingml/2006/main">
               <a:ext uri="{FF2B5EF4-FFF2-40B4-BE49-F238E27FC236}">
-                <a16:creationId xmlns:a16="http://schemas.microsoft.com/office/drawing/2014/main" id="{31BEF9EB-06D9-48F8-BDC6-DBB017193720}"/>
+                <a16:creationId xmlns:a16="http://schemas.microsoft.com/office/drawing/2014/main" id="{8B3E24E1-0712-4D63-B044-CA323BC146CB}"/>
               </a:ext>
             </a:extLst>
           </p:cNvPr>
@@ -2527,7 +2527,7 @@
           <p:cNvPr id="7" name="">
             <a:extLst xmlns:a="http://schemas.openxmlformats.org/drawingml/2006/main">
               <a:ext uri="{FF2B5EF4-FFF2-40B4-BE49-F238E27FC236}">
-                <a16:creationId xmlns:a16="http://schemas.microsoft.com/office/drawing/2014/main" id="{790D5386-0D09-48AB-A799-946ECF00E727}"/>
+                <a16:creationId xmlns:a16="http://schemas.microsoft.com/office/drawing/2014/main" id="{3FB24F9A-92BF-42DB-BCBD-52882DE5E12D}"/>
               </a:ext>
             </a:extLst>
           </p:cNvPr>
@@ -2578,7 +2578,7 @@
           <p:cNvPr id="8" name="">
             <a:extLst xmlns:a="http://schemas.openxmlformats.org/drawingml/2006/main">
               <a:ext uri="{FF2B5EF4-FFF2-40B4-BE49-F238E27FC236}">
-                <a16:creationId xmlns:a16="http://schemas.microsoft.com/office/drawing/2014/main" id="{BDE1B577-E962-45FF-9883-47A6A4D6E407}"/>
+                <a16:creationId xmlns:a16="http://schemas.microsoft.com/office/drawing/2014/main" id="{AA5E7FBC-C2B8-461E-9D00-A34CB1E7AC20}"/>
               </a:ext>
             </a:extLst>
           </p:cNvPr>
@@ -2629,7 +2629,7 @@
           <p:cNvPr id="9" name="">
             <a:extLst xmlns:a="http://schemas.openxmlformats.org/drawingml/2006/main">
               <a:ext uri="{FF2B5EF4-FFF2-40B4-BE49-F238E27FC236}">
-                <a16:creationId xmlns:a16="http://schemas.microsoft.com/office/drawing/2014/main" id="{49DA913E-B64A-473D-9E4F-1F1A3DB47A17}"/>
+                <a16:creationId xmlns:a16="http://schemas.microsoft.com/office/drawing/2014/main" id="{984B35EF-5F34-465E-ABFA-0EA070CD182A}"/>
               </a:ext>
             </a:extLst>
           </p:cNvPr>
@@ -2664,7 +2664,7 @@
           <p:cNvPr id="10" name="">
             <a:extLst xmlns:a="http://schemas.openxmlformats.org/drawingml/2006/main">
               <a:ext uri="{FF2B5EF4-FFF2-40B4-BE49-F238E27FC236}">
-                <a16:creationId xmlns:a16="http://schemas.microsoft.com/office/drawing/2014/main" id="{836C875C-E8A9-440E-B345-DC1AEECD0C60}"/>
+                <a16:creationId xmlns:a16="http://schemas.microsoft.com/office/drawing/2014/main" id="{4C4E2D69-154B-4DDB-8D96-213E91F369F9}"/>
               </a:ext>
             </a:extLst>
           </p:cNvPr>
@@ -2699,7 +2699,7 @@
           <p:cNvPr id="11" name="">
             <a:extLst xmlns:a="http://schemas.openxmlformats.org/drawingml/2006/main">
               <a:ext uri="{FF2B5EF4-FFF2-40B4-BE49-F238E27FC236}">
-                <a16:creationId xmlns:a16="http://schemas.microsoft.com/office/drawing/2014/main" id="{86D9D333-E916-4410-8E60-A0893D4A1D03}"/>
+                <a16:creationId xmlns:a16="http://schemas.microsoft.com/office/drawing/2014/main" id="{9E2036D6-ADE2-47C8-BEF6-F7855B4C5DBD}"/>
               </a:ext>
             </a:extLst>
           </p:cNvPr>
@@ -2750,7 +2750,7 @@
           <p:cNvPr id="12" name="">
             <a:extLst xmlns:a="http://schemas.openxmlformats.org/drawingml/2006/main">
               <a:ext uri="{FF2B5EF4-FFF2-40B4-BE49-F238E27FC236}">
-                <a16:creationId xmlns:a16="http://schemas.microsoft.com/office/drawing/2014/main" id="{6D3E3111-DF22-453C-A576-0E81AC3E2B1F}"/>
+                <a16:creationId xmlns:a16="http://schemas.microsoft.com/office/drawing/2014/main" id="{612E18A4-AA02-49FC-BB90-8663F29A3B53}"/>
               </a:ext>
             </a:extLst>
           </p:cNvPr>
@@ -2801,7 +2801,7 @@
           <p:cNvPr id="13" name="">
             <a:extLst xmlns:a="http://schemas.openxmlformats.org/drawingml/2006/main">
               <a:ext uri="{FF2B5EF4-FFF2-40B4-BE49-F238E27FC236}">
-                <a16:creationId xmlns:a16="http://schemas.microsoft.com/office/drawing/2014/main" id="{DF63D30B-A3DF-4143-A6E5-3366B3841EA0}"/>
+                <a16:creationId xmlns:a16="http://schemas.microsoft.com/office/drawing/2014/main" id="{876338E6-418B-4659-9938-F6AD8E61D88D}"/>
               </a:ext>
             </a:extLst>
           </p:cNvPr>
@@ -2836,7 +2836,7 @@
           <p:cNvPr id="14" name="">
             <a:extLst xmlns:a="http://schemas.openxmlformats.org/drawingml/2006/main">
               <a:ext uri="{FF2B5EF4-FFF2-40B4-BE49-F238E27FC236}">
-                <a16:creationId xmlns:a16="http://schemas.microsoft.com/office/drawing/2014/main" id="{A4643343-78A0-4545-A535-A4849D9A4A37}"/>
+                <a16:creationId xmlns:a16="http://schemas.microsoft.com/office/drawing/2014/main" id="{1FD9A96E-8BF0-478C-821C-93A120DC2A5B}"/>
               </a:ext>
             </a:extLst>
           </p:cNvPr>
@@ -2871,7 +2871,7 @@
           <p:cNvPr id="15" name="">
             <a:extLst xmlns:a="http://schemas.openxmlformats.org/drawingml/2006/main">
               <a:ext uri="{FF2B5EF4-FFF2-40B4-BE49-F238E27FC236}">
-                <a16:creationId xmlns:a16="http://schemas.microsoft.com/office/drawing/2014/main" id="{193D0AA5-1929-495F-A38B-D9A02628A81C}"/>
+                <a16:creationId xmlns:a16="http://schemas.microsoft.com/office/drawing/2014/main" id="{BB5AA220-8F57-4B2E-B8AA-C8A72170C3D5}"/>
               </a:ext>
             </a:extLst>
           </p:cNvPr>
@@ -2922,7 +2922,7 @@
           <p:cNvPr id="16" name="">
             <a:extLst xmlns:a="http://schemas.openxmlformats.org/drawingml/2006/main">
               <a:ext uri="{FF2B5EF4-FFF2-40B4-BE49-F238E27FC236}">
-                <a16:creationId xmlns:a16="http://schemas.microsoft.com/office/drawing/2014/main" id="{10E42479-DCBF-4F88-BDA9-434A69B2AD10}"/>
+                <a16:creationId xmlns:a16="http://schemas.microsoft.com/office/drawing/2014/main" id="{B33AB68A-476C-458B-B8F1-3099D6C52175}"/>
               </a:ext>
             </a:extLst>
           </p:cNvPr>
@@ -2973,7 +2973,7 @@
           <p:cNvPr id="17" name="">
             <a:extLst xmlns:a="http://schemas.openxmlformats.org/drawingml/2006/main">
               <a:ext uri="{FF2B5EF4-FFF2-40B4-BE49-F238E27FC236}">
-                <a16:creationId xmlns:a16="http://schemas.microsoft.com/office/drawing/2014/main" id="{007B86F5-6CBE-45BF-8711-CEBF688B35AB}"/>
+                <a16:creationId xmlns:a16="http://schemas.microsoft.com/office/drawing/2014/main" id="{B9965678-4D23-4254-9ABA-227E395F4E9A}"/>
               </a:ext>
             </a:extLst>
           </p:cNvPr>
@@ -3008,7 +3008,7 @@
           <p:cNvPr id="18" name="">
             <a:extLst xmlns:a="http://schemas.openxmlformats.org/drawingml/2006/main">
               <a:ext uri="{FF2B5EF4-FFF2-40B4-BE49-F238E27FC236}">
-                <a16:creationId xmlns:a16="http://schemas.microsoft.com/office/drawing/2014/main" id="{DEA1FB5A-F482-446B-AAF0-29DB9EA7CB5F}"/>
+                <a16:creationId xmlns:a16="http://schemas.microsoft.com/office/drawing/2014/main" id="{53C1E8EF-EDFE-4C38-9CF9-6A39998612F6}"/>
               </a:ext>
             </a:extLst>
           </p:cNvPr>
@@ -3043,7 +3043,7 @@
           <p:cNvPr id="19" name="">
             <a:extLst xmlns:a="http://schemas.openxmlformats.org/drawingml/2006/main">
               <a:ext uri="{FF2B5EF4-FFF2-40B4-BE49-F238E27FC236}">
-                <a16:creationId xmlns:a16="http://schemas.microsoft.com/office/drawing/2014/main" id="{D942582C-9062-44B3-9A25-A19C2087FEB4}"/>
+                <a16:creationId xmlns:a16="http://schemas.microsoft.com/office/drawing/2014/main" id="{9C6EC0FB-6F7D-4366-836E-770437C125CC}"/>
               </a:ext>
             </a:extLst>
           </p:cNvPr>
@@ -3094,7 +3094,7 @@
           <p:cNvPr id="20" name="">
             <a:extLst xmlns:a="http://schemas.openxmlformats.org/drawingml/2006/main">
               <a:ext uri="{FF2B5EF4-FFF2-40B4-BE49-F238E27FC236}">
-                <a16:creationId xmlns:a16="http://schemas.microsoft.com/office/drawing/2014/main" id="{260CF243-BDDA-4EE1-B846-E8E4B4098C05}"/>
+                <a16:creationId xmlns:a16="http://schemas.microsoft.com/office/drawing/2014/main" id="{C17B650D-CD6D-42F8-BD55-418918E54581}"/>
               </a:ext>
             </a:extLst>
           </p:cNvPr>
@@ -3145,7 +3145,7 @@
           <p:cNvPr id="21" name="">
             <a:extLst xmlns:a="http://schemas.openxmlformats.org/drawingml/2006/main">
               <a:ext uri="{FF2B5EF4-FFF2-40B4-BE49-F238E27FC236}">
-                <a16:creationId xmlns:a16="http://schemas.microsoft.com/office/drawing/2014/main" id="{F5D1FC7A-2761-447C-8714-4A3E33560215}"/>
+                <a16:creationId xmlns:a16="http://schemas.microsoft.com/office/drawing/2014/main" id="{0897A920-002B-4D9B-AB32-C5BC453DB0BE}"/>
               </a:ext>
             </a:extLst>
           </p:cNvPr>
@@ -3180,7 +3180,7 @@
           <p:cNvPr id="22" name="">
             <a:extLst xmlns:a="http://schemas.openxmlformats.org/drawingml/2006/main">
               <a:ext uri="{FF2B5EF4-FFF2-40B4-BE49-F238E27FC236}">
-                <a16:creationId xmlns:a16="http://schemas.microsoft.com/office/drawing/2014/main" id="{BC7CECB6-9C10-42A3-80BD-07420DE88B31}"/>
+                <a16:creationId xmlns:a16="http://schemas.microsoft.com/office/drawing/2014/main" id="{AACDB8C6-841D-42B8-9616-E82F591B5467}"/>
               </a:ext>
             </a:extLst>
           </p:cNvPr>
@@ -3215,7 +3215,7 @@
           <p:cNvPr id="23" name="">
             <a:extLst xmlns:a="http://schemas.openxmlformats.org/drawingml/2006/main">
               <a:ext uri="{FF2B5EF4-FFF2-40B4-BE49-F238E27FC236}">
-                <a16:creationId xmlns:a16="http://schemas.microsoft.com/office/drawing/2014/main" id="{2887C040-2A83-4E7F-AB35-D29F79AADFB3}"/>
+                <a16:creationId xmlns:a16="http://schemas.microsoft.com/office/drawing/2014/main" id="{794BD002-43AA-4C2B-8E89-09FA7D8E321C}"/>
               </a:ext>
             </a:extLst>
           </p:cNvPr>
@@ -3266,7 +3266,7 @@
           <p:cNvPr id="24" name="">
             <a:extLst xmlns:a="http://schemas.openxmlformats.org/drawingml/2006/main">
               <a:ext uri="{FF2B5EF4-FFF2-40B4-BE49-F238E27FC236}">
-                <a16:creationId xmlns:a16="http://schemas.microsoft.com/office/drawing/2014/main" id="{AC666814-3A81-4B94-9418-2CD8908ADC8F}"/>
+                <a16:creationId xmlns:a16="http://schemas.microsoft.com/office/drawing/2014/main" id="{5CEDA10A-D0B2-4538-BFEA-2706060544E9}"/>
               </a:ext>
             </a:extLst>
           </p:cNvPr>
@@ -3315,7 +3315,7 @@
     </p:spTree>
     <p:extLst>
       <p:ext uri="{BB962C8B-B14F-4D97-AF65-F5344CB8AC3E}">
-        <p14:creationId xmlns:p14="http://schemas.microsoft.com/office/powerpoint/2010/main" val="1548747518"/>
+        <p14:creationId xmlns:p14="http://schemas.microsoft.com/office/powerpoint/2010/main" val="339881175"/>
       </p:ext>
     </p:extLst>
   </p:cSld>
@@ -3339,7 +3339,7 @@
           <p:cNvPr id="1" name="Slide Number Placeholder 5">
             <a:extLst xmlns:a="http://schemas.openxmlformats.org/drawingml/2006/main">
               <a:ext uri="{FF2B5EF4-FFF2-40B4-BE49-F238E27FC236}">
-                <a16:creationId xmlns:a16="http://schemas.microsoft.com/office/drawing/2014/main" id="{CDDE4EB3-21C4-46D4-95F1-3948D7A0E82C}"/>
+                <a16:creationId xmlns:a16="http://schemas.microsoft.com/office/drawing/2014/main" id="{F1D126EA-F237-4CFC-A5A9-C2CB178F0336}"/>
               </a:ext>
             </a:extLst>
           </p:cNvPr>
@@ -3371,7 +3371,7 @@
           <p:cNvPr id="2" name="">
             <a:extLst xmlns:a="http://schemas.openxmlformats.org/drawingml/2006/main">
               <a:ext uri="{FF2B5EF4-FFF2-40B4-BE49-F238E27FC236}">
-                <a16:creationId xmlns:a16="http://schemas.microsoft.com/office/drawing/2014/main" id="{15D42C7A-31D8-4E1E-BC1A-BA2B388FB70D}"/>
+                <a16:creationId xmlns:a16="http://schemas.microsoft.com/office/drawing/2014/main" id="{4A006DA8-958B-4AFA-9E7F-A3A388CF05F4}"/>
               </a:ext>
             </a:extLst>
           </p:cNvPr>
@@ -3404,7 +3404,7 @@
           <p:cNvPr id="3" name="">
             <a:extLst xmlns:a="http://schemas.openxmlformats.org/drawingml/2006/main">
               <a:ext uri="{FF2B5EF4-FFF2-40B4-BE49-F238E27FC236}">
-                <a16:creationId xmlns:a16="http://schemas.microsoft.com/office/drawing/2014/main" id="{869A9CEB-FB1C-4649-907A-FCDDCA61AAA0}"/>
+                <a16:creationId xmlns:a16="http://schemas.microsoft.com/office/drawing/2014/main" id="{0CCB82D7-0035-48C1-8149-49BFF3838316}"/>
               </a:ext>
             </a:extLst>
           </p:cNvPr>
@@ -3437,7 +3437,7 @@
           <p:cNvPr id="4" name="">
             <a:extLst xmlns:a="http://schemas.openxmlformats.org/drawingml/2006/main">
               <a:ext uri="{FF2B5EF4-FFF2-40B4-BE49-F238E27FC236}">
-                <a16:creationId xmlns:a16="http://schemas.microsoft.com/office/drawing/2014/main" id="{32C6039C-A7C0-43E6-B7E4-CF87AED5C570}"/>
+                <a16:creationId xmlns:a16="http://schemas.microsoft.com/office/drawing/2014/main" id="{6843E09A-2AFF-4D3E-AC87-2F4F3895C763}"/>
               </a:ext>
             </a:extLst>
           </p:cNvPr>
@@ -3488,7 +3488,7 @@
           <p:cNvPr id="5" name="">
             <a:extLst xmlns:a="http://schemas.openxmlformats.org/drawingml/2006/main">
               <a:ext uri="{FF2B5EF4-FFF2-40B4-BE49-F238E27FC236}">
-                <a16:creationId xmlns:a16="http://schemas.microsoft.com/office/drawing/2014/main" id="{1B685CFA-0D91-4222-89F7-0B8978D83F66}"/>
+                <a16:creationId xmlns:a16="http://schemas.microsoft.com/office/drawing/2014/main" id="{B325E1B7-08A5-4623-89C2-B8EC06867E67}"/>
               </a:ext>
             </a:extLst>
           </p:cNvPr>
@@ -3523,7 +3523,7 @@
           <p:cNvPr id="6" name="">
             <a:extLst xmlns:a="http://schemas.openxmlformats.org/drawingml/2006/main">
               <a:ext uri="{FF2B5EF4-FFF2-40B4-BE49-F238E27FC236}">
-                <a16:creationId xmlns:a16="http://schemas.microsoft.com/office/drawing/2014/main" id="{6E3A7A10-95E4-41D5-B106-54F6075818F4}"/>
+                <a16:creationId xmlns:a16="http://schemas.microsoft.com/office/drawing/2014/main" id="{69160C03-EA7A-4201-975F-5732085C42E5}"/>
               </a:ext>
             </a:extLst>
           </p:cNvPr>
@@ -3558,7 +3558,7 @@
           <p:cNvPr id="7" name="">
             <a:extLst xmlns:a="http://schemas.openxmlformats.org/drawingml/2006/main">
               <a:ext uri="{FF2B5EF4-FFF2-40B4-BE49-F238E27FC236}">
-                <a16:creationId xmlns:a16="http://schemas.microsoft.com/office/drawing/2014/main" id="{08937F2C-9079-4225-AE39-02393166E274}"/>
+                <a16:creationId xmlns:a16="http://schemas.microsoft.com/office/drawing/2014/main" id="{91A16014-DC2F-4D75-8E22-7141BCF8F5CB}"/>
               </a:ext>
             </a:extLst>
           </p:cNvPr>
@@ -3609,7 +3609,7 @@
           <p:cNvPr id="8" name="">
             <a:extLst xmlns:a="http://schemas.openxmlformats.org/drawingml/2006/main">
               <a:ext uri="{FF2B5EF4-FFF2-40B4-BE49-F238E27FC236}">
-                <a16:creationId xmlns:a16="http://schemas.microsoft.com/office/drawing/2014/main" id="{A7EBECE2-11AF-4125-81BE-49262758390D}"/>
+                <a16:creationId xmlns:a16="http://schemas.microsoft.com/office/drawing/2014/main" id="{461CF8A5-91EF-484F-BBEE-C324A2AE83E6}"/>
               </a:ext>
             </a:extLst>
           </p:cNvPr>
@@ -3697,14 +3697,14 @@
         </p:xfrm>
         <a:graphic xmlns:a="http://schemas.openxmlformats.org/drawingml/2006/main">
           <a:graphicData uri="http://schemas.openxmlformats.org/drawingml/2006/chart">
-            <c:chart xmlns:r="http://schemas.openxmlformats.org/officeDocument/2006/relationships" xmlns:c="http://schemas.openxmlformats.org/drawingml/2006/chart" r:id="R319cf1fd1bc44b19"/>
+            <c:chart xmlns:r="http://schemas.openxmlformats.org/officeDocument/2006/relationships" xmlns:c="http://schemas.openxmlformats.org/drawingml/2006/chart" r:id="Rc67adba7f7e74a8d"/>
           </a:graphicData>
         </a:graphic>
       </p:graphicFrame>
     </p:spTree>
     <p:extLst>
       <p:ext uri="{BB962C8B-B14F-4D97-AF65-F5344CB8AC3E}">
-        <p14:creationId xmlns:p14="http://schemas.microsoft.com/office/powerpoint/2010/main" val="35307839"/>
+        <p14:creationId xmlns:p14="http://schemas.microsoft.com/office/powerpoint/2010/main" val="261350008"/>
       </p:ext>
     </p:extLst>
   </p:cSld>
@@ -3728,7 +3728,7 @@
           <p:cNvPr id="1" name="Slide Number Placeholder 5">
             <a:extLst xmlns:a="http://schemas.openxmlformats.org/drawingml/2006/main">
               <a:ext uri="{FF2B5EF4-FFF2-40B4-BE49-F238E27FC236}">
-                <a16:creationId xmlns:a16="http://schemas.microsoft.com/office/drawing/2014/main" id="{CDDE4EB3-21C4-46D4-95F1-3948D7A0E82C}"/>
+                <a16:creationId xmlns:a16="http://schemas.microsoft.com/office/drawing/2014/main" id="{F1D126EA-F237-4CFC-A5A9-C2CB178F0336}"/>
               </a:ext>
             </a:extLst>
           </p:cNvPr>
@@ -3760,7 +3760,7 @@
           <p:cNvPr id="2" name="">
             <a:extLst xmlns:a="http://schemas.openxmlformats.org/drawingml/2006/main">
               <a:ext uri="{FF2B5EF4-FFF2-40B4-BE49-F238E27FC236}">
-                <a16:creationId xmlns:a16="http://schemas.microsoft.com/office/drawing/2014/main" id="{21050319-FF84-4D2D-A9AD-19E026F0D3F0}"/>
+                <a16:creationId xmlns:a16="http://schemas.microsoft.com/office/drawing/2014/main" id="{75926342-9A1A-48D7-AFFB-88585D7A9FE2}"/>
               </a:ext>
             </a:extLst>
           </p:cNvPr>
@@ -3793,7 +3793,7 @@
           <p:cNvPr id="3" name="">
             <a:extLst xmlns:a="http://schemas.openxmlformats.org/drawingml/2006/main">
               <a:ext uri="{FF2B5EF4-FFF2-40B4-BE49-F238E27FC236}">
-                <a16:creationId xmlns:a16="http://schemas.microsoft.com/office/drawing/2014/main" id="{F1C540E4-753D-4616-980F-EB3C4A43DE81}"/>
+                <a16:creationId xmlns:a16="http://schemas.microsoft.com/office/drawing/2014/main" id="{44B78141-DE80-4CB1-9982-F61419B4263D}"/>
               </a:ext>
             </a:extLst>
           </p:cNvPr>
@@ -3826,7 +3826,7 @@
           <p:cNvPr id="4" name="">
             <a:extLst xmlns:a="http://schemas.openxmlformats.org/drawingml/2006/main">
               <a:ext uri="{FF2B5EF4-FFF2-40B4-BE49-F238E27FC236}">
-                <a16:creationId xmlns:a16="http://schemas.microsoft.com/office/drawing/2014/main" id="{CF5C4D3E-4D47-4D1C-BE18-C1D759F03AEC}"/>
+                <a16:creationId xmlns:a16="http://schemas.microsoft.com/office/drawing/2014/main" id="{AEC97227-4274-4266-928D-51AA12543386}"/>
               </a:ext>
             </a:extLst>
           </p:cNvPr>
@@ -3877,7 +3877,7 @@
           <p:cNvPr id="5" name="">
             <a:extLst xmlns:a="http://schemas.openxmlformats.org/drawingml/2006/main">
               <a:ext uri="{FF2B5EF4-FFF2-40B4-BE49-F238E27FC236}">
-                <a16:creationId xmlns:a16="http://schemas.microsoft.com/office/drawing/2014/main" id="{D477D667-0C14-4DFC-AC4F-FD9B49FC6920}"/>
+                <a16:creationId xmlns:a16="http://schemas.microsoft.com/office/drawing/2014/main" id="{338ED2F9-37D1-4FE2-A677-834757E5281C}"/>
               </a:ext>
             </a:extLst>
           </p:cNvPr>
@@ -3912,7 +3912,7 @@
           <p:cNvPr id="6" name="">
             <a:extLst xmlns:a="http://schemas.openxmlformats.org/drawingml/2006/main">
               <a:ext uri="{FF2B5EF4-FFF2-40B4-BE49-F238E27FC236}">
-                <a16:creationId xmlns:a16="http://schemas.microsoft.com/office/drawing/2014/main" id="{8688BE70-D992-47B8-8FC9-E4EC1CA39A01}"/>
+                <a16:creationId xmlns:a16="http://schemas.microsoft.com/office/drawing/2014/main" id="{B79A0952-99EF-4489-B851-4D1AE84ABA7E}"/>
               </a:ext>
             </a:extLst>
           </p:cNvPr>
@@ -3947,7 +3947,7 @@
           <p:cNvPr id="7" name="">
             <a:extLst xmlns:a="http://schemas.openxmlformats.org/drawingml/2006/main">
               <a:ext uri="{FF2B5EF4-FFF2-40B4-BE49-F238E27FC236}">
-                <a16:creationId xmlns:a16="http://schemas.microsoft.com/office/drawing/2014/main" id="{06589336-EFD9-4544-9E50-88EDA1CD8D96}"/>
+                <a16:creationId xmlns:a16="http://schemas.microsoft.com/office/drawing/2014/main" id="{8E350CA4-E25D-49A5-8C04-1D7B964B72A3}"/>
               </a:ext>
             </a:extLst>
           </p:cNvPr>
@@ -3998,7 +3998,7 @@
           <p:cNvPr id="8" name="">
             <a:extLst xmlns:a="http://schemas.openxmlformats.org/drawingml/2006/main">
               <a:ext uri="{FF2B5EF4-FFF2-40B4-BE49-F238E27FC236}">
-                <a16:creationId xmlns:a16="http://schemas.microsoft.com/office/drawing/2014/main" id="{5A4956B3-0639-4995-A1A1-DFAE86754BBC}"/>
+                <a16:creationId xmlns:a16="http://schemas.microsoft.com/office/drawing/2014/main" id="{5A4124B4-24D1-4E27-B88B-2F8340A44CB2}"/>
               </a:ext>
             </a:extLst>
           </p:cNvPr>
@@ -4039,7 +4039,7 @@
                   <a:srgbClr val="334155"/>
                 </a:solidFill>
               </a:rPr>
-              <a:t>1. The board will care most about whether enterprise pipeline supports the Q3 revenue target.</a:t>
+              <a:t>1. C09MXSVB2HH: • The CEO of the retail client said the weekly advisory cadence is working, but they want tighter decision logs and clearer owner follow-through. • The operations lead asked for a dashboard pack that shows burn, renewal risk, and implementation blockers in one place. • This is a good expansion signal if we package the reporting layer cleanly.</a:t>
             </a:r>
           </a:p>
           <a:p xmlns:a="http://schemas.openxmlformats.org/drawingml/2006/main">
@@ -4054,7 +4054,7 @@
                   <a:srgbClr val="334155"/>
                 </a:solidFill>
               </a:rPr>
-              <a:t>2. Keep net burn under $230k while continuing to invest in product reliability.</a:t>
+              <a:t>2. C09MXSVB2HH: • Qualified consulting pipeline moved from _$118k to $164k_ over the last 10 days. • Two enterprise advisory opportunities are now in procurement review. • The near-term risk is slower legal turnaround on MSA redlines, which could push one April close into May.</a:t>
             </a:r>
           </a:p>
           <a:p xmlns:a="http://schemas.openxmlformats.org/drawingml/2006/main">
@@ -4069,7 +4069,7 @@
                   <a:srgbClr val="334155"/>
                 </a:solidFill>
               </a:rPr>
-              <a:t>3. Make the narrative concrete: growth is working, but reliability and enterprise readiness still need disciplined execution.</a:t>
+              <a:t>3. C09MXSVB2HH: Hyperagent is a good alternative for clients, in advanced talks with RTPL for its implementaiotn on behalf of DB consulting and Advisory</a:t>
             </a:r>
           </a:p>
         </p:txBody>
@@ -4079,7 +4079,7 @@
           <p:cNvPr id="9" name="">
             <a:extLst xmlns:a="http://schemas.openxmlformats.org/drawingml/2006/main">
               <a:ext uri="{FF2B5EF4-FFF2-40B4-BE49-F238E27FC236}">
-                <a16:creationId xmlns:a16="http://schemas.microsoft.com/office/drawing/2014/main" id="{973CE8A6-1787-41C6-B029-CA1BD6577A88}"/>
+                <a16:creationId xmlns:a16="http://schemas.microsoft.com/office/drawing/2014/main" id="{6FAF8F4E-D783-4243-A81D-025E3E87A977}"/>
               </a:ext>
             </a:extLst>
           </p:cNvPr>
@@ -4114,7 +4114,7 @@
           <p:cNvPr id="10" name="">
             <a:extLst xmlns:a="http://schemas.openxmlformats.org/drawingml/2006/main">
               <a:ext uri="{FF2B5EF4-FFF2-40B4-BE49-F238E27FC236}">
-                <a16:creationId xmlns:a16="http://schemas.microsoft.com/office/drawing/2014/main" id="{70D4C189-F70E-4DF2-A012-13C8D2BBB52A}"/>
+                <a16:creationId xmlns:a16="http://schemas.microsoft.com/office/drawing/2014/main" id="{E399C8DE-CF7F-42F8-BD96-7A4D48403E2C}"/>
               </a:ext>
             </a:extLst>
           </p:cNvPr>
@@ -4149,7 +4149,7 @@
           <p:cNvPr id="11" name="">
             <a:extLst xmlns:a="http://schemas.openxmlformats.org/drawingml/2006/main">
               <a:ext uri="{FF2B5EF4-FFF2-40B4-BE49-F238E27FC236}">
-                <a16:creationId xmlns:a16="http://schemas.microsoft.com/office/drawing/2014/main" id="{6588E65F-E31C-4C29-9857-BFF0A2B40C75}"/>
+                <a16:creationId xmlns:a16="http://schemas.microsoft.com/office/drawing/2014/main" id="{DAD7801E-5C98-470B-8A20-8437843DC558}"/>
               </a:ext>
             </a:extLst>
           </p:cNvPr>
@@ -4200,7 +4200,7 @@
           <p:cNvPr id="12" name="">
             <a:extLst xmlns:a="http://schemas.openxmlformats.org/drawingml/2006/main">
               <a:ext uri="{FF2B5EF4-FFF2-40B4-BE49-F238E27FC236}">
-                <a16:creationId xmlns:a16="http://schemas.microsoft.com/office/drawing/2014/main" id="{8B183B0F-70CA-4136-A6D4-6EC108C67AD8}"/>
+                <a16:creationId xmlns:a16="http://schemas.microsoft.com/office/drawing/2014/main" id="{E0713459-34E7-4D46-9315-9D8DEB1A2DD2}"/>
               </a:ext>
             </a:extLst>
           </p:cNvPr>
@@ -4236,7 +4236,42 @@
           <a:lstStyle xmlns:a="http://schemas.openxmlformats.org/drawingml/2006/main"/>
           <a:p xmlns:a="http://schemas.openxmlformats.org/drawingml/2006/main">
             <a:r>
+              <a:rPr sz="1200" b="0">
+                <a:solidFill>
+                  <a:srgbClr val="334155"/>
+                </a:solidFill>
+              </a:rPr>
+              <a:t>1. C09MXSVB2HH: • One client workshop is blocked until the data room access issue is resolved. • Delivery confidence remains high, but the team needs a named owner for exec stakeholder scheduling. • If we do not unblock the security questionnaire by Friday, the healthcare advisory kickoff will slip by at least one week.</a:t>
+            </a:r>
+          </a:p>
+          <a:p xmlns:a="http://schemas.openxmlformats.org/drawingml/2006/main">
+            <a:r>
               <a:t/>
+            </a:r>
+          </a:p>
+          <a:p xmlns:a="http://schemas.openxmlformats.org/drawingml/2006/main">
+            <a:r>
+              <a:rPr sz="1200" b="0">
+                <a:solidFill>
+                  <a:srgbClr val="334155"/>
+                </a:solidFill>
+              </a:rPr>
+              <a:t>2. Open issue #5: Risk: Live channel quality can overwhelm executive-briefing signal</a:t>
+            </a:r>
+          </a:p>
+          <a:p xmlns:a="http://schemas.openxmlformats.org/drawingml/2006/main">
+            <a:r>
+              <a:t/>
+            </a:r>
+          </a:p>
+          <a:p xmlns:a="http://schemas.openxmlformats.org/drawingml/2006/main">
+            <a:r>
+              <a:rPr sz="1200" b="0">
+                <a:solidFill>
+                  <a:srgbClr val="334155"/>
+                </a:solidFill>
+              </a:rPr>
+              <a:t>3. Open issue #4: Future idea: Add client-ready QBR output mode</a:t>
             </a:r>
           </a:p>
         </p:txBody>
@@ -4244,7 +4279,7 @@
     </p:spTree>
     <p:extLst>
       <p:ext uri="{BB962C8B-B14F-4D97-AF65-F5344CB8AC3E}">
-        <p14:creationId xmlns:p14="http://schemas.microsoft.com/office/powerpoint/2010/main" val="1766696813"/>
+        <p14:creationId xmlns:p14="http://schemas.microsoft.com/office/powerpoint/2010/main" val="1760353765"/>
       </p:ext>
     </p:extLst>
   </p:cSld>
@@ -4268,7 +4303,7 @@
           <p:cNvPr id="1" name="Slide Number Placeholder 5">
             <a:extLst xmlns:a="http://schemas.openxmlformats.org/drawingml/2006/main">
               <a:ext uri="{FF2B5EF4-FFF2-40B4-BE49-F238E27FC236}">
-                <a16:creationId xmlns:a16="http://schemas.microsoft.com/office/drawing/2014/main" id="{CDDE4EB3-21C4-46D4-95F1-3948D7A0E82C}"/>
+                <a16:creationId xmlns:a16="http://schemas.microsoft.com/office/drawing/2014/main" id="{F1D126EA-F237-4CFC-A5A9-C2CB178F0336}"/>
               </a:ext>
             </a:extLst>
           </p:cNvPr>
@@ -4300,7 +4335,7 @@
           <p:cNvPr id="2" name="">
             <a:extLst xmlns:a="http://schemas.openxmlformats.org/drawingml/2006/main">
               <a:ext uri="{FF2B5EF4-FFF2-40B4-BE49-F238E27FC236}">
-                <a16:creationId xmlns:a16="http://schemas.microsoft.com/office/drawing/2014/main" id="{9D62D453-B01B-443C-9486-7E2C3BF82EDD}"/>
+                <a16:creationId xmlns:a16="http://schemas.microsoft.com/office/drawing/2014/main" id="{F15F958A-7E72-4AEC-A905-11EE8BE24689}"/>
               </a:ext>
             </a:extLst>
           </p:cNvPr>
@@ -4333,7 +4368,7 @@
           <p:cNvPr id="3" name="">
             <a:extLst xmlns:a="http://schemas.openxmlformats.org/drawingml/2006/main">
               <a:ext uri="{FF2B5EF4-FFF2-40B4-BE49-F238E27FC236}">
-                <a16:creationId xmlns:a16="http://schemas.microsoft.com/office/drawing/2014/main" id="{E6CBF5C4-5CCF-484C-83E7-CFE0AD3820C5}"/>
+                <a16:creationId xmlns:a16="http://schemas.microsoft.com/office/drawing/2014/main" id="{639568F3-5497-4913-9D42-22A7C414B4BB}"/>
               </a:ext>
             </a:extLst>
           </p:cNvPr>
@@ -4366,7 +4401,7 @@
           <p:cNvPr id="4" name="">
             <a:extLst xmlns:a="http://schemas.openxmlformats.org/drawingml/2006/main">
               <a:ext uri="{FF2B5EF4-FFF2-40B4-BE49-F238E27FC236}">
-                <a16:creationId xmlns:a16="http://schemas.microsoft.com/office/drawing/2014/main" id="{0E3D8348-8E0E-4348-A8E2-2812EDCA6C54}"/>
+                <a16:creationId xmlns:a16="http://schemas.microsoft.com/office/drawing/2014/main" id="{93BC8BE2-36D2-40BF-9692-95AAD819ACEE}"/>
               </a:ext>
             </a:extLst>
           </p:cNvPr>
@@ -4417,7 +4452,7 @@
           <p:cNvPr id="5" name="">
             <a:extLst xmlns:a="http://schemas.openxmlformats.org/drawingml/2006/main">
               <a:ext uri="{FF2B5EF4-FFF2-40B4-BE49-F238E27FC236}">
-                <a16:creationId xmlns:a16="http://schemas.microsoft.com/office/drawing/2014/main" id="{0B479B66-4FE8-4757-B00D-79D680BF6225}"/>
+                <a16:creationId xmlns:a16="http://schemas.microsoft.com/office/drawing/2014/main" id="{70BDCD12-F2A0-4F73-95E0-4C9DCBEF1561}"/>
               </a:ext>
             </a:extLst>
           </p:cNvPr>
@@ -4452,7 +4487,7 @@
           <p:cNvPr id="6" name="">
             <a:extLst xmlns:a="http://schemas.openxmlformats.org/drawingml/2006/main">
               <a:ext uri="{FF2B5EF4-FFF2-40B4-BE49-F238E27FC236}">
-                <a16:creationId xmlns:a16="http://schemas.microsoft.com/office/drawing/2014/main" id="{0D40D3B5-E2E5-4A70-B6BD-92407C65805F}"/>
+                <a16:creationId xmlns:a16="http://schemas.microsoft.com/office/drawing/2014/main" id="{FAF2AEE4-B9A7-4A02-A119-4DC8EB33B026}"/>
               </a:ext>
             </a:extLst>
           </p:cNvPr>
@@ -4487,7 +4522,7 @@
           <p:cNvPr id="7" name="">
             <a:extLst xmlns:a="http://schemas.openxmlformats.org/drawingml/2006/main">
               <a:ext uri="{FF2B5EF4-FFF2-40B4-BE49-F238E27FC236}">
-                <a16:creationId xmlns:a16="http://schemas.microsoft.com/office/drawing/2014/main" id="{9D89DE02-F848-4D72-85FE-F167B2652474}"/>
+                <a16:creationId xmlns:a16="http://schemas.microsoft.com/office/drawing/2014/main" id="{DF5D00F9-2098-4911-A564-BBFBBFE47FCB}"/>
               </a:ext>
             </a:extLst>
           </p:cNvPr>
@@ -4538,7 +4573,7 @@
           <p:cNvPr id="8" name="">
             <a:extLst xmlns:a="http://schemas.openxmlformats.org/drawingml/2006/main">
               <a:ext uri="{FF2B5EF4-FFF2-40B4-BE49-F238E27FC236}">
-                <a16:creationId xmlns:a16="http://schemas.microsoft.com/office/drawing/2014/main" id="{7C18BED3-AEF2-4475-9D96-E25347FE00EE}"/>
+                <a16:creationId xmlns:a16="http://schemas.microsoft.com/office/drawing/2014/main" id="{E17FCBDF-4AFD-4125-9B60-574046EC1A57}"/>
               </a:ext>
             </a:extLst>
           </p:cNvPr>
@@ -4579,7 +4614,7 @@
                   <a:srgbClr val="334155"/>
                 </a:solidFill>
               </a:rPr>
-              <a:t>1. The board will care most about whether enterprise pipeline supports the Q3 revenue target.</a:t>
+              <a:t>1. C09MXSVB2HH: • Need approval to pull one additional analytics contractor into the customer-ops workstream for 3 weeks. • Need legal support on the enterprise MSA backlog to protect April revenue timing. • Please confirm whether we want the board narrative to emphasize pipeline quality, delivery readiness, or margin improvement first.</a:t>
             </a:r>
           </a:p>
           <a:p xmlns:a="http://schemas.openxmlformats.org/drawingml/2006/main">
@@ -4594,7 +4629,22 @@
                   <a:srgbClr val="334155"/>
                 </a:solidFill>
               </a:rPr>
-              <a:t>2. Keep net burn under $230k while continuing to invest in product reliability.</a:t>
+              <a:t>2. The board will care most about whether enterprise pipeline supports the Q3 revenue target.</a:t>
+            </a:r>
+          </a:p>
+          <a:p xmlns:a="http://schemas.openxmlformats.org/drawingml/2006/main">
+            <a:r>
+              <a:t/>
+            </a:r>
+          </a:p>
+          <a:p xmlns:a="http://schemas.openxmlformats.org/drawingml/2006/main">
+            <a:r>
+              <a:rPr sz="1200" b="0">
+                <a:solidFill>
+                  <a:srgbClr val="334155"/>
+                </a:solidFill>
+              </a:rPr>
+              <a:t>3. Keep net burn under $230k while continuing to invest in product reliability.</a:t>
             </a:r>
           </a:p>
         </p:txBody>
@@ -4604,7 +4654,7 @@
           <p:cNvPr id="9" name="">
             <a:extLst xmlns:a="http://schemas.openxmlformats.org/drawingml/2006/main">
               <a:ext uri="{FF2B5EF4-FFF2-40B4-BE49-F238E27FC236}">
-                <a16:creationId xmlns:a16="http://schemas.microsoft.com/office/drawing/2014/main" id="{01F745A4-D02F-420D-87FF-574ED138F649}"/>
+                <a16:creationId xmlns:a16="http://schemas.microsoft.com/office/drawing/2014/main" id="{5E83D1BC-80D6-4D2D-9266-1CF0C3EEA984}"/>
               </a:ext>
             </a:extLst>
           </p:cNvPr>
@@ -4639,7 +4689,7 @@
           <p:cNvPr id="10" name="">
             <a:extLst xmlns:a="http://schemas.openxmlformats.org/drawingml/2006/main">
               <a:ext uri="{FF2B5EF4-FFF2-40B4-BE49-F238E27FC236}">
-                <a16:creationId xmlns:a16="http://schemas.microsoft.com/office/drawing/2014/main" id="{8D435FAF-59D8-4170-A6C2-C76EF601E418}"/>
+                <a16:creationId xmlns:a16="http://schemas.microsoft.com/office/drawing/2014/main" id="{C959F9E9-2B9A-4D04-A837-AAFD1D8C5156}"/>
               </a:ext>
             </a:extLst>
           </p:cNvPr>
@@ -4674,7 +4724,7 @@
           <p:cNvPr id="11" name="">
             <a:extLst xmlns:a="http://schemas.openxmlformats.org/drawingml/2006/main">
               <a:ext uri="{FF2B5EF4-FFF2-40B4-BE49-F238E27FC236}">
-                <a16:creationId xmlns:a16="http://schemas.microsoft.com/office/drawing/2014/main" id="{03596240-FAA2-4585-A63D-292399541332}"/>
+                <a16:creationId xmlns:a16="http://schemas.microsoft.com/office/drawing/2014/main" id="{E92D4DA4-F3F6-4EC2-A223-3EAF479F3275}"/>
               </a:ext>
             </a:extLst>
           </p:cNvPr>
@@ -4725,7 +4775,7 @@
           <p:cNvPr id="12" name="">
             <a:extLst xmlns:a="http://schemas.openxmlformats.org/drawingml/2006/main">
               <a:ext uri="{FF2B5EF4-FFF2-40B4-BE49-F238E27FC236}">
-                <a16:creationId xmlns:a16="http://schemas.microsoft.com/office/drawing/2014/main" id="{10EDD33E-6A65-43EB-9F4B-5C75A1B6469B}"/>
+                <a16:creationId xmlns:a16="http://schemas.microsoft.com/office/drawing/2014/main" id="{66E97AA9-1956-4194-9E5A-7DFF89CCD685}"/>
               </a:ext>
             </a:extLst>
           </p:cNvPr>
@@ -4804,7 +4854,7 @@
     </p:spTree>
     <p:extLst>
       <p:ext uri="{BB962C8B-B14F-4D97-AF65-F5344CB8AC3E}">
-        <p14:creationId xmlns:p14="http://schemas.microsoft.com/office/powerpoint/2010/main" val="113339355"/>
+        <p14:creationId xmlns:p14="http://schemas.microsoft.com/office/powerpoint/2010/main" val="512652787"/>
       </p:ext>
     </p:extLst>
   </p:cSld>

</xml_diff>

<commit_message>
Curate final consulting demo inputs and outputs
</commit_message>
<xml_diff>
--- a/outputs/executive-briefing-machine-demo/executive-briefing-demo.pptx
+++ b/outputs/executive-briefing-machine-demo/executive-briefing-demo.pptx
@@ -2,17 +2,17 @@
 <file path=ppt/presentation.xml><?xml version="1.0" encoding="utf-8"?>
 <p:presentation xmlns:p="http://schemas.openxmlformats.org/presentationml/2006/main">
   <p:sldMasterIdLst>
-    <p:sldMasterId xmlns:r="http://schemas.openxmlformats.org/officeDocument/2006/relationships" id="2147483648" r:id="R8eafe0ec0d6d4c76"/>
+    <p:sldMasterId xmlns:r="http://schemas.openxmlformats.org/officeDocument/2006/relationships" id="2147483648" r:id="Re574bd1114e5435b"/>
   </p:sldMasterIdLst>
   <p:notesMasterIdLst>
-    <p:notesMasterId xmlns:r="http://schemas.openxmlformats.org/officeDocument/2006/relationships" r:id="R5f0b76010df846c5"/>
+    <p:notesMasterId xmlns:r="http://schemas.openxmlformats.org/officeDocument/2006/relationships" r:id="R860361c4814343de"/>
   </p:notesMasterIdLst>
   <p:sldIdLst>
-    <p:sldId xmlns:r="http://schemas.openxmlformats.org/officeDocument/2006/relationships" id="256" r:id="R24c6bbf9b1e0410f"/>
-    <p:sldId xmlns:r="http://schemas.openxmlformats.org/officeDocument/2006/relationships" id="257" r:id="R531560b276de4cd4"/>
-    <p:sldId xmlns:r="http://schemas.openxmlformats.org/officeDocument/2006/relationships" id="258" r:id="R5a4b59c7f4664cdd"/>
-    <p:sldId xmlns:r="http://schemas.openxmlformats.org/officeDocument/2006/relationships" id="259" r:id="R75fe185507374281"/>
-    <p:sldId xmlns:r="http://schemas.openxmlformats.org/officeDocument/2006/relationships" id="260" r:id="R0a4a3d1ca86d4545"/>
+    <p:sldId xmlns:r="http://schemas.openxmlformats.org/officeDocument/2006/relationships" id="256" r:id="Re17f0cee1d364aa9"/>
+    <p:sldId xmlns:r="http://schemas.openxmlformats.org/officeDocument/2006/relationships" id="257" r:id="Rc3eec21ec81347bb"/>
+    <p:sldId xmlns:r="http://schemas.openxmlformats.org/officeDocument/2006/relationships" id="258" r:id="Rc812a899102848eb"/>
+    <p:sldId xmlns:r="http://schemas.openxmlformats.org/officeDocument/2006/relationships" id="259" r:id="R0a8c95daf5e14a86"/>
+    <p:sldId xmlns:r="http://schemas.openxmlformats.org/officeDocument/2006/relationships" id="260" r:id="R48cf364a4ee64c09"/>
   </p:sldIdLst>
   <p:sldSz cx="12192000" cy="6858000"/>
   <p:notesSz cx="6858000" cy="9144000"/>
@@ -721,7 +721,7 @@
           <p:cNvPr id="1" name="Title 1">
             <a:extLst xmlns:a="http://schemas.openxmlformats.org/drawingml/2006/main">
               <a:ext uri="{FF2B5EF4-FFF2-40B4-BE49-F238E27FC236}">
-                <a16:creationId xmlns:a16="http://schemas.microsoft.com/office/drawing/2014/main" id="{BF5EC6A2-0656-4316-92DC-AC1944886EA3}"/>
+                <a16:creationId xmlns:a16="http://schemas.microsoft.com/office/drawing/2014/main" id="{385831EB-902E-43CB-AC60-FB4F8CF4767B}"/>
               </a:ext>
             </a:extLst>
           </p:cNvPr>
@@ -752,7 +752,7 @@
           <p:cNvPr id="2" name="Subtitle 2">
             <a:extLst xmlns:a="http://schemas.openxmlformats.org/drawingml/2006/main">
               <a:ext uri="{FF2B5EF4-FFF2-40B4-BE49-F238E27FC236}">
-                <a16:creationId xmlns:a16="http://schemas.microsoft.com/office/drawing/2014/main" id="{2BF70191-68D7-4262-B344-8197ABEB2ADA}"/>
+                <a16:creationId xmlns:a16="http://schemas.microsoft.com/office/drawing/2014/main" id="{687E4003-8BEE-4A48-B07B-5FE79CF5102F}"/>
               </a:ext>
             </a:extLst>
           </p:cNvPr>
@@ -815,7 +815,7 @@
           <p:cNvPr id="3" name="Date Placeholder 3">
             <a:extLst xmlns:a="http://schemas.openxmlformats.org/drawingml/2006/main">
               <a:ext uri="{FF2B5EF4-FFF2-40B4-BE49-F238E27FC236}">
-                <a16:creationId xmlns:a16="http://schemas.microsoft.com/office/drawing/2014/main" id="{C22CFAD8-40CB-427B-BC49-04FF1CE9DC00}"/>
+                <a16:creationId xmlns:a16="http://schemas.microsoft.com/office/drawing/2014/main" id="{81A5CEAE-8823-4331-AEB0-8BE9D89A24AA}"/>
               </a:ext>
             </a:extLst>
           </p:cNvPr>
@@ -836,7 +836,7 @@
           <p:cNvPr id="4" name="Footer Placeholder 4">
             <a:extLst xmlns:a="http://schemas.openxmlformats.org/drawingml/2006/main">
               <a:ext uri="{FF2B5EF4-FFF2-40B4-BE49-F238E27FC236}">
-                <a16:creationId xmlns:a16="http://schemas.microsoft.com/office/drawing/2014/main" id="{5E1AB07B-41BD-4E56-9056-9F8825B69719}"/>
+                <a16:creationId xmlns:a16="http://schemas.microsoft.com/office/drawing/2014/main" id="{65C67A3B-809A-4203-A639-C838BCC49932}"/>
               </a:ext>
             </a:extLst>
           </p:cNvPr>
@@ -857,7 +857,7 @@
           <p:cNvPr id="5" name="Slide Number Placeholder 5">
             <a:extLst xmlns:a="http://schemas.openxmlformats.org/drawingml/2006/main">
               <a:ext uri="{FF2B5EF4-FFF2-40B4-BE49-F238E27FC236}">
-                <a16:creationId xmlns:a16="http://schemas.microsoft.com/office/drawing/2014/main" id="{F1D126EA-F237-4CFC-A5A9-C2CB178F0336}"/>
+                <a16:creationId xmlns:a16="http://schemas.microsoft.com/office/drawing/2014/main" id="{5D223293-109B-42C6-8AB0-D8D7CB124344}"/>
               </a:ext>
             </a:extLst>
           </p:cNvPr>
@@ -900,7 +900,7 @@
           <p:cNvPr id="1" name="Slide Number Placeholder 5">
             <a:extLst xmlns:a="http://schemas.openxmlformats.org/drawingml/2006/main">
               <a:ext uri="{FF2B5EF4-FFF2-40B4-BE49-F238E27FC236}">
-                <a16:creationId xmlns:a16="http://schemas.microsoft.com/office/drawing/2014/main" id="{DDB8EC9A-3C35-4BC7-A9C5-567B8714224A}"/>
+                <a16:creationId xmlns:a16="http://schemas.microsoft.com/office/drawing/2014/main" id="{0487AE93-D8D1-4855-86E9-DA422CFCDB8D}"/>
               </a:ext>
             </a:extLst>
           </p:cNvPr>
@@ -939,7 +939,7 @@
   </p:cSld>
   <p:clrMap bg1="lt1" tx1="dk1" bg2="lt2" tx2="dk2" accent1="accent1" accent2="accent2" accent3="accent3" accent4="accent4" accent5="accent5" accent6="accent6" hlink="hlink" folHlink="folHlink"/>
   <p:sldLayoutIdLst>
-    <p:sldLayoutId xmlns:r="http://schemas.openxmlformats.org/officeDocument/2006/relationships" id="2147483649" r:id="R86cd31cc3f5741b8"/>
+    <p:sldLayoutId xmlns:r="http://schemas.openxmlformats.org/officeDocument/2006/relationships" id="2147483649" r:id="R4102c960ef20449a"/>
   </p:sldLayoutIdLst>
   <p:txStyles>
     <p:titleStyle>
@@ -1317,22 +1317,22 @@
               <c:formatCode/>
               <c:ptCount val="6"/>
               <c:pt idx="0">
-                <c:v>1420</c:v>
+                <c:v>612</c:v>
               </c:pt>
               <c:pt idx="1">
-                <c:v>1465</c:v>
+                <c:v>648</c:v>
               </c:pt>
               <c:pt idx="2">
-                <c:v>1510</c:v>
+                <c:v>691</c:v>
               </c:pt>
               <c:pt idx="3">
-                <c:v>1568</c:v>
+                <c:v>744</c:v>
               </c:pt>
               <c:pt idx="4">
-                <c:v>1624</c:v>
+                <c:v>802</c:v>
               </c:pt>
               <c:pt idx="5">
-                <c:v>1688</c:v>
+                <c:v>869</c:v>
               </c:pt>
             </c:numLit>
           </c:val>
@@ -1384,22 +1384,22 @@
               <c:formatCode/>
               <c:ptCount val="6"/>
               <c:pt idx="0">
-                <c:v>980</c:v>
+                <c:v>455</c:v>
               </c:pt>
               <c:pt idx="1">
-                <c:v>1020</c:v>
+                <c:v>492</c:v>
               </c:pt>
               <c:pt idx="2">
-                <c:v>1085</c:v>
+                <c:v>548</c:v>
               </c:pt>
               <c:pt idx="3">
-                <c:v>1175</c:v>
+                <c:v>612</c:v>
               </c:pt>
               <c:pt idx="4">
-                <c:v>1250</c:v>
+                <c:v>688</c:v>
               </c:pt>
               <c:pt idx="5">
-                <c:v>1335</c:v>
+                <c:v>772</c:v>
               </c:pt>
             </c:numLit>
           </c:val>
@@ -1540,7 +1540,7 @@
           <p:cNvPr id="1" name="Slide Number Placeholder 5">
             <a:extLst xmlns:a="http://schemas.openxmlformats.org/drawingml/2006/main">
               <a:ext uri="{FF2B5EF4-FFF2-40B4-BE49-F238E27FC236}">
-                <a16:creationId xmlns:a16="http://schemas.microsoft.com/office/drawing/2014/main" id="{F1D126EA-F237-4CFC-A5A9-C2CB178F0336}"/>
+                <a16:creationId xmlns:a16="http://schemas.microsoft.com/office/drawing/2014/main" id="{5D223293-109B-42C6-8AB0-D8D7CB124344}"/>
               </a:ext>
             </a:extLst>
           </p:cNvPr>
@@ -1572,7 +1572,7 @@
           <p:cNvPr id="2" name="">
             <a:extLst xmlns:a="http://schemas.openxmlformats.org/drawingml/2006/main">
               <a:ext uri="{FF2B5EF4-FFF2-40B4-BE49-F238E27FC236}">
-                <a16:creationId xmlns:a16="http://schemas.microsoft.com/office/drawing/2014/main" id="{0987DCDF-B84E-4DF6-8176-E5410B6BE3A8}"/>
+                <a16:creationId xmlns:a16="http://schemas.microsoft.com/office/drawing/2014/main" id="{0A3781F0-8FCA-4AFC-9FE5-3D26C8255B27}"/>
               </a:ext>
             </a:extLst>
           </p:cNvPr>
@@ -1605,7 +1605,7 @@
           <p:cNvPr id="3" name="">
             <a:extLst xmlns:a="http://schemas.openxmlformats.org/drawingml/2006/main">
               <a:ext uri="{FF2B5EF4-FFF2-40B4-BE49-F238E27FC236}">
-                <a16:creationId xmlns:a16="http://schemas.microsoft.com/office/drawing/2014/main" id="{B386ED9E-E036-4EEE-B01E-E6165369BE85}"/>
+                <a16:creationId xmlns:a16="http://schemas.microsoft.com/office/drawing/2014/main" id="{55F0FA05-4A0D-4AEB-84B4-12A5CDF88AA4}"/>
               </a:ext>
             </a:extLst>
           </p:cNvPr>
@@ -1638,7 +1638,7 @@
           <p:cNvPr id="4" name="">
             <a:extLst xmlns:a="http://schemas.openxmlformats.org/drawingml/2006/main">
               <a:ext uri="{FF2B5EF4-FFF2-40B4-BE49-F238E27FC236}">
-                <a16:creationId xmlns:a16="http://schemas.microsoft.com/office/drawing/2014/main" id="{E802159A-C037-495E-9EA3-899DDD1B6689}"/>
+                <a16:creationId xmlns:a16="http://schemas.microsoft.com/office/drawing/2014/main" id="{04FE4868-D9F6-4FD7-9490-42069C3E7D79}"/>
               </a:ext>
             </a:extLst>
           </p:cNvPr>
@@ -1689,7 +1689,7 @@
           <p:cNvPr id="5" name="">
             <a:extLst xmlns:a="http://schemas.openxmlformats.org/drawingml/2006/main">
               <a:ext uri="{FF2B5EF4-FFF2-40B4-BE49-F238E27FC236}">
-                <a16:creationId xmlns:a16="http://schemas.microsoft.com/office/drawing/2014/main" id="{98A31955-1FD8-4B0D-9E98-FCB83FF8B906}"/>
+                <a16:creationId xmlns:a16="http://schemas.microsoft.com/office/drawing/2014/main" id="{C9EB8F67-3244-4E0D-BC38-D3BF1E9748C1}"/>
               </a:ext>
             </a:extLst>
           </p:cNvPr>
@@ -1730,7 +1730,7 @@
                   <a:srgbClr val="334155"/>
                 </a:solidFill>
               </a:rPr>
-              <a:t>Growth and efficiency improved this month, with reliability still the main watch item.</a:t>
+              <a:t>Revenue quality and operating discipline improved this month, with delivery execution still the main watch item.</a:t>
             </a:r>
           </a:p>
         </p:txBody>
@@ -1740,7 +1740,7 @@
           <p:cNvPr id="6" name="">
             <a:extLst xmlns:a="http://schemas.openxmlformats.org/drawingml/2006/main">
               <a:ext uri="{FF2B5EF4-FFF2-40B4-BE49-F238E27FC236}">
-                <a16:creationId xmlns:a16="http://schemas.microsoft.com/office/drawing/2014/main" id="{143ED7E4-901B-4A19-A30B-7CF663C0FB14}"/>
+                <a16:creationId xmlns:a16="http://schemas.microsoft.com/office/drawing/2014/main" id="{E5B44C51-09E6-4371-B173-27C7422EF8D8}"/>
               </a:ext>
             </a:extLst>
           </p:cNvPr>
@@ -1775,7 +1775,7 @@
           <p:cNvPr id="7" name="">
             <a:extLst xmlns:a="http://schemas.openxmlformats.org/drawingml/2006/main">
               <a:ext uri="{FF2B5EF4-FFF2-40B4-BE49-F238E27FC236}">
-                <a16:creationId xmlns:a16="http://schemas.microsoft.com/office/drawing/2014/main" id="{D4D22F85-8C91-4506-BF8F-7D68CBBBAFC5}"/>
+                <a16:creationId xmlns:a16="http://schemas.microsoft.com/office/drawing/2014/main" id="{7DB0D9F7-8B40-46D5-8D14-9530F85807C0}"/>
               </a:ext>
             </a:extLst>
           </p:cNvPr>
@@ -1810,7 +1810,7 @@
           <p:cNvPr id="8" name="">
             <a:extLst xmlns:a="http://schemas.openxmlformats.org/drawingml/2006/main">
               <a:ext uri="{FF2B5EF4-FFF2-40B4-BE49-F238E27FC236}">
-                <a16:creationId xmlns:a16="http://schemas.microsoft.com/office/drawing/2014/main" id="{84EB2626-E3BC-409D-9E76-2ED438558A54}"/>
+                <a16:creationId xmlns:a16="http://schemas.microsoft.com/office/drawing/2014/main" id="{E334DA6C-24D6-4C5B-8CD5-87C35ED22E69}"/>
               </a:ext>
             </a:extLst>
           </p:cNvPr>
@@ -1861,7 +1861,7 @@
           <p:cNvPr id="9" name="">
             <a:extLst xmlns:a="http://schemas.openxmlformats.org/drawingml/2006/main">
               <a:ext uri="{FF2B5EF4-FFF2-40B4-BE49-F238E27FC236}">
-                <a16:creationId xmlns:a16="http://schemas.microsoft.com/office/drawing/2014/main" id="{D3A6345E-E09E-49AD-AD6A-CF6BF6D4448C}"/>
+                <a16:creationId xmlns:a16="http://schemas.microsoft.com/office/drawing/2014/main" id="{45EC46EA-BC00-4CDB-BA19-6BDE03341499}"/>
               </a:ext>
             </a:extLst>
           </p:cNvPr>
@@ -1927,7 +1927,7 @@
           <p:cNvPr id="10" name="">
             <a:extLst xmlns:a="http://schemas.openxmlformats.org/drawingml/2006/main">
               <a:ext uri="{FF2B5EF4-FFF2-40B4-BE49-F238E27FC236}">
-                <a16:creationId xmlns:a16="http://schemas.microsoft.com/office/drawing/2014/main" id="{398EC6DC-1789-4E24-8D1F-C8F7BF312952}"/>
+                <a16:creationId xmlns:a16="http://schemas.microsoft.com/office/drawing/2014/main" id="{6E550C9E-1C1C-414C-B619-8EFC064E5D00}"/>
               </a:ext>
             </a:extLst>
           </p:cNvPr>
@@ -1962,7 +1962,7 @@
           <p:cNvPr id="11" name="">
             <a:extLst xmlns:a="http://schemas.openxmlformats.org/drawingml/2006/main">
               <a:ext uri="{FF2B5EF4-FFF2-40B4-BE49-F238E27FC236}">
-                <a16:creationId xmlns:a16="http://schemas.microsoft.com/office/drawing/2014/main" id="{91B3D336-AFC8-4524-B42C-B3CDA035E2F1}"/>
+                <a16:creationId xmlns:a16="http://schemas.microsoft.com/office/drawing/2014/main" id="{833AACCB-17D4-454E-9D8E-697E7E074CE6}"/>
               </a:ext>
             </a:extLst>
           </p:cNvPr>
@@ -1997,7 +1997,7 @@
           <p:cNvPr id="12" name="">
             <a:extLst xmlns:a="http://schemas.openxmlformats.org/drawingml/2006/main">
               <a:ext uri="{FF2B5EF4-FFF2-40B4-BE49-F238E27FC236}">
-                <a16:creationId xmlns:a16="http://schemas.microsoft.com/office/drawing/2014/main" id="{152F78FE-34CD-4513-AC3A-6243B31A9AE8}"/>
+                <a16:creationId xmlns:a16="http://schemas.microsoft.com/office/drawing/2014/main" id="{F4590EFF-B442-4EF2-B8B4-C1507FFABE51}"/>
               </a:ext>
             </a:extLst>
           </p:cNvPr>
@@ -2048,7 +2048,7 @@
           <p:cNvPr id="13" name="">
             <a:extLst xmlns:a="http://schemas.openxmlformats.org/drawingml/2006/main">
               <a:ext uri="{FF2B5EF4-FFF2-40B4-BE49-F238E27FC236}">
-                <a16:creationId xmlns:a16="http://schemas.microsoft.com/office/drawing/2014/main" id="{6B26FDB9-3511-41FE-8558-07779C88B7A0}"/>
+                <a16:creationId xmlns:a16="http://schemas.microsoft.com/office/drawing/2014/main" id="{F27C1202-5A4B-4720-BEF7-A5E0F17BF8C4}"/>
               </a:ext>
             </a:extLst>
           </p:cNvPr>
@@ -2089,7 +2089,7 @@
                   <a:srgbClr val="334155"/>
                 </a:solidFill>
               </a:rPr>
-              <a:t>ARR reached $1688k and qualified pipeline rose to $1335k, keeping the Q3 growth story credible.</a:t>
+              <a:t>ARR reached $869k and qualified pipeline rose to $772k, supporting the story that the firm is converting bespoke work into a more repeatable advisory business.</a:t>
             </a:r>
           </a:p>
           <a:p xmlns:a="http://schemas.openxmlformats.org/drawingml/2006/main">
@@ -2104,7 +2104,7 @@
                   <a:srgbClr val="334155"/>
                 </a:solidFill>
               </a:rPr>
-              <a:t>Net burn improved to $226k and NRR moved to 114%, which supports the efficiency narrative leadership wants to maintain.</a:t>
+              <a:t>Net burn improved to $121k and NRR moved to 111%, which reinforces the case for disciplined growth without overextending delivery capacity.</a:t>
             </a:r>
           </a:p>
         </p:txBody>
@@ -2114,7 +2114,7 @@
           <p:cNvPr id="14" name="">
             <a:extLst xmlns:a="http://schemas.openxmlformats.org/drawingml/2006/main">
               <a:ext uri="{FF2B5EF4-FFF2-40B4-BE49-F238E27FC236}">
-                <a16:creationId xmlns:a16="http://schemas.microsoft.com/office/drawing/2014/main" id="{07480DB1-D0AA-46D3-A9E5-0742C55477D7}"/>
+                <a16:creationId xmlns:a16="http://schemas.microsoft.com/office/drawing/2014/main" id="{42B69772-D420-4421-9CCD-5D0490C88267}"/>
               </a:ext>
             </a:extLst>
           </p:cNvPr>
@@ -2149,7 +2149,7 @@
           <p:cNvPr id="15" name="">
             <a:extLst xmlns:a="http://schemas.openxmlformats.org/drawingml/2006/main">
               <a:ext uri="{FF2B5EF4-FFF2-40B4-BE49-F238E27FC236}">
-                <a16:creationId xmlns:a16="http://schemas.microsoft.com/office/drawing/2014/main" id="{62D6F971-B892-402B-AFDD-4E494C689BDF}"/>
+                <a16:creationId xmlns:a16="http://schemas.microsoft.com/office/drawing/2014/main" id="{4B587892-2EA1-4699-A78C-A114711CA3AB}"/>
               </a:ext>
             </a:extLst>
           </p:cNvPr>
@@ -2184,7 +2184,7 @@
           <p:cNvPr id="16" name="">
             <a:extLst xmlns:a="http://schemas.openxmlformats.org/drawingml/2006/main">
               <a:ext uri="{FF2B5EF4-FFF2-40B4-BE49-F238E27FC236}">
-                <a16:creationId xmlns:a16="http://schemas.microsoft.com/office/drawing/2014/main" id="{0FA631CB-53CF-4CE1-B2E7-EBCA7A6AFA6B}"/>
+                <a16:creationId xmlns:a16="http://schemas.microsoft.com/office/drawing/2014/main" id="{60C7EBAE-CA1F-4CC2-B707-7E7BAB9E0DAC}"/>
               </a:ext>
             </a:extLst>
           </p:cNvPr>
@@ -2235,7 +2235,7 @@
           <p:cNvPr id="17" name="">
             <a:extLst xmlns:a="http://schemas.openxmlformats.org/drawingml/2006/main">
               <a:ext uri="{FF2B5EF4-FFF2-40B4-BE49-F238E27FC236}">
-                <a16:creationId xmlns:a16="http://schemas.microsoft.com/office/drawing/2014/main" id="{7A3BDB74-45B1-486F-8F00-63D94A9D2224}"/>
+                <a16:creationId xmlns:a16="http://schemas.microsoft.com/office/drawing/2014/main" id="{2D084D67-CF0B-441B-8CEC-D46B1A6EB0EC}"/>
               </a:ext>
             </a:extLst>
           </p:cNvPr>
@@ -2276,7 +2276,7 @@
                   <a:srgbClr val="334155"/>
                 </a:solidFill>
               </a:rPr>
-              <a:t>The main risk remains mobile reliability and enterprise deal friction around security review turnaround.</a:t>
+              <a:t>The main execution risk is one client workshop is blocked until the data room access issue is resolved. • Delivery confidence remains high, but the team needs a named owner for exec stakeholder scheduling. • If we do not unblock the security questionnaire by Friday, the healthcare advisory kickoff will slip by at least one week.</a:t>
             </a:r>
           </a:p>
         </p:txBody>
@@ -2284,7 +2284,7 @@
     </p:spTree>
     <p:extLst>
       <p:ext uri="{BB962C8B-B14F-4D97-AF65-F5344CB8AC3E}">
-        <p14:creationId xmlns:p14="http://schemas.microsoft.com/office/powerpoint/2010/main" val="670442820"/>
+        <p14:creationId xmlns:p14="http://schemas.microsoft.com/office/powerpoint/2010/main" val="245748177"/>
       </p:ext>
     </p:extLst>
   </p:cSld>
@@ -2308,7 +2308,7 @@
           <p:cNvPr id="1" name="Slide Number Placeholder 5">
             <a:extLst xmlns:a="http://schemas.openxmlformats.org/drawingml/2006/main">
               <a:ext uri="{FF2B5EF4-FFF2-40B4-BE49-F238E27FC236}">
-                <a16:creationId xmlns:a16="http://schemas.microsoft.com/office/drawing/2014/main" id="{F1D126EA-F237-4CFC-A5A9-C2CB178F0336}"/>
+                <a16:creationId xmlns:a16="http://schemas.microsoft.com/office/drawing/2014/main" id="{5D223293-109B-42C6-8AB0-D8D7CB124344}"/>
               </a:ext>
             </a:extLst>
           </p:cNvPr>
@@ -2340,7 +2340,7 @@
           <p:cNvPr id="2" name="">
             <a:extLst xmlns:a="http://schemas.openxmlformats.org/drawingml/2006/main">
               <a:ext uri="{FF2B5EF4-FFF2-40B4-BE49-F238E27FC236}">
-                <a16:creationId xmlns:a16="http://schemas.microsoft.com/office/drawing/2014/main" id="{C5A364EC-AE5B-4566-8D96-2202FB638BD7}"/>
+                <a16:creationId xmlns:a16="http://schemas.microsoft.com/office/drawing/2014/main" id="{38BC80C4-C203-4139-BAF2-6C79F16432A5}"/>
               </a:ext>
             </a:extLst>
           </p:cNvPr>
@@ -2373,7 +2373,7 @@
           <p:cNvPr id="3" name="">
             <a:extLst xmlns:a="http://schemas.openxmlformats.org/drawingml/2006/main">
               <a:ext uri="{FF2B5EF4-FFF2-40B4-BE49-F238E27FC236}">
-                <a16:creationId xmlns:a16="http://schemas.microsoft.com/office/drawing/2014/main" id="{2A87045A-5E13-4822-9107-B65734426D6C}"/>
+                <a16:creationId xmlns:a16="http://schemas.microsoft.com/office/drawing/2014/main" id="{A484AD2D-1758-4D96-8EA7-0F3C012FB18A}"/>
               </a:ext>
             </a:extLst>
           </p:cNvPr>
@@ -2406,7 +2406,7 @@
           <p:cNvPr id="4" name="">
             <a:extLst xmlns:a="http://schemas.openxmlformats.org/drawingml/2006/main">
               <a:ext uri="{FF2B5EF4-FFF2-40B4-BE49-F238E27FC236}">
-                <a16:creationId xmlns:a16="http://schemas.microsoft.com/office/drawing/2014/main" id="{44F9F361-ABB3-442F-98A1-2FC6293CC7E6}"/>
+                <a16:creationId xmlns:a16="http://schemas.microsoft.com/office/drawing/2014/main" id="{CA28EA79-649F-4CCF-9FFE-CD21CD1D20A9}"/>
               </a:ext>
             </a:extLst>
           </p:cNvPr>
@@ -2457,7 +2457,7 @@
           <p:cNvPr id="5" name="">
             <a:extLst xmlns:a="http://schemas.openxmlformats.org/drawingml/2006/main">
               <a:ext uri="{FF2B5EF4-FFF2-40B4-BE49-F238E27FC236}">
-                <a16:creationId xmlns:a16="http://schemas.microsoft.com/office/drawing/2014/main" id="{D4BE4CCA-00F9-457E-99E3-9B2BBEE46682}"/>
+                <a16:creationId xmlns:a16="http://schemas.microsoft.com/office/drawing/2014/main" id="{7D455B3C-E4D7-44B9-AC9D-1BFE45BFA77D}"/>
               </a:ext>
             </a:extLst>
           </p:cNvPr>
@@ -2492,7 +2492,7 @@
           <p:cNvPr id="6" name="">
             <a:extLst xmlns:a="http://schemas.openxmlformats.org/drawingml/2006/main">
               <a:ext uri="{FF2B5EF4-FFF2-40B4-BE49-F238E27FC236}">
-                <a16:creationId xmlns:a16="http://schemas.microsoft.com/office/drawing/2014/main" id="{8B3E24E1-0712-4D63-B044-CA323BC146CB}"/>
+                <a16:creationId xmlns:a16="http://schemas.microsoft.com/office/drawing/2014/main" id="{CB8461AA-667F-4468-B339-B96A3F3EED89}"/>
               </a:ext>
             </a:extLst>
           </p:cNvPr>
@@ -2527,7 +2527,7 @@
           <p:cNvPr id="7" name="">
             <a:extLst xmlns:a="http://schemas.openxmlformats.org/drawingml/2006/main">
               <a:ext uri="{FF2B5EF4-FFF2-40B4-BE49-F238E27FC236}">
-                <a16:creationId xmlns:a16="http://schemas.microsoft.com/office/drawing/2014/main" id="{3FB24F9A-92BF-42DB-BCBD-52882DE5E12D}"/>
+                <a16:creationId xmlns:a16="http://schemas.microsoft.com/office/drawing/2014/main" id="{D9F8D4C2-45E7-4D92-9C4E-6332989621E2}"/>
               </a:ext>
             </a:extLst>
           </p:cNvPr>
@@ -2568,7 +2568,7 @@
                   <a:srgbClr val="0F172A"/>
                 </a:solidFill>
               </a:rPr>
-              <a:t>ARR: $1688k</a:t>
+              <a:t>ARR: $869k</a:t>
             </a:r>
           </a:p>
         </p:txBody>
@@ -2578,7 +2578,7 @@
           <p:cNvPr id="8" name="">
             <a:extLst xmlns:a="http://schemas.openxmlformats.org/drawingml/2006/main">
               <a:ext uri="{FF2B5EF4-FFF2-40B4-BE49-F238E27FC236}">
-                <a16:creationId xmlns:a16="http://schemas.microsoft.com/office/drawing/2014/main" id="{AA5E7FBC-C2B8-461E-9D00-A34CB1E7AC20}"/>
+                <a16:creationId xmlns:a16="http://schemas.microsoft.com/office/drawing/2014/main" id="{5FFBE6E2-3E37-4733-A785-DBB929FE6EFF}"/>
               </a:ext>
             </a:extLst>
           </p:cNvPr>
@@ -2619,7 +2619,7 @@
                   <a:srgbClr val="334155"/>
                 </a:solidFill>
               </a:rPr>
-              <a:t>+64k vs last month</a:t>
+              <a:t>+67k vs last month</a:t>
             </a:r>
           </a:p>
         </p:txBody>
@@ -2629,7 +2629,7 @@
           <p:cNvPr id="9" name="">
             <a:extLst xmlns:a="http://schemas.openxmlformats.org/drawingml/2006/main">
               <a:ext uri="{FF2B5EF4-FFF2-40B4-BE49-F238E27FC236}">
-                <a16:creationId xmlns:a16="http://schemas.microsoft.com/office/drawing/2014/main" id="{984B35EF-5F34-465E-ABFA-0EA070CD182A}"/>
+                <a16:creationId xmlns:a16="http://schemas.microsoft.com/office/drawing/2014/main" id="{D2D17847-83DB-4AAE-B21E-6BB2B6739A5F}"/>
               </a:ext>
             </a:extLst>
           </p:cNvPr>
@@ -2664,7 +2664,7 @@
           <p:cNvPr id="10" name="">
             <a:extLst xmlns:a="http://schemas.openxmlformats.org/drawingml/2006/main">
               <a:ext uri="{FF2B5EF4-FFF2-40B4-BE49-F238E27FC236}">
-                <a16:creationId xmlns:a16="http://schemas.microsoft.com/office/drawing/2014/main" id="{4C4E2D69-154B-4DDB-8D96-213E91F369F9}"/>
+                <a16:creationId xmlns:a16="http://schemas.microsoft.com/office/drawing/2014/main" id="{2B422620-C1DA-4027-BA06-1BD67F3C4B0E}"/>
               </a:ext>
             </a:extLst>
           </p:cNvPr>
@@ -2699,7 +2699,7 @@
           <p:cNvPr id="11" name="">
             <a:extLst xmlns:a="http://schemas.openxmlformats.org/drawingml/2006/main">
               <a:ext uri="{FF2B5EF4-FFF2-40B4-BE49-F238E27FC236}">
-                <a16:creationId xmlns:a16="http://schemas.microsoft.com/office/drawing/2014/main" id="{9E2036D6-ADE2-47C8-BEF6-F7855B4C5DBD}"/>
+                <a16:creationId xmlns:a16="http://schemas.microsoft.com/office/drawing/2014/main" id="{8F137EC0-EE84-4CA2-A4FE-BA02F6C77171}"/>
               </a:ext>
             </a:extLst>
           </p:cNvPr>
@@ -2740,7 +2740,7 @@
                   <a:srgbClr val="0F172A"/>
                 </a:solidFill>
               </a:rPr>
-              <a:t>Qualified Pipeline: $1335k</a:t>
+              <a:t>Qualified Pipeline: $772k</a:t>
             </a:r>
           </a:p>
         </p:txBody>
@@ -2750,7 +2750,7 @@
           <p:cNvPr id="12" name="">
             <a:extLst xmlns:a="http://schemas.openxmlformats.org/drawingml/2006/main">
               <a:ext uri="{FF2B5EF4-FFF2-40B4-BE49-F238E27FC236}">
-                <a16:creationId xmlns:a16="http://schemas.microsoft.com/office/drawing/2014/main" id="{612E18A4-AA02-49FC-BB90-8663F29A3B53}"/>
+                <a16:creationId xmlns:a16="http://schemas.microsoft.com/office/drawing/2014/main" id="{9E0DABDB-27B3-4FD6-8D7D-F85972763215}"/>
               </a:ext>
             </a:extLst>
           </p:cNvPr>
@@ -2791,7 +2791,7 @@
                   <a:srgbClr val="334155"/>
                 </a:solidFill>
               </a:rPr>
-              <a:t>+85k vs last month</a:t>
+              <a:t>+84k vs last month</a:t>
             </a:r>
           </a:p>
         </p:txBody>
@@ -2801,7 +2801,7 @@
           <p:cNvPr id="13" name="">
             <a:extLst xmlns:a="http://schemas.openxmlformats.org/drawingml/2006/main">
               <a:ext uri="{FF2B5EF4-FFF2-40B4-BE49-F238E27FC236}">
-                <a16:creationId xmlns:a16="http://schemas.microsoft.com/office/drawing/2014/main" id="{876338E6-418B-4659-9938-F6AD8E61D88D}"/>
+                <a16:creationId xmlns:a16="http://schemas.microsoft.com/office/drawing/2014/main" id="{B92734BE-877E-42FB-9876-CDA90276DE20}"/>
               </a:ext>
             </a:extLst>
           </p:cNvPr>
@@ -2836,7 +2836,7 @@
           <p:cNvPr id="14" name="">
             <a:extLst xmlns:a="http://schemas.openxmlformats.org/drawingml/2006/main">
               <a:ext uri="{FF2B5EF4-FFF2-40B4-BE49-F238E27FC236}">
-                <a16:creationId xmlns:a16="http://schemas.microsoft.com/office/drawing/2014/main" id="{1FD9A96E-8BF0-478C-821C-93A120DC2A5B}"/>
+                <a16:creationId xmlns:a16="http://schemas.microsoft.com/office/drawing/2014/main" id="{3C03890E-DBE1-478C-965C-60FF51201334}"/>
               </a:ext>
             </a:extLst>
           </p:cNvPr>
@@ -2871,7 +2871,7 @@
           <p:cNvPr id="15" name="">
             <a:extLst xmlns:a="http://schemas.openxmlformats.org/drawingml/2006/main">
               <a:ext uri="{FF2B5EF4-FFF2-40B4-BE49-F238E27FC236}">
-                <a16:creationId xmlns:a16="http://schemas.microsoft.com/office/drawing/2014/main" id="{BB5AA220-8F57-4B2E-B8AA-C8A72170C3D5}"/>
+                <a16:creationId xmlns:a16="http://schemas.microsoft.com/office/drawing/2014/main" id="{0EC5EA1E-F4B0-4542-A7EC-5444E244DEA3}"/>
               </a:ext>
             </a:extLst>
           </p:cNvPr>
@@ -2912,7 +2912,7 @@
                   <a:srgbClr val="0F172A"/>
                 </a:solidFill>
               </a:rPr>
-              <a:t>Net Burn: $226k</a:t>
+              <a:t>Net Burn: $121k</a:t>
             </a:r>
           </a:p>
         </p:txBody>
@@ -2922,7 +2922,7 @@
           <p:cNvPr id="16" name="">
             <a:extLst xmlns:a="http://schemas.openxmlformats.org/drawingml/2006/main">
               <a:ext uri="{FF2B5EF4-FFF2-40B4-BE49-F238E27FC236}">
-                <a16:creationId xmlns:a16="http://schemas.microsoft.com/office/drawing/2014/main" id="{B33AB68A-476C-458B-B8F1-3099D6C52175}"/>
+                <a16:creationId xmlns:a16="http://schemas.microsoft.com/office/drawing/2014/main" id="{E6DD502A-3CE5-466E-9ED0-D03131AE54EB}"/>
               </a:ext>
             </a:extLst>
           </p:cNvPr>
@@ -2973,7 +2973,7 @@
           <p:cNvPr id="17" name="">
             <a:extLst xmlns:a="http://schemas.openxmlformats.org/drawingml/2006/main">
               <a:ext uri="{FF2B5EF4-FFF2-40B4-BE49-F238E27FC236}">
-                <a16:creationId xmlns:a16="http://schemas.microsoft.com/office/drawing/2014/main" id="{B9965678-4D23-4254-9ABA-227E395F4E9A}"/>
+                <a16:creationId xmlns:a16="http://schemas.microsoft.com/office/drawing/2014/main" id="{E821054D-8A80-4969-9A6D-253F662B5243}"/>
               </a:ext>
             </a:extLst>
           </p:cNvPr>
@@ -3008,7 +3008,7 @@
           <p:cNvPr id="18" name="">
             <a:extLst xmlns:a="http://schemas.openxmlformats.org/drawingml/2006/main">
               <a:ext uri="{FF2B5EF4-FFF2-40B4-BE49-F238E27FC236}">
-                <a16:creationId xmlns:a16="http://schemas.microsoft.com/office/drawing/2014/main" id="{53C1E8EF-EDFE-4C38-9CF9-6A39998612F6}"/>
+                <a16:creationId xmlns:a16="http://schemas.microsoft.com/office/drawing/2014/main" id="{26448ABD-5C64-439D-8DA6-105F3D5695B0}"/>
               </a:ext>
             </a:extLst>
           </p:cNvPr>
@@ -3043,7 +3043,7 @@
           <p:cNvPr id="19" name="">
             <a:extLst xmlns:a="http://schemas.openxmlformats.org/drawingml/2006/main">
               <a:ext uri="{FF2B5EF4-FFF2-40B4-BE49-F238E27FC236}">
-                <a16:creationId xmlns:a16="http://schemas.microsoft.com/office/drawing/2014/main" id="{9C6EC0FB-6F7D-4366-836E-770437C125CC}"/>
+                <a16:creationId xmlns:a16="http://schemas.microsoft.com/office/drawing/2014/main" id="{098E9D27-9703-4480-881A-E5BE972EC813}"/>
               </a:ext>
             </a:extLst>
           </p:cNvPr>
@@ -3084,7 +3084,7 @@
                   <a:srgbClr val="0F172A"/>
                 </a:solidFill>
               </a:rPr>
-              <a:t>NRR: 114%</a:t>
+              <a:t>NRR: 111%</a:t>
             </a:r>
           </a:p>
         </p:txBody>
@@ -3094,7 +3094,7 @@
           <p:cNvPr id="20" name="">
             <a:extLst xmlns:a="http://schemas.openxmlformats.org/drawingml/2006/main">
               <a:ext uri="{FF2B5EF4-FFF2-40B4-BE49-F238E27FC236}">
-                <a16:creationId xmlns:a16="http://schemas.microsoft.com/office/drawing/2014/main" id="{C17B650D-CD6D-42F8-BD55-418918E54581}"/>
+                <a16:creationId xmlns:a16="http://schemas.microsoft.com/office/drawing/2014/main" id="{977EA8C3-E65D-43BF-A402-4BDC88A0AEFE}"/>
               </a:ext>
             </a:extLst>
           </p:cNvPr>
@@ -3135,7 +3135,7 @@
                   <a:srgbClr val="334155"/>
                 </a:solidFill>
               </a:rPr>
-              <a:t>+1 pts vs last month</a:t>
+              <a:t>+2 pts vs last month</a:t>
             </a:r>
           </a:p>
         </p:txBody>
@@ -3145,7 +3145,7 @@
           <p:cNvPr id="21" name="">
             <a:extLst xmlns:a="http://schemas.openxmlformats.org/drawingml/2006/main">
               <a:ext uri="{FF2B5EF4-FFF2-40B4-BE49-F238E27FC236}">
-                <a16:creationId xmlns:a16="http://schemas.microsoft.com/office/drawing/2014/main" id="{0897A920-002B-4D9B-AB32-C5BC453DB0BE}"/>
+                <a16:creationId xmlns:a16="http://schemas.microsoft.com/office/drawing/2014/main" id="{ABC893CF-0274-4922-8856-7CFD3002D19B}"/>
               </a:ext>
             </a:extLst>
           </p:cNvPr>
@@ -3180,7 +3180,7 @@
           <p:cNvPr id="22" name="">
             <a:extLst xmlns:a="http://schemas.openxmlformats.org/drawingml/2006/main">
               <a:ext uri="{FF2B5EF4-FFF2-40B4-BE49-F238E27FC236}">
-                <a16:creationId xmlns:a16="http://schemas.microsoft.com/office/drawing/2014/main" id="{AACDB8C6-841D-42B8-9616-E82F591B5467}"/>
+                <a16:creationId xmlns:a16="http://schemas.microsoft.com/office/drawing/2014/main" id="{EA84484A-8CE3-4ADC-A6EB-2D8B403FCB92}"/>
               </a:ext>
             </a:extLst>
           </p:cNvPr>
@@ -3215,7 +3215,7 @@
           <p:cNvPr id="23" name="">
             <a:extLst xmlns:a="http://schemas.openxmlformats.org/drawingml/2006/main">
               <a:ext uri="{FF2B5EF4-FFF2-40B4-BE49-F238E27FC236}">
-                <a16:creationId xmlns:a16="http://schemas.microsoft.com/office/drawing/2014/main" id="{794BD002-43AA-4C2B-8E89-09FA7D8E321C}"/>
+                <a16:creationId xmlns:a16="http://schemas.microsoft.com/office/drawing/2014/main" id="{AB9F4486-806E-434A-B2A1-49611B347D9C}"/>
               </a:ext>
             </a:extLst>
           </p:cNvPr>
@@ -3256,7 +3256,7 @@
                   <a:srgbClr val="0F172A"/>
                 </a:solidFill>
               </a:rPr>
-              <a:t>Sev-1 Incidents: 1</a:t>
+              <a:t>Sev-1 Incidents: 0</a:t>
             </a:r>
           </a:p>
         </p:txBody>
@@ -3266,7 +3266,7 @@
           <p:cNvPr id="24" name="">
             <a:extLst xmlns:a="http://schemas.openxmlformats.org/drawingml/2006/main">
               <a:ext uri="{FF2B5EF4-FFF2-40B4-BE49-F238E27FC236}">
-                <a16:creationId xmlns:a16="http://schemas.microsoft.com/office/drawing/2014/main" id="{5CEDA10A-D0B2-4538-BFEA-2706060544E9}"/>
+                <a16:creationId xmlns:a16="http://schemas.microsoft.com/office/drawing/2014/main" id="{E462FAB2-F511-4784-9D17-3347778595BC}"/>
               </a:ext>
             </a:extLst>
           </p:cNvPr>
@@ -3307,7 +3307,7 @@
                   <a:srgbClr val="334155"/>
                 </a:solidFill>
               </a:rPr>
-              <a:t>+1 incident improvement</a:t>
+              <a:t>0 incident improvement</a:t>
             </a:r>
           </a:p>
         </p:txBody>
@@ -3315,7 +3315,7 @@
     </p:spTree>
     <p:extLst>
       <p:ext uri="{BB962C8B-B14F-4D97-AF65-F5344CB8AC3E}">
-        <p14:creationId xmlns:p14="http://schemas.microsoft.com/office/powerpoint/2010/main" val="339881175"/>
+        <p14:creationId xmlns:p14="http://schemas.microsoft.com/office/powerpoint/2010/main" val="57297720"/>
       </p:ext>
     </p:extLst>
   </p:cSld>
@@ -3339,7 +3339,7 @@
           <p:cNvPr id="1" name="Slide Number Placeholder 5">
             <a:extLst xmlns:a="http://schemas.openxmlformats.org/drawingml/2006/main">
               <a:ext uri="{FF2B5EF4-FFF2-40B4-BE49-F238E27FC236}">
-                <a16:creationId xmlns:a16="http://schemas.microsoft.com/office/drawing/2014/main" id="{F1D126EA-F237-4CFC-A5A9-C2CB178F0336}"/>
+                <a16:creationId xmlns:a16="http://schemas.microsoft.com/office/drawing/2014/main" id="{5D223293-109B-42C6-8AB0-D8D7CB124344}"/>
               </a:ext>
             </a:extLst>
           </p:cNvPr>
@@ -3371,7 +3371,7 @@
           <p:cNvPr id="2" name="">
             <a:extLst xmlns:a="http://schemas.openxmlformats.org/drawingml/2006/main">
               <a:ext uri="{FF2B5EF4-FFF2-40B4-BE49-F238E27FC236}">
-                <a16:creationId xmlns:a16="http://schemas.microsoft.com/office/drawing/2014/main" id="{4A006DA8-958B-4AFA-9E7F-A3A388CF05F4}"/>
+                <a16:creationId xmlns:a16="http://schemas.microsoft.com/office/drawing/2014/main" id="{C9676BBA-214D-4F89-B244-E137D6A3F2E5}"/>
               </a:ext>
             </a:extLst>
           </p:cNvPr>
@@ -3404,7 +3404,7 @@
           <p:cNvPr id="3" name="">
             <a:extLst xmlns:a="http://schemas.openxmlformats.org/drawingml/2006/main">
               <a:ext uri="{FF2B5EF4-FFF2-40B4-BE49-F238E27FC236}">
-                <a16:creationId xmlns:a16="http://schemas.microsoft.com/office/drawing/2014/main" id="{0CCB82D7-0035-48C1-8149-49BFF3838316}"/>
+                <a16:creationId xmlns:a16="http://schemas.microsoft.com/office/drawing/2014/main" id="{F22081A1-99DB-4842-880C-1016E5FDF238}"/>
               </a:ext>
             </a:extLst>
           </p:cNvPr>
@@ -3437,7 +3437,7 @@
           <p:cNvPr id="4" name="">
             <a:extLst xmlns:a="http://schemas.openxmlformats.org/drawingml/2006/main">
               <a:ext uri="{FF2B5EF4-FFF2-40B4-BE49-F238E27FC236}">
-                <a16:creationId xmlns:a16="http://schemas.microsoft.com/office/drawing/2014/main" id="{6843E09A-2AFF-4D3E-AC87-2F4F3895C763}"/>
+                <a16:creationId xmlns:a16="http://schemas.microsoft.com/office/drawing/2014/main" id="{C455E503-DAFF-4836-B692-13172814CBB5}"/>
               </a:ext>
             </a:extLst>
           </p:cNvPr>
@@ -3488,7 +3488,7 @@
           <p:cNvPr id="5" name="">
             <a:extLst xmlns:a="http://schemas.openxmlformats.org/drawingml/2006/main">
               <a:ext uri="{FF2B5EF4-FFF2-40B4-BE49-F238E27FC236}">
-                <a16:creationId xmlns:a16="http://schemas.microsoft.com/office/drawing/2014/main" id="{B325E1B7-08A5-4623-89C2-B8EC06867E67}"/>
+                <a16:creationId xmlns:a16="http://schemas.microsoft.com/office/drawing/2014/main" id="{4030EF7B-8CDF-4451-8DF9-46763946A4A9}"/>
               </a:ext>
             </a:extLst>
           </p:cNvPr>
@@ -3523,7 +3523,7 @@
           <p:cNvPr id="6" name="">
             <a:extLst xmlns:a="http://schemas.openxmlformats.org/drawingml/2006/main">
               <a:ext uri="{FF2B5EF4-FFF2-40B4-BE49-F238E27FC236}">
-                <a16:creationId xmlns:a16="http://schemas.microsoft.com/office/drawing/2014/main" id="{69160C03-EA7A-4201-975F-5732085C42E5}"/>
+                <a16:creationId xmlns:a16="http://schemas.microsoft.com/office/drawing/2014/main" id="{5B6DE600-A906-4518-8205-7AD7F8B0AA4F}"/>
               </a:ext>
             </a:extLst>
           </p:cNvPr>
@@ -3558,7 +3558,7 @@
           <p:cNvPr id="7" name="">
             <a:extLst xmlns:a="http://schemas.openxmlformats.org/drawingml/2006/main">
               <a:ext uri="{FF2B5EF4-FFF2-40B4-BE49-F238E27FC236}">
-                <a16:creationId xmlns:a16="http://schemas.microsoft.com/office/drawing/2014/main" id="{91A16014-DC2F-4D75-8E22-7141BCF8F5CB}"/>
+                <a16:creationId xmlns:a16="http://schemas.microsoft.com/office/drawing/2014/main" id="{F21958C0-935E-48C3-9C1B-E5ECBFCF0A82}"/>
               </a:ext>
             </a:extLst>
           </p:cNvPr>
@@ -3609,7 +3609,7 @@
           <p:cNvPr id="8" name="">
             <a:extLst xmlns:a="http://schemas.openxmlformats.org/drawingml/2006/main">
               <a:ext uri="{FF2B5EF4-FFF2-40B4-BE49-F238E27FC236}">
-                <a16:creationId xmlns:a16="http://schemas.microsoft.com/office/drawing/2014/main" id="{461CF8A5-91EF-484F-BBEE-C324A2AE83E6}"/>
+                <a16:creationId xmlns:a16="http://schemas.microsoft.com/office/drawing/2014/main" id="{239058D4-E00D-4C27-8D6C-550F1891DF25}"/>
               </a:ext>
             </a:extLst>
           </p:cNvPr>
@@ -3650,7 +3650,7 @@
                   <a:srgbClr val="334155"/>
                 </a:solidFill>
               </a:rPr>
-              <a:t>ARR reached $1688k and qualified pipeline rose to $1335k, keeping the Q3 growth story credible.</a:t>
+              <a:t>ARR reached $869k and qualified pipeline rose to $772k, supporting the story that the firm is converting bespoke work into a more repeatable advisory business.</a:t>
             </a:r>
           </a:p>
           <a:p xmlns:a="http://schemas.openxmlformats.org/drawingml/2006/main">
@@ -3665,7 +3665,7 @@
                   <a:srgbClr val="334155"/>
                 </a:solidFill>
               </a:rPr>
-              <a:t>Net burn improved to $226k and NRR moved to 114%, which supports the efficiency narrative leadership wants to maintain.</a:t>
+              <a:t>Net burn improved to $121k and NRR moved to 111%, which reinforces the case for disciplined growth without overextending delivery capacity.</a:t>
             </a:r>
           </a:p>
           <a:p xmlns:a="http://schemas.openxmlformats.org/drawingml/2006/main">
@@ -3680,7 +3680,7 @@
                   <a:srgbClr val="334155"/>
                 </a:solidFill>
               </a:rPr>
-              <a:t>The main risk remains mobile reliability and enterprise deal friction around security review turnaround.</a:t>
+              <a:t>The main execution risk is one client workshop is blocked until the data room access issue is resolved. • Delivery confidence remains high, but the team needs a named owner for exec stakeholder scheduling. • If we do not unblock the security questionnaire by Friday, the healthcare advisory kickoff will slip by at least one week.</a:t>
             </a:r>
           </a:p>
         </p:txBody>
@@ -3697,14 +3697,14 @@
         </p:xfrm>
         <a:graphic xmlns:a="http://schemas.openxmlformats.org/drawingml/2006/main">
           <a:graphicData uri="http://schemas.openxmlformats.org/drawingml/2006/chart">
-            <c:chart xmlns:r="http://schemas.openxmlformats.org/officeDocument/2006/relationships" xmlns:c="http://schemas.openxmlformats.org/drawingml/2006/chart" r:id="Rc67adba7f7e74a8d"/>
+            <c:chart xmlns:r="http://schemas.openxmlformats.org/officeDocument/2006/relationships" xmlns:c="http://schemas.openxmlformats.org/drawingml/2006/chart" r:id="R63e2389fe59a4c46"/>
           </a:graphicData>
         </a:graphic>
       </p:graphicFrame>
     </p:spTree>
     <p:extLst>
       <p:ext uri="{BB962C8B-B14F-4D97-AF65-F5344CB8AC3E}">
-        <p14:creationId xmlns:p14="http://schemas.microsoft.com/office/powerpoint/2010/main" val="261350008"/>
+        <p14:creationId xmlns:p14="http://schemas.microsoft.com/office/powerpoint/2010/main" val="1619587801"/>
       </p:ext>
     </p:extLst>
   </p:cSld>
@@ -3728,7 +3728,7 @@
           <p:cNvPr id="1" name="Slide Number Placeholder 5">
             <a:extLst xmlns:a="http://schemas.openxmlformats.org/drawingml/2006/main">
               <a:ext uri="{FF2B5EF4-FFF2-40B4-BE49-F238E27FC236}">
-                <a16:creationId xmlns:a16="http://schemas.microsoft.com/office/drawing/2014/main" id="{F1D126EA-F237-4CFC-A5A9-C2CB178F0336}"/>
+                <a16:creationId xmlns:a16="http://schemas.microsoft.com/office/drawing/2014/main" id="{5D223293-109B-42C6-8AB0-D8D7CB124344}"/>
               </a:ext>
             </a:extLst>
           </p:cNvPr>
@@ -3760,7 +3760,7 @@
           <p:cNvPr id="2" name="">
             <a:extLst xmlns:a="http://schemas.openxmlformats.org/drawingml/2006/main">
               <a:ext uri="{FF2B5EF4-FFF2-40B4-BE49-F238E27FC236}">
-                <a16:creationId xmlns:a16="http://schemas.microsoft.com/office/drawing/2014/main" id="{75926342-9A1A-48D7-AFFB-88585D7A9FE2}"/>
+                <a16:creationId xmlns:a16="http://schemas.microsoft.com/office/drawing/2014/main" id="{63A083E6-1513-47F9-B45F-9186B0E53090}"/>
               </a:ext>
             </a:extLst>
           </p:cNvPr>
@@ -3793,7 +3793,7 @@
           <p:cNvPr id="3" name="">
             <a:extLst xmlns:a="http://schemas.openxmlformats.org/drawingml/2006/main">
               <a:ext uri="{FF2B5EF4-FFF2-40B4-BE49-F238E27FC236}">
-                <a16:creationId xmlns:a16="http://schemas.microsoft.com/office/drawing/2014/main" id="{44B78141-DE80-4CB1-9982-F61419B4263D}"/>
+                <a16:creationId xmlns:a16="http://schemas.microsoft.com/office/drawing/2014/main" id="{B492D29D-423F-4850-B8F5-036A8CA0CBB8}"/>
               </a:ext>
             </a:extLst>
           </p:cNvPr>
@@ -3826,7 +3826,7 @@
           <p:cNvPr id="4" name="">
             <a:extLst xmlns:a="http://schemas.openxmlformats.org/drawingml/2006/main">
               <a:ext uri="{FF2B5EF4-FFF2-40B4-BE49-F238E27FC236}">
-                <a16:creationId xmlns:a16="http://schemas.microsoft.com/office/drawing/2014/main" id="{AEC97227-4274-4266-928D-51AA12543386}"/>
+                <a16:creationId xmlns:a16="http://schemas.microsoft.com/office/drawing/2014/main" id="{2C0F4EAD-F84B-40F4-B780-A433DB2F3056}"/>
               </a:ext>
             </a:extLst>
           </p:cNvPr>
@@ -3877,7 +3877,7 @@
           <p:cNvPr id="5" name="">
             <a:extLst xmlns:a="http://schemas.openxmlformats.org/drawingml/2006/main">
               <a:ext uri="{FF2B5EF4-FFF2-40B4-BE49-F238E27FC236}">
-                <a16:creationId xmlns:a16="http://schemas.microsoft.com/office/drawing/2014/main" id="{338ED2F9-37D1-4FE2-A677-834757E5281C}"/>
+                <a16:creationId xmlns:a16="http://schemas.microsoft.com/office/drawing/2014/main" id="{46DDFE6C-0BAA-4A70-A29D-73A597FDB7CE}"/>
               </a:ext>
             </a:extLst>
           </p:cNvPr>
@@ -3912,7 +3912,7 @@
           <p:cNvPr id="6" name="">
             <a:extLst xmlns:a="http://schemas.openxmlformats.org/drawingml/2006/main">
               <a:ext uri="{FF2B5EF4-FFF2-40B4-BE49-F238E27FC236}">
-                <a16:creationId xmlns:a16="http://schemas.microsoft.com/office/drawing/2014/main" id="{B79A0952-99EF-4489-B851-4D1AE84ABA7E}"/>
+                <a16:creationId xmlns:a16="http://schemas.microsoft.com/office/drawing/2014/main" id="{6D110E49-495C-40D5-AC0F-D203694B21EA}"/>
               </a:ext>
             </a:extLst>
           </p:cNvPr>
@@ -3947,7 +3947,7 @@
           <p:cNvPr id="7" name="">
             <a:extLst xmlns:a="http://schemas.openxmlformats.org/drawingml/2006/main">
               <a:ext uri="{FF2B5EF4-FFF2-40B4-BE49-F238E27FC236}">
-                <a16:creationId xmlns:a16="http://schemas.microsoft.com/office/drawing/2014/main" id="{8E350CA4-E25D-49A5-8C04-1D7B964B72A3}"/>
+                <a16:creationId xmlns:a16="http://schemas.microsoft.com/office/drawing/2014/main" id="{D6730C82-F679-4793-82D1-8651358A9517}"/>
               </a:ext>
             </a:extLst>
           </p:cNvPr>
@@ -3998,7 +3998,7 @@
           <p:cNvPr id="8" name="">
             <a:extLst xmlns:a="http://schemas.openxmlformats.org/drawingml/2006/main">
               <a:ext uri="{FF2B5EF4-FFF2-40B4-BE49-F238E27FC236}">
-                <a16:creationId xmlns:a16="http://schemas.microsoft.com/office/drawing/2014/main" id="{5A4124B4-24D1-4E27-B88B-2F8340A44CB2}"/>
+                <a16:creationId xmlns:a16="http://schemas.microsoft.com/office/drawing/2014/main" id="{6F90E17C-0F9C-4CBF-B5A3-431CEE10251F}"/>
               </a:ext>
             </a:extLst>
           </p:cNvPr>
@@ -4079,7 +4079,7 @@
           <p:cNvPr id="9" name="">
             <a:extLst xmlns:a="http://schemas.openxmlformats.org/drawingml/2006/main">
               <a:ext uri="{FF2B5EF4-FFF2-40B4-BE49-F238E27FC236}">
-                <a16:creationId xmlns:a16="http://schemas.microsoft.com/office/drawing/2014/main" id="{6FAF8F4E-D783-4243-A81D-025E3E87A977}"/>
+                <a16:creationId xmlns:a16="http://schemas.microsoft.com/office/drawing/2014/main" id="{65006206-13C0-437F-8139-8F19E66D2EB2}"/>
               </a:ext>
             </a:extLst>
           </p:cNvPr>
@@ -4114,7 +4114,7 @@
           <p:cNvPr id="10" name="">
             <a:extLst xmlns:a="http://schemas.openxmlformats.org/drawingml/2006/main">
               <a:ext uri="{FF2B5EF4-FFF2-40B4-BE49-F238E27FC236}">
-                <a16:creationId xmlns:a16="http://schemas.microsoft.com/office/drawing/2014/main" id="{E399C8DE-CF7F-42F8-BD96-7A4D48403E2C}"/>
+                <a16:creationId xmlns:a16="http://schemas.microsoft.com/office/drawing/2014/main" id="{B924A253-5342-4425-8166-BA6EBF30683B}"/>
               </a:ext>
             </a:extLst>
           </p:cNvPr>
@@ -4149,7 +4149,7 @@
           <p:cNvPr id="11" name="">
             <a:extLst xmlns:a="http://schemas.openxmlformats.org/drawingml/2006/main">
               <a:ext uri="{FF2B5EF4-FFF2-40B4-BE49-F238E27FC236}">
-                <a16:creationId xmlns:a16="http://schemas.microsoft.com/office/drawing/2014/main" id="{DAD7801E-5C98-470B-8A20-8437843DC558}"/>
+                <a16:creationId xmlns:a16="http://schemas.microsoft.com/office/drawing/2014/main" id="{71F7B85D-B015-4F6F-873D-246408074608}"/>
               </a:ext>
             </a:extLst>
           </p:cNvPr>
@@ -4200,7 +4200,7 @@
           <p:cNvPr id="12" name="">
             <a:extLst xmlns:a="http://schemas.openxmlformats.org/drawingml/2006/main">
               <a:ext uri="{FF2B5EF4-FFF2-40B4-BE49-F238E27FC236}">
-                <a16:creationId xmlns:a16="http://schemas.microsoft.com/office/drawing/2014/main" id="{E0713459-34E7-4D46-9315-9D8DEB1A2DD2}"/>
+                <a16:creationId xmlns:a16="http://schemas.microsoft.com/office/drawing/2014/main" id="{04D6FD8E-CC15-448B-9489-684D2E5D81EE}"/>
               </a:ext>
             </a:extLst>
           </p:cNvPr>
@@ -4256,22 +4256,7 @@
                   <a:srgbClr val="334155"/>
                 </a:solidFill>
               </a:rPr>
-              <a:t>2. Open issue #5: Risk: Live channel quality can overwhelm executive-briefing signal</a:t>
-            </a:r>
-          </a:p>
-          <a:p xmlns:a="http://schemas.openxmlformats.org/drawingml/2006/main">
-            <a:r>
-              <a:t/>
-            </a:r>
-          </a:p>
-          <a:p xmlns:a="http://schemas.openxmlformats.org/drawingml/2006/main">
-            <a:r>
-              <a:rPr sz="1200" b="0">
-                <a:solidFill>
-                  <a:srgbClr val="334155"/>
-                </a:solidFill>
-              </a:rPr>
-              <a:t>3. Open issue #4: Future idea: Add client-ready QBR output mode</a:t>
+              <a:t>2. Risk #5: Risk: Live channel quality can overwhelm executive-briefing signal</a:t>
             </a:r>
           </a:p>
         </p:txBody>
@@ -4279,7 +4264,7 @@
     </p:spTree>
     <p:extLst>
       <p:ext uri="{BB962C8B-B14F-4D97-AF65-F5344CB8AC3E}">
-        <p14:creationId xmlns:p14="http://schemas.microsoft.com/office/powerpoint/2010/main" val="1760353765"/>
+        <p14:creationId xmlns:p14="http://schemas.microsoft.com/office/powerpoint/2010/main" val="679248278"/>
       </p:ext>
     </p:extLst>
   </p:cSld>
@@ -4303,7 +4288,7 @@
           <p:cNvPr id="1" name="Slide Number Placeholder 5">
             <a:extLst xmlns:a="http://schemas.openxmlformats.org/drawingml/2006/main">
               <a:ext uri="{FF2B5EF4-FFF2-40B4-BE49-F238E27FC236}">
-                <a16:creationId xmlns:a16="http://schemas.microsoft.com/office/drawing/2014/main" id="{F1D126EA-F237-4CFC-A5A9-C2CB178F0336}"/>
+                <a16:creationId xmlns:a16="http://schemas.microsoft.com/office/drawing/2014/main" id="{5D223293-109B-42C6-8AB0-D8D7CB124344}"/>
               </a:ext>
             </a:extLst>
           </p:cNvPr>
@@ -4335,7 +4320,7 @@
           <p:cNvPr id="2" name="">
             <a:extLst xmlns:a="http://schemas.openxmlformats.org/drawingml/2006/main">
               <a:ext uri="{FF2B5EF4-FFF2-40B4-BE49-F238E27FC236}">
-                <a16:creationId xmlns:a16="http://schemas.microsoft.com/office/drawing/2014/main" id="{F15F958A-7E72-4AEC-A905-11EE8BE24689}"/>
+                <a16:creationId xmlns:a16="http://schemas.microsoft.com/office/drawing/2014/main" id="{D72A2F1D-069D-40C7-841E-FFE4C769EC65}"/>
               </a:ext>
             </a:extLst>
           </p:cNvPr>
@@ -4368,7 +4353,7 @@
           <p:cNvPr id="3" name="">
             <a:extLst xmlns:a="http://schemas.openxmlformats.org/drawingml/2006/main">
               <a:ext uri="{FF2B5EF4-FFF2-40B4-BE49-F238E27FC236}">
-                <a16:creationId xmlns:a16="http://schemas.microsoft.com/office/drawing/2014/main" id="{639568F3-5497-4913-9D42-22A7C414B4BB}"/>
+                <a16:creationId xmlns:a16="http://schemas.microsoft.com/office/drawing/2014/main" id="{81569CEC-5F5D-49E0-A89D-C8CEC2414552}"/>
               </a:ext>
             </a:extLst>
           </p:cNvPr>
@@ -4401,7 +4386,7 @@
           <p:cNvPr id="4" name="">
             <a:extLst xmlns:a="http://schemas.openxmlformats.org/drawingml/2006/main">
               <a:ext uri="{FF2B5EF4-FFF2-40B4-BE49-F238E27FC236}">
-                <a16:creationId xmlns:a16="http://schemas.microsoft.com/office/drawing/2014/main" id="{93BC8BE2-36D2-40BF-9692-95AAD819ACEE}"/>
+                <a16:creationId xmlns:a16="http://schemas.microsoft.com/office/drawing/2014/main" id="{421365D2-18E8-454A-9B73-77B815726B27}"/>
               </a:ext>
             </a:extLst>
           </p:cNvPr>
@@ -4452,7 +4437,7 @@
           <p:cNvPr id="5" name="">
             <a:extLst xmlns:a="http://schemas.openxmlformats.org/drawingml/2006/main">
               <a:ext uri="{FF2B5EF4-FFF2-40B4-BE49-F238E27FC236}">
-                <a16:creationId xmlns:a16="http://schemas.microsoft.com/office/drawing/2014/main" id="{70BDCD12-F2A0-4F73-95E0-4C9DCBEF1561}"/>
+                <a16:creationId xmlns:a16="http://schemas.microsoft.com/office/drawing/2014/main" id="{4BA91E26-1522-49EB-B8EF-61A01A9EA06B}"/>
               </a:ext>
             </a:extLst>
           </p:cNvPr>
@@ -4487,7 +4472,7 @@
           <p:cNvPr id="6" name="">
             <a:extLst xmlns:a="http://schemas.openxmlformats.org/drawingml/2006/main">
               <a:ext uri="{FF2B5EF4-FFF2-40B4-BE49-F238E27FC236}">
-                <a16:creationId xmlns:a16="http://schemas.microsoft.com/office/drawing/2014/main" id="{FAF2AEE4-B9A7-4A02-A119-4DC8EB33B026}"/>
+                <a16:creationId xmlns:a16="http://schemas.microsoft.com/office/drawing/2014/main" id="{8BDFAD0D-15EC-4340-8840-5D7D93409C73}"/>
               </a:ext>
             </a:extLst>
           </p:cNvPr>
@@ -4522,7 +4507,7 @@
           <p:cNvPr id="7" name="">
             <a:extLst xmlns:a="http://schemas.openxmlformats.org/drawingml/2006/main">
               <a:ext uri="{FF2B5EF4-FFF2-40B4-BE49-F238E27FC236}">
-                <a16:creationId xmlns:a16="http://schemas.microsoft.com/office/drawing/2014/main" id="{DF5D00F9-2098-4911-A564-BBFBBFE47FCB}"/>
+                <a16:creationId xmlns:a16="http://schemas.microsoft.com/office/drawing/2014/main" id="{890B38E9-30A4-4BC2-BF5A-E3D32B73E328}"/>
               </a:ext>
             </a:extLst>
           </p:cNvPr>
@@ -4573,7 +4558,7 @@
           <p:cNvPr id="8" name="">
             <a:extLst xmlns:a="http://schemas.openxmlformats.org/drawingml/2006/main">
               <a:ext uri="{FF2B5EF4-FFF2-40B4-BE49-F238E27FC236}">
-                <a16:creationId xmlns:a16="http://schemas.microsoft.com/office/drawing/2014/main" id="{E17FCBDF-4AFD-4125-9B60-574046EC1A57}"/>
+                <a16:creationId xmlns:a16="http://schemas.microsoft.com/office/drawing/2014/main" id="{84CC872F-E6EE-4F1A-A3CE-A8AB6F834490}"/>
               </a:ext>
             </a:extLst>
           </p:cNvPr>
@@ -4629,7 +4614,7 @@
                   <a:srgbClr val="334155"/>
                 </a:solidFill>
               </a:rPr>
-              <a:t>2. The board will care most about whether enterprise pipeline supports the Q3 revenue target.</a:t>
+              <a:t>2. The board narrative should show that Directing Business Consulting Advisory is becoming a repeatable boutique AI advisory business, not a collection of one-off projects.</a:t>
             </a:r>
           </a:p>
           <a:p xmlns:a="http://schemas.openxmlformats.org/drawingml/2006/main">
@@ -4644,7 +4629,7 @@
                   <a:srgbClr val="334155"/>
                 </a:solidFill>
               </a:rPr>
-              <a:t>3. Keep net burn under $230k while continuing to invest in product reliability.</a:t>
+              <a:t>3. Emphasize conversion from founder-led consulting into packaged offerings: chief-of-staff systems, GTM operating cadence, and AI-enabled advisory retainers.</a:t>
             </a:r>
           </a:p>
         </p:txBody>
@@ -4654,7 +4639,7 @@
           <p:cNvPr id="9" name="">
             <a:extLst xmlns:a="http://schemas.openxmlformats.org/drawingml/2006/main">
               <a:ext uri="{FF2B5EF4-FFF2-40B4-BE49-F238E27FC236}">
-                <a16:creationId xmlns:a16="http://schemas.microsoft.com/office/drawing/2014/main" id="{5E83D1BC-80D6-4D2D-9266-1CF0C3EEA984}"/>
+                <a16:creationId xmlns:a16="http://schemas.microsoft.com/office/drawing/2014/main" id="{847A7836-6778-43AA-84FF-3382B033E13E}"/>
               </a:ext>
             </a:extLst>
           </p:cNvPr>
@@ -4689,7 +4674,7 @@
           <p:cNvPr id="10" name="">
             <a:extLst xmlns:a="http://schemas.openxmlformats.org/drawingml/2006/main">
               <a:ext uri="{FF2B5EF4-FFF2-40B4-BE49-F238E27FC236}">
-                <a16:creationId xmlns:a16="http://schemas.microsoft.com/office/drawing/2014/main" id="{C959F9E9-2B9A-4D04-A837-AAFD1D8C5156}"/>
+                <a16:creationId xmlns:a16="http://schemas.microsoft.com/office/drawing/2014/main" id="{27094BC1-1366-4AD7-AECB-9A9AB5E8D7C1}"/>
               </a:ext>
             </a:extLst>
           </p:cNvPr>
@@ -4724,7 +4709,7 @@
           <p:cNvPr id="11" name="">
             <a:extLst xmlns:a="http://schemas.openxmlformats.org/drawingml/2006/main">
               <a:ext uri="{FF2B5EF4-FFF2-40B4-BE49-F238E27FC236}">
-                <a16:creationId xmlns:a16="http://schemas.microsoft.com/office/drawing/2014/main" id="{E92D4DA4-F3F6-4EC2-A223-3EAF479F3275}"/>
+                <a16:creationId xmlns:a16="http://schemas.microsoft.com/office/drawing/2014/main" id="{B65CA1F8-8D83-4AC5-8192-3088810F1139}"/>
               </a:ext>
             </a:extLst>
           </p:cNvPr>
@@ -4775,7 +4760,7 @@
           <p:cNvPr id="12" name="">
             <a:extLst xmlns:a="http://schemas.openxmlformats.org/drawingml/2006/main">
               <a:ext uri="{FF2B5EF4-FFF2-40B4-BE49-F238E27FC236}">
-                <a16:creationId xmlns:a16="http://schemas.microsoft.com/office/drawing/2014/main" id="{66E97AA9-1956-4194-9E5A-7DFF89CCD685}"/>
+                <a16:creationId xmlns:a16="http://schemas.microsoft.com/office/drawing/2014/main" id="{EE250E57-1E46-4F88-87CA-411668B635CB}"/>
               </a:ext>
             </a:extLst>
           </p:cNvPr>
@@ -4854,7 +4839,7 @@
     </p:spTree>
     <p:extLst>
       <p:ext uri="{BB962C8B-B14F-4D97-AF65-F5344CB8AC3E}">
-        <p14:creationId xmlns:p14="http://schemas.microsoft.com/office/powerpoint/2010/main" val="512652787"/>
+        <p14:creationId xmlns:p14="http://schemas.microsoft.com/office/powerpoint/2010/main" val="1542074149"/>
       </p:ext>
     </p:extLst>
   </p:cSld>

</xml_diff>